<commit_message>
Add ATR percent state-band price view
</commit_message>
<xml_diff>
--- a/operator_hypothesis_lab/presentations/tsla_descriptive_microscope_evidence.pptx
+++ b/operator_hypothesis_lab/presentations/tsla_descriptive_microscope_evidence.pptx
@@ -2,42 +2,43 @@
 <file path=ppt/presentation.xml><?xml version="1.0" encoding="utf-8"?>
 <p:presentation xmlns:p="http://schemas.openxmlformats.org/presentationml/2006/main">
   <p:sldMasterIdLst>
-    <p:sldMasterId xmlns:r="http://schemas.openxmlformats.org/officeDocument/2006/relationships" id="2147483648" r:id="Reb843da5173647aa"/>
+    <p:sldMasterId xmlns:r="http://schemas.openxmlformats.org/officeDocument/2006/relationships" id="2147483648" r:id="R8784b9d88eb04a77"/>
   </p:sldMasterIdLst>
   <p:notesMasterIdLst>
-    <p:notesMasterId xmlns:r="http://schemas.openxmlformats.org/officeDocument/2006/relationships" r:id="Rd8fc8777ce8b4b36"/>
+    <p:notesMasterId xmlns:r="http://schemas.openxmlformats.org/officeDocument/2006/relationships" r:id="Rd4a0359dc2924145"/>
   </p:notesMasterIdLst>
   <p:sldIdLst>
-    <p:sldId xmlns:r="http://schemas.openxmlformats.org/officeDocument/2006/relationships" id="256" r:id="R63902cd3df904b09"/>
-    <p:sldId xmlns:r="http://schemas.openxmlformats.org/officeDocument/2006/relationships" id="257" r:id="Rc3b1b92a27454849"/>
-    <p:sldId xmlns:r="http://schemas.openxmlformats.org/officeDocument/2006/relationships" id="258" r:id="R8215d72e601042f7"/>
-    <p:sldId xmlns:r="http://schemas.openxmlformats.org/officeDocument/2006/relationships" id="259" r:id="R6c5a6d101c9a4f28"/>
-    <p:sldId xmlns:r="http://schemas.openxmlformats.org/officeDocument/2006/relationships" id="260" r:id="Rc362f307e3924d5a"/>
-    <p:sldId xmlns:r="http://schemas.openxmlformats.org/officeDocument/2006/relationships" id="261" r:id="R3c1e37d2ca2c4e82"/>
-    <p:sldId xmlns:r="http://schemas.openxmlformats.org/officeDocument/2006/relationships" id="262" r:id="R048a3f4a33b74b91"/>
-    <p:sldId xmlns:r="http://schemas.openxmlformats.org/officeDocument/2006/relationships" id="263" r:id="Red344faaa8ba49d8"/>
-    <p:sldId xmlns:r="http://schemas.openxmlformats.org/officeDocument/2006/relationships" id="264" r:id="Rd08eefb8905741af"/>
-    <p:sldId xmlns:r="http://schemas.openxmlformats.org/officeDocument/2006/relationships" id="265" r:id="R9f7dafc8f9bb431b"/>
-    <p:sldId xmlns:r="http://schemas.openxmlformats.org/officeDocument/2006/relationships" id="266" r:id="R81e4ce78c2b64caf"/>
-    <p:sldId xmlns:r="http://schemas.openxmlformats.org/officeDocument/2006/relationships" id="267" r:id="Ra53fe406658e42c5"/>
-    <p:sldId xmlns:r="http://schemas.openxmlformats.org/officeDocument/2006/relationships" id="268" r:id="Rbe0235201b9f43cc"/>
-    <p:sldId xmlns:r="http://schemas.openxmlformats.org/officeDocument/2006/relationships" id="269" r:id="R9d9fe8cecb614130"/>
-    <p:sldId xmlns:r="http://schemas.openxmlformats.org/officeDocument/2006/relationships" id="270" r:id="R3755445df2314ad5"/>
-    <p:sldId xmlns:r="http://schemas.openxmlformats.org/officeDocument/2006/relationships" id="271" r:id="R376f8aae59e14dfb"/>
-    <p:sldId xmlns:r="http://schemas.openxmlformats.org/officeDocument/2006/relationships" id="272" r:id="Rce11102322054118"/>
-    <p:sldId xmlns:r="http://schemas.openxmlformats.org/officeDocument/2006/relationships" id="273" r:id="Rdf0b1a57102c496e"/>
-    <p:sldId xmlns:r="http://schemas.openxmlformats.org/officeDocument/2006/relationships" id="274" r:id="R5c397b28c5254ce9"/>
-    <p:sldId xmlns:r="http://schemas.openxmlformats.org/officeDocument/2006/relationships" id="275" r:id="Rad7276fc2ba14134"/>
-    <p:sldId xmlns:r="http://schemas.openxmlformats.org/officeDocument/2006/relationships" id="276" r:id="R17512c94dd114f05"/>
-    <p:sldId xmlns:r="http://schemas.openxmlformats.org/officeDocument/2006/relationships" id="277" r:id="Ra712361768c247ac"/>
-    <p:sldId xmlns:r="http://schemas.openxmlformats.org/officeDocument/2006/relationships" id="278" r:id="Rf00890273f9342cd"/>
-    <p:sldId xmlns:r="http://schemas.openxmlformats.org/officeDocument/2006/relationships" id="279" r:id="R8bafadd3c9c14419"/>
-    <p:sldId xmlns:r="http://schemas.openxmlformats.org/officeDocument/2006/relationships" id="280" r:id="Rdffbb9be272f4b7c"/>
-    <p:sldId xmlns:r="http://schemas.openxmlformats.org/officeDocument/2006/relationships" id="281" r:id="Ra9cb828de4b643a3"/>
-    <p:sldId xmlns:r="http://schemas.openxmlformats.org/officeDocument/2006/relationships" id="282" r:id="Raacf707921284382"/>
-    <p:sldId xmlns:r="http://schemas.openxmlformats.org/officeDocument/2006/relationships" id="283" r:id="Recebf945e77f4c21"/>
-    <p:sldId xmlns:r="http://schemas.openxmlformats.org/officeDocument/2006/relationships" id="284" r:id="Rc08eb660b1b74482"/>
-    <p:sldId xmlns:r="http://schemas.openxmlformats.org/officeDocument/2006/relationships" id="285" r:id="Rf197cce8d6574203"/>
+    <p:sldId xmlns:r="http://schemas.openxmlformats.org/officeDocument/2006/relationships" id="256" r:id="Ra856ea82b1f24691"/>
+    <p:sldId xmlns:r="http://schemas.openxmlformats.org/officeDocument/2006/relationships" id="257" r:id="R738ada6bc0a642e9"/>
+    <p:sldId xmlns:r="http://schemas.openxmlformats.org/officeDocument/2006/relationships" id="258" r:id="Rb64df74bfd4f4ea1"/>
+    <p:sldId xmlns:r="http://schemas.openxmlformats.org/officeDocument/2006/relationships" id="259" r:id="R769ae138f9504f10"/>
+    <p:sldId xmlns:r="http://schemas.openxmlformats.org/officeDocument/2006/relationships" id="260" r:id="R9e8a54764f9f4237"/>
+    <p:sldId xmlns:r="http://schemas.openxmlformats.org/officeDocument/2006/relationships" id="261" r:id="R3289a9d1be36412b"/>
+    <p:sldId xmlns:r="http://schemas.openxmlformats.org/officeDocument/2006/relationships" id="262" r:id="R7226d268e68c4588"/>
+    <p:sldId xmlns:r="http://schemas.openxmlformats.org/officeDocument/2006/relationships" id="263" r:id="R89e884d3145340ed"/>
+    <p:sldId xmlns:r="http://schemas.openxmlformats.org/officeDocument/2006/relationships" id="264" r:id="Re09e93c3c0fa455c"/>
+    <p:sldId xmlns:r="http://schemas.openxmlformats.org/officeDocument/2006/relationships" id="265" r:id="R67f0fd8180f24c98"/>
+    <p:sldId xmlns:r="http://schemas.openxmlformats.org/officeDocument/2006/relationships" id="266" r:id="Rb9137075e1664967"/>
+    <p:sldId xmlns:r="http://schemas.openxmlformats.org/officeDocument/2006/relationships" id="267" r:id="Rb87db3e7d5ba4a3a"/>
+    <p:sldId xmlns:r="http://schemas.openxmlformats.org/officeDocument/2006/relationships" id="268" r:id="Rb164100bbee94752"/>
+    <p:sldId xmlns:r="http://schemas.openxmlformats.org/officeDocument/2006/relationships" id="269" r:id="Rf41834c2c2554a2d"/>
+    <p:sldId xmlns:r="http://schemas.openxmlformats.org/officeDocument/2006/relationships" id="270" r:id="Rd115eed1654a4d45"/>
+    <p:sldId xmlns:r="http://schemas.openxmlformats.org/officeDocument/2006/relationships" id="271" r:id="R1915b87901aa4ae8"/>
+    <p:sldId xmlns:r="http://schemas.openxmlformats.org/officeDocument/2006/relationships" id="272" r:id="Rab08085a89ec4be0"/>
+    <p:sldId xmlns:r="http://schemas.openxmlformats.org/officeDocument/2006/relationships" id="273" r:id="R6a0cead665214d25"/>
+    <p:sldId xmlns:r="http://schemas.openxmlformats.org/officeDocument/2006/relationships" id="274" r:id="R4c2780eeef9041dd"/>
+    <p:sldId xmlns:r="http://schemas.openxmlformats.org/officeDocument/2006/relationships" id="275" r:id="R33f5770978b743f9"/>
+    <p:sldId xmlns:r="http://schemas.openxmlformats.org/officeDocument/2006/relationships" id="276" r:id="R698610770dc74bb5"/>
+    <p:sldId xmlns:r="http://schemas.openxmlformats.org/officeDocument/2006/relationships" id="277" r:id="R25a1037079ba4109"/>
+    <p:sldId xmlns:r="http://schemas.openxmlformats.org/officeDocument/2006/relationships" id="278" r:id="Rf2d3fd44323e486b"/>
+    <p:sldId xmlns:r="http://schemas.openxmlformats.org/officeDocument/2006/relationships" id="279" r:id="Rf5336442302b42ac"/>
+    <p:sldId xmlns:r="http://schemas.openxmlformats.org/officeDocument/2006/relationships" id="280" r:id="R71b81cb4596f46d6"/>
+    <p:sldId xmlns:r="http://schemas.openxmlformats.org/officeDocument/2006/relationships" id="281" r:id="R34c4264d362646f4"/>
+    <p:sldId xmlns:r="http://schemas.openxmlformats.org/officeDocument/2006/relationships" id="282" r:id="R77d11d352233451f"/>
+    <p:sldId xmlns:r="http://schemas.openxmlformats.org/officeDocument/2006/relationships" id="283" r:id="Rdc885d4a6f3749b4"/>
+    <p:sldId xmlns:r="http://schemas.openxmlformats.org/officeDocument/2006/relationships" id="284" r:id="R7ecbec7979cd4a4d"/>
+    <p:sldId xmlns:r="http://schemas.openxmlformats.org/officeDocument/2006/relationships" id="285" r:id="Re52bc379730e41a5"/>
+    <p:sldId xmlns:r="http://schemas.openxmlformats.org/officeDocument/2006/relationships" id="286" r:id="Rba546ac1250d4b29"/>
   </p:sldIdLst>
   <p:sldSz cx="12192000" cy="6858000"/>
   <p:notesSz cx="6858000" cy="9144000"/>
@@ -2241,7 +2242,7 @@
           <a:lstStyle xmlns:a="http://schemas.openxmlformats.org/drawingml/2006/main"/>
           <a:p xmlns:a="http://schemas.openxmlformats.org/drawingml/2006/main">
             <a:r>
-              <a:t>LOW ATR-percent anchors produce positive point estimates throughout the grid, but the strongest cell's interval crosses zero and no LOW cell survives the within-state scan.</a:t>
+              <a:t>This companion view makes the accepted volatility classifier visible in price time. Blue, gold, and red mean LOW, MEDIUM, and HIGH movement capacity; they do not mean bearish, neutral, and bullish. The lower panel shows the causal trailing ATR-percent rank and accepted hysteretic state at each close.</a:t>
             </a:r>
           </a:p>
           <a:p xmlns:a="http://schemas.openxmlformats.org/drawingml/2006/main">
@@ -2256,17 +2257,22 @@
           </a:p>
           <a:p xmlns:a="http://schemas.openxmlformats.org/drawingml/2006/main">
             <a:r>
-              <a:t>- runs/research_workbench/operator_hypothesis_lab/tsla_atrp_conditioned_return_horizon_grid_20260825/low_pearson_matrix.csv</a:t>
-            </a:r>
-          </a:p>
-          <a:p xmlns:a="http://schemas.openxmlformats.org/drawingml/2006/main">
-            <a:r>
-              <a:t>- runs/research_workbench/operator_hypothesis_lab/tsla_atrp_conditioned_return_horizon_grid_20260825/conditioned_horizon_grid_statistics.csv</a:t>
-            </a:r>
-          </a:p>
-          <a:p xmlns:a="http://schemas.openxmlformats.org/drawingml/2006/main">
-            <a:r>
-              <a:t>- runs/research_workbench/operator_hypothesis_lab/tsla_atrp_conditioned_return_horizon_grid_20260825/visuals/tsla_atrp_low_pearson_heatmap.png</a:t>
+              <a:t>- runs/research_workbench/operator_hypothesis_lab/tsla_atrp_conditioned_return_horizon_grid_20260825/visuals/tsla_atrp_state_price_bands.png</a:t>
+            </a:r>
+          </a:p>
+          <a:p xmlns:a="http://schemas.openxmlformats.org/drawingml/2006/main">
+            <a:r>
+              <a:t>- runs/research_workbench/operator_hypothesis_lab/tsla_atrp_conditioned_return_horizon_grid_20260825/tsla_atrp_state_chart_ledger.csv</a:t>
+            </a:r>
+          </a:p>
+          <a:p xmlns:a="http://schemas.openxmlformats.org/drawingml/2006/main">
+            <a:r>
+              <a:t>- runs/research_workbench/operator_hypothesis_lab/tsla_atrp_conditioned_return_horizon_grid_20260825/tsla_atrp_state_spans.csv</a:t>
+            </a:r>
+          </a:p>
+          <a:p xmlns:a="http://schemas.openxmlformats.org/drawingml/2006/main">
+            <a:r>
+              <a:t>- runs/research_workbench/operator_hypothesis_lab/hyp_reg_01_1_atr_percent_20260814/hyp_reg_01_1_daily_state_ledger.csv</a:t>
             </a:r>
           </a:p>
           <a:p xmlns:a="http://schemas.openxmlformats.org/drawingml/2006/main">
@@ -2341,7 +2347,7 @@
           <a:lstStyle xmlns:a="http://schemas.openxmlformats.org/drawingml/2006/main"/>
           <a:p xmlns:a="http://schemas.openxmlformats.org/drawingml/2006/main">
             <a:r>
-              <a:t>MEDIUM ATR-percent anchors show the most statistically stable continuation pattern. Under the strict correction across all 486 tests, the 5/3, 10/2, and 10/3 cells remain.</a:t>
+              <a:t>LOW ATR-percent anchors produce positive point estimates throughout the grid, but the strongest cell's interval crosses zero and no LOW cell survives the within-state scan.</a:t>
             </a:r>
           </a:p>
           <a:p xmlns:a="http://schemas.openxmlformats.org/drawingml/2006/main">
@@ -2356,7 +2362,7 @@
           </a:p>
           <a:p xmlns:a="http://schemas.openxmlformats.org/drawingml/2006/main">
             <a:r>
-              <a:t>- runs/research_workbench/operator_hypothesis_lab/tsla_atrp_conditioned_return_horizon_grid_20260825/medium_pearson_matrix.csv</a:t>
+              <a:t>- runs/research_workbench/operator_hypothesis_lab/tsla_atrp_conditioned_return_horizon_grid_20260825/low_pearson_matrix.csv</a:t>
             </a:r>
           </a:p>
           <a:p xmlns:a="http://schemas.openxmlformats.org/drawingml/2006/main">
@@ -2366,7 +2372,7 @@
           </a:p>
           <a:p xmlns:a="http://schemas.openxmlformats.org/drawingml/2006/main">
             <a:r>
-              <a:t>- runs/research_workbench/operator_hypothesis_lab/tsla_atrp_conditioned_return_horizon_grid_20260825/visuals/tsla_atrp_medium_pearson_heatmap.png</a:t>
+              <a:t>- runs/research_workbench/operator_hypothesis_lab/tsla_atrp_conditioned_return_horizon_grid_20260825/visuals/tsla_atrp_low_pearson_heatmap.png</a:t>
             </a:r>
           </a:p>
           <a:p xmlns:a="http://schemas.openxmlformats.org/drawingml/2006/main">
@@ -2441,7 +2447,7 @@
           <a:lstStyle xmlns:a="http://schemas.openxmlformats.org/drawingml/2006/main"/>
           <a:p xmlns:a="http://schemas.openxmlformats.org/drawingml/2006/main">
             <a:r>
-              <a:t>HIGH ATR-percent anchors reverse the sign of the broad surface, especially at longer horizons. The most extreme cell is visually strong but its dependence-robust interval still crosses zero.</a:t>
+              <a:t>MEDIUM ATR-percent anchors show the most statistically stable continuation pattern. Under the strict correction across all 486 tests, the 5/3, 10/2, and 10/3 cells remain.</a:t>
             </a:r>
           </a:p>
           <a:p xmlns:a="http://schemas.openxmlformats.org/drawingml/2006/main">
@@ -2456,7 +2462,7 @@
           </a:p>
           <a:p xmlns:a="http://schemas.openxmlformats.org/drawingml/2006/main">
             <a:r>
-              <a:t>- runs/research_workbench/operator_hypothesis_lab/tsla_atrp_conditioned_return_horizon_grid_20260825/high_pearson_matrix.csv</a:t>
+              <a:t>- runs/research_workbench/operator_hypothesis_lab/tsla_atrp_conditioned_return_horizon_grid_20260825/medium_pearson_matrix.csv</a:t>
             </a:r>
           </a:p>
           <a:p xmlns:a="http://schemas.openxmlformats.org/drawingml/2006/main">
@@ -2466,7 +2472,7 @@
           </a:p>
           <a:p xmlns:a="http://schemas.openxmlformats.org/drawingml/2006/main">
             <a:r>
-              <a:t>- runs/research_workbench/operator_hypothesis_lab/tsla_atrp_conditioned_return_horizon_grid_20260825/visuals/tsla_atrp_high_pearson_heatmap.png</a:t>
+              <a:t>- runs/research_workbench/operator_hypothesis_lab/tsla_atrp_conditioned_return_horizon_grid_20260825/visuals/tsla_atrp_medium_pearson_heatmap.png</a:t>
             </a:r>
           </a:p>
           <a:p xmlns:a="http://schemas.openxmlformats.org/drawingml/2006/main">
@@ -2541,7 +2547,7 @@
           <a:lstStyle xmlns:a="http://schemas.openxmlformats.org/drawingml/2006/main"/>
           <a:p xmlns:a="http://schemas.openxmlformats.org/drawingml/2006/main">
             <a:r>
-              <a:t>The largest correlation contrast is -0.548 at 25 prior and 15 forward; its within-family interaction q is 0.038 but strict omnibus q is 0.081. Three smaller HIGH-minus-MEDIUM interactions survive the omnibus correction.</a:t>
+              <a:t>HIGH ATR-percent anchors reverse the sign of the broad surface, especially at longer horizons. The most extreme cell is visually strong but its dependence-robust interval still crosses zero.</a:t>
             </a:r>
           </a:p>
           <a:p xmlns:a="http://schemas.openxmlformats.org/drawingml/2006/main">
@@ -2556,22 +2562,17 @@
           </a:p>
           <a:p xmlns:a="http://schemas.openxmlformats.org/drawingml/2006/main">
             <a:r>
-              <a:t>- runs/research_workbench/operator_hypothesis_lab/tsla_atrp_conditioned_return_horizon_grid_20260825/high_minus_medium_pearson_difference_matrix.csv</a:t>
-            </a:r>
-          </a:p>
-          <a:p xmlns:a="http://schemas.openxmlformats.org/drawingml/2006/main">
-            <a:r>
-              <a:t>- runs/research_workbench/operator_hypothesis_lab/tsla_atrp_conditioned_return_horizon_grid_20260825/pairwise_state_comparison_statistics.csv</a:t>
-            </a:r>
-          </a:p>
-          <a:p xmlns:a="http://schemas.openxmlformats.org/drawingml/2006/main">
-            <a:r>
-              <a:t>- runs/research_workbench/operator_hypothesis_lab/tsla_atrp_conditioned_return_horizon_grid_20260825/high_minus_medium_interaction_bh_q_matrix.csv</a:t>
-            </a:r>
-          </a:p>
-          <a:p xmlns:a="http://schemas.openxmlformats.org/drawingml/2006/main">
-            <a:r>
-              <a:t>- runs/research_workbench/operator_hypothesis_lab/tsla_atrp_conditioned_return_horizon_grid_20260825/visuals/tsla_atrp_high_minus_medium_pearson_heatmap.png</a:t>
+              <a:t>- runs/research_workbench/operator_hypothesis_lab/tsla_atrp_conditioned_return_horizon_grid_20260825/high_pearson_matrix.csv</a:t>
+            </a:r>
+          </a:p>
+          <a:p xmlns:a="http://schemas.openxmlformats.org/drawingml/2006/main">
+            <a:r>
+              <a:t>- runs/research_workbench/operator_hypothesis_lab/tsla_atrp_conditioned_return_horizon_grid_20260825/conditioned_horizon_grid_statistics.csv</a:t>
+            </a:r>
+          </a:p>
+          <a:p xmlns:a="http://schemas.openxmlformats.org/drawingml/2006/main">
+            <a:r>
+              <a:t>- runs/research_workbench/operator_hypothesis_lab/tsla_atrp_conditioned_return_horizon_grid_20260825/visuals/tsla_atrp_high_pearson_heatmap.png</a:t>
             </a:r>
           </a:p>
           <a:p xmlns:a="http://schemas.openxmlformats.org/drawingml/2006/main">
@@ -2702,6 +2703,111 @@
 </file>
 
 <file path=ppt/notesSlides/notesSlide30.xml><?xml version="1.0" encoding="utf-8"?>
+<p:notes xmlns:p="http://schemas.openxmlformats.org/presentationml/2006/main">
+  <p:cSld>
+    <p:spTree>
+      <p:nvGrpSpPr>
+        <p:cNvPr id="1" name=""/>
+        <p:cNvGrpSpPr/>
+        <p:nvPr/>
+      </p:nvGrpSpPr>
+      <p:grpSpPr>
+        <a:xfrm xmlns:a="http://schemas.openxmlformats.org/drawingml/2006/main"/>
+      </p:grpSpPr>
+      <p:sp>
+        <p:nvSpPr>
+          <p:cNvPr id="2" name="Slide Image Placeholder 1"/>
+          <p:cNvSpPr>
+            <a:spLocks xmlns:a="http://schemas.openxmlformats.org/drawingml/2006/main" noGrp="1"/>
+          </p:cNvSpPr>
+          <p:nvPr>
+            <p:ph type="sldImg" idx="0"/>
+          </p:nvPr>
+        </p:nvSpPr>
+        <p:spPr/>
+      </p:sp>
+      <p:sp>
+        <p:nvSpPr>
+          <p:cNvPr id="3" name="Notes Placeholder 2"/>
+          <p:cNvSpPr>
+            <a:spLocks xmlns:a="http://schemas.openxmlformats.org/drawingml/2006/main" noGrp="1"/>
+          </p:cNvSpPr>
+          <p:nvPr>
+            <p:ph type="body" idx="1"/>
+          </p:nvPr>
+        </p:nvSpPr>
+        <p:spPr/>
+        <p:txBody>
+          <a:bodyPr xmlns:a="http://schemas.openxmlformats.org/drawingml/2006/main"/>
+          <a:lstStyle xmlns:a="http://schemas.openxmlformats.org/drawingml/2006/main"/>
+          <a:p xmlns:a="http://schemas.openxmlformats.org/drawingml/2006/main">
+            <a:r>
+              <a:t>The largest correlation contrast is -0.548 at 25 prior and 15 forward; its within-family interaction q is 0.038 but strict omnibus q is 0.081. Three smaller HIGH-minus-MEDIUM interactions survive the omnibus correction.</a:t>
+            </a:r>
+          </a:p>
+          <a:p xmlns:a="http://schemas.openxmlformats.org/drawingml/2006/main">
+            <a:r>
+              <a:t/>
+            </a:r>
+          </a:p>
+          <a:p xmlns:a="http://schemas.openxmlformats.org/drawingml/2006/main">
+            <a:r>
+              <a:t>[Sources]</a:t>
+            </a:r>
+          </a:p>
+          <a:p xmlns:a="http://schemas.openxmlformats.org/drawingml/2006/main">
+            <a:r>
+              <a:t>- runs/research_workbench/operator_hypothesis_lab/tsla_atrp_conditioned_return_horizon_grid_20260825/high_minus_medium_pearson_difference_matrix.csv</a:t>
+            </a:r>
+          </a:p>
+          <a:p xmlns:a="http://schemas.openxmlformats.org/drawingml/2006/main">
+            <a:r>
+              <a:t>- runs/research_workbench/operator_hypothesis_lab/tsla_atrp_conditioned_return_horizon_grid_20260825/pairwise_state_comparison_statistics.csv</a:t>
+            </a:r>
+          </a:p>
+          <a:p xmlns:a="http://schemas.openxmlformats.org/drawingml/2006/main">
+            <a:r>
+              <a:t>- runs/research_workbench/operator_hypothesis_lab/tsla_atrp_conditioned_return_horizon_grid_20260825/high_minus_medium_interaction_bh_q_matrix.csv</a:t>
+            </a:r>
+          </a:p>
+          <a:p xmlns:a="http://schemas.openxmlformats.org/drawingml/2006/main">
+            <a:r>
+              <a:t>- runs/research_workbench/operator_hypothesis_lab/tsla_atrp_conditioned_return_horizon_grid_20260825/visuals/tsla_atrp_high_minus_medium_pearson_heatmap.png</a:t>
+            </a:r>
+          </a:p>
+          <a:p xmlns:a="http://schemas.openxmlformats.org/drawingml/2006/main">
+            <a:r>
+              <a:t>[/Sources]</a:t>
+            </a:r>
+          </a:p>
+        </p:txBody>
+      </p:sp>
+      <p:sp>
+        <p:nvSpPr>
+          <p:cNvPr id="4" name="Slide Number Placeholder 3"/>
+          <p:cNvSpPr>
+            <a:spLocks xmlns:a="http://schemas.openxmlformats.org/drawingml/2006/main" noGrp="1"/>
+          </p:cNvSpPr>
+          <p:nvPr>
+            <p:ph type="sldNum" idx="5"/>
+          </p:nvPr>
+        </p:nvSpPr>
+        <p:spPr/>
+        <p:txBody>
+          <a:bodyPr xmlns:a="http://schemas.openxmlformats.org/drawingml/2006/main"/>
+          <a:lstStyle xmlns:a="http://schemas.openxmlformats.org/drawingml/2006/main"/>
+          <a:p xmlns:a="http://schemas.openxmlformats.org/drawingml/2006/main"/>
+        </p:txBody>
+      </p:sp>
+    </p:spTree>
+  </p:cSld>
+  <p:clrMapOvr>
+    <a:masterClrMapping xmlns:a="http://schemas.openxmlformats.org/drawingml/2006/main"/>
+  </p:clrMapOvr>
+</p:notes>
+</file>
+
+<file path=ppt/notesSlides/notesSlide31.xml><?xml version="1.0" encoding="utf-8"?>
 <p:notes xmlns:p="http://schemas.openxmlformats.org/presentationml/2006/main">
   <p:cSld>
     <p:spTree>
@@ -3424,7 +3530,7 @@
   </p:cSld>
   <p:clrMap bg1="lt1" tx1="dk1" bg2="lt2" tx2="dk2" accent1="accent1" accent2="accent2" accent3="accent3" accent4="accent4" accent5="accent5" accent6="accent6" hlink="hlink" folHlink="folHlink"/>
   <p:sldLayoutIdLst>
-    <p:sldLayoutId xmlns:r="http://schemas.openxmlformats.org/officeDocument/2006/relationships" id="2147483649" r:id="R292de2d17219467d"/>
+    <p:sldLayoutId xmlns:r="http://schemas.openxmlformats.org/officeDocument/2006/relationships" id="2147483649" r:id="R92246c71310d46c6"/>
   </p:sldLayoutIdLst>
   <p:txStyles>
     <p:titleStyle>
@@ -4603,7 +4709,7 @@
           <p:nvPr/>
         </p:nvPicPr>
         <p:blipFill>
-          <a:blip xmlns:r="http://schemas.openxmlformats.org/officeDocument/2006/relationships" xmlns:a="http://schemas.openxmlformats.org/drawingml/2006/main" r:embed="R56bc2161bcbf44d9"/>
+          <a:blip xmlns:r="http://schemas.openxmlformats.org/officeDocument/2006/relationships" xmlns:a="http://schemas.openxmlformats.org/drawingml/2006/main" r:embed="R09a06b7a1b4448ba"/>
           <a:stretch xmlns:a="http://schemas.openxmlformats.org/drawingml/2006/main"/>
         </p:blipFill>
         <p:spPr>
@@ -8524,7 +8630,7 @@
           <p:nvPr/>
         </p:nvPicPr>
         <p:blipFill>
-          <a:blip xmlns:r="http://schemas.openxmlformats.org/officeDocument/2006/relationships" xmlns:a="http://schemas.openxmlformats.org/drawingml/2006/main" r:embed="R5ce294c17730419d"/>
+          <a:blip xmlns:r="http://schemas.openxmlformats.org/officeDocument/2006/relationships" xmlns:a="http://schemas.openxmlformats.org/drawingml/2006/main" r:embed="Rbfa95d3868d0430e"/>
           <a:stretch xmlns:a="http://schemas.openxmlformats.org/drawingml/2006/main"/>
         </p:blipFill>
         <p:spPr>
@@ -9429,7 +9535,7 @@
           <p:nvPr/>
         </p:nvPicPr>
         <p:blipFill>
-          <a:blip xmlns:r="http://schemas.openxmlformats.org/officeDocument/2006/relationships" xmlns:a="http://schemas.openxmlformats.org/drawingml/2006/main" r:embed="R289a279bf7814f58"/>
+          <a:blip xmlns:r="http://schemas.openxmlformats.org/officeDocument/2006/relationships" xmlns:a="http://schemas.openxmlformats.org/drawingml/2006/main" r:embed="R79622c9646664e71"/>
           <a:stretch xmlns:a="http://schemas.openxmlformats.org/drawingml/2006/main"/>
         </p:blipFill>
         <p:spPr>
@@ -10233,7 +10339,7 @@
           <p:nvPr/>
         </p:nvPicPr>
         <p:blipFill>
-          <a:blip xmlns:r="http://schemas.openxmlformats.org/officeDocument/2006/relationships" xmlns:a="http://schemas.openxmlformats.org/drawingml/2006/main" r:embed="Rac4bc51d55e94bb3"/>
+          <a:blip xmlns:r="http://schemas.openxmlformats.org/officeDocument/2006/relationships" xmlns:a="http://schemas.openxmlformats.org/drawingml/2006/main" r:embed="R62069b35f6314be2"/>
           <a:stretch xmlns:a="http://schemas.openxmlformats.org/drawingml/2006/main"/>
         </p:blipFill>
         <p:spPr>
@@ -14586,7 +14692,7 @@
           <p:nvPr/>
         </p:nvPicPr>
         <p:blipFill>
-          <a:blip xmlns:r="http://schemas.openxmlformats.org/officeDocument/2006/relationships" xmlns:a="http://schemas.openxmlformats.org/drawingml/2006/main" r:embed="Rea91341bf18248b7"/>
+          <a:blip xmlns:r="http://schemas.openxmlformats.org/officeDocument/2006/relationships" xmlns:a="http://schemas.openxmlformats.org/drawingml/2006/main" r:embed="Rdfb41a89193e446f"/>
           <a:stretch xmlns:a="http://schemas.openxmlformats.org/drawingml/2006/main"/>
         </p:blipFill>
         <p:spPr>
@@ -14998,7 +15104,7 @@
           <p:nvPr/>
         </p:nvPicPr>
         <p:blipFill>
-          <a:blip xmlns:r="http://schemas.openxmlformats.org/officeDocument/2006/relationships" xmlns:a="http://schemas.openxmlformats.org/drawingml/2006/main" r:embed="Rf1cee17a749742af"/>
+          <a:blip xmlns:r="http://schemas.openxmlformats.org/officeDocument/2006/relationships" xmlns:a="http://schemas.openxmlformats.org/drawingml/2006/main" r:embed="R568f535318ed4a37"/>
           <a:stretch xmlns:a="http://schemas.openxmlformats.org/drawingml/2006/main"/>
         </p:blipFill>
         <p:spPr>
@@ -15903,7 +16009,7 @@
           <p:nvPr/>
         </p:nvPicPr>
         <p:blipFill>
-          <a:blip xmlns:r="http://schemas.openxmlformats.org/officeDocument/2006/relationships" xmlns:a="http://schemas.openxmlformats.org/drawingml/2006/main" r:embed="R1cdc019cc28c4648"/>
+          <a:blip xmlns:r="http://schemas.openxmlformats.org/officeDocument/2006/relationships" xmlns:a="http://schemas.openxmlformats.org/drawingml/2006/main" r:embed="R6d3711f7ae974143"/>
           <a:stretch xmlns:a="http://schemas.openxmlformats.org/drawingml/2006/main"/>
         </p:blipFill>
         <p:spPr>
@@ -19038,10 +19144,10 @@
       </p:grpSpPr>
       <p:sp>
         <p:nvSpPr>
-          <p:cNvPr id="9" name="section-4">
-            <a:extLst xmlns:a="http://schemas.openxmlformats.org/drawingml/2006/main">
-              <a:ext uri="{FF2B5EF4-FFF2-40B4-BE49-F238E27FC236}">
-                <a16:creationId xmlns:a16="http://schemas.microsoft.com/office/drawing/2014/main" id="{8AE0A271-669A-49F0-A82E-C4438BEE27D9}"/>
+          <p:cNvPr id="14" name="section-5">
+            <a:extLst xmlns:a="http://schemas.openxmlformats.org/drawingml/2006/main">
+              <a:ext uri="{FF2B5EF4-FFF2-40B4-BE49-F238E27FC236}">
+                <a16:creationId xmlns:a16="http://schemas.microsoft.com/office/drawing/2014/main" id="{7D217279-BBB9-4442-BD43-E35AFD380A36}"/>
               </a:ext>
             </a:extLst>
           </p:cNvPr>
@@ -19097,10 +19203,10 @@
       </p:sp>
       <p:sp>
         <p:nvSpPr>
-          <p:cNvPr id="2" name="title-4">
-            <a:extLst xmlns:a="http://schemas.openxmlformats.org/drawingml/2006/main">
-              <a:ext uri="{FF2B5EF4-FFF2-40B4-BE49-F238E27FC236}">
-                <a16:creationId xmlns:a16="http://schemas.microsoft.com/office/drawing/2014/main" id="{50C6F92F-721A-4252-9CF8-B5C9B01C7310}"/>
+          <p:cNvPr id="2" name="title-5">
+            <a:extLst xmlns:a="http://schemas.openxmlformats.org/drawingml/2006/main">
+              <a:ext uri="{FF2B5EF4-FFF2-40B4-BE49-F238E27FC236}">
+                <a16:creationId xmlns:a16="http://schemas.microsoft.com/office/drawing/2014/main" id="{ACF70291-6FC2-4F25-8EF7-C5343297C791}"/>
               </a:ext>
             </a:extLst>
           </p:cNvPr>
@@ -19149,7 +19255,7 @@
                 <a:ea typeface="Arial"/>
                 <a:cs typeface="Arial"/>
               </a:rPr>
-              <a:t>LOW ATR% is broadly positive, but no cell passes</a:t>
+              <a:t>ATR% shows movement capacity—not direction</a:t>
             </a:r>
           </a:p>
         </p:txBody>
@@ -19159,7 +19265,7 @@
           <p:cNvPr id="3" name="">
             <a:extLst xmlns:a="http://schemas.openxmlformats.org/drawingml/2006/main">
               <a:ext uri="{FF2B5EF4-FFF2-40B4-BE49-F238E27FC236}">
-                <a16:creationId xmlns:a16="http://schemas.microsoft.com/office/drawing/2014/main" id="{242399F2-4D0A-4337-B17E-DB3599DC380F}"/>
+                <a16:creationId xmlns:a16="http://schemas.microsoft.com/office/drawing/2014/main" id="{DC8E3755-2109-4A95-AAD7-09D4B54CD317}"/>
               </a:ext>
             </a:extLst>
           </p:cNvPr>
@@ -19189,10 +19295,10 @@
       </p:sp>
       <p:sp>
         <p:nvSpPr>
-          <p:cNvPr id="4" name="footer-left-4">
-            <a:extLst xmlns:a="http://schemas.openxmlformats.org/drawingml/2006/main">
-              <a:ext uri="{FF2B5EF4-FFF2-40B4-BE49-F238E27FC236}">
-                <a16:creationId xmlns:a16="http://schemas.microsoft.com/office/drawing/2014/main" id="{BF8B82CA-1E48-4669-BAD8-1FF8C09FCBFB}"/>
+          <p:cNvPr id="4" name="footer-left-5">
+            <a:extLst xmlns:a="http://schemas.openxmlformats.org/drawingml/2006/main">
+              <a:ext uri="{FF2B5EF4-FFF2-40B4-BE49-F238E27FC236}">
+                <a16:creationId xmlns:a16="http://schemas.microsoft.com/office/drawing/2014/main" id="{3D616FCB-FD1B-4926-8056-5988E7D3FD76}"/>
               </a:ext>
             </a:extLst>
           </p:cNvPr>
@@ -19248,10 +19354,10 @@
       </p:sp>
       <p:sp>
         <p:nvSpPr>
-          <p:cNvPr id="5" name="footer-number-4">
-            <a:extLst xmlns:a="http://schemas.openxmlformats.org/drawingml/2006/main">
-              <a:ext uri="{FF2B5EF4-FFF2-40B4-BE49-F238E27FC236}">
-                <a16:creationId xmlns:a16="http://schemas.microsoft.com/office/drawing/2014/main" id="{05959AEC-B0A5-45F0-A65B-C94C3E5A032F}"/>
+          <p:cNvPr id="5" name="footer-number-5">
+            <a:extLst xmlns:a="http://schemas.openxmlformats.org/drawingml/2006/main">
+              <a:ext uri="{FF2B5EF4-FFF2-40B4-BE49-F238E27FC236}">
+                <a16:creationId xmlns:a16="http://schemas.microsoft.com/office/drawing/2014/main" id="{7E3BECCF-F54F-4D27-BB58-7ED627475AF5}"/>
               </a:ext>
             </a:extLst>
           </p:cNvPr>
@@ -19310,19 +19416,19 @@
           <p:cNvPr id="6" name="">
             <a:extLst xmlns:a="http://schemas.openxmlformats.org/drawingml/2006/main">
               <a:ext uri="{FF2B5EF4-FFF2-40B4-BE49-F238E27FC236}">
-                <a16:creationId xmlns:a16="http://schemas.microsoft.com/office/drawing/2014/main" id="{9C8DEA29-E57D-4C8D-8538-2028FF89DA7C}"/>
-              </a:ext>
-            </a:extLst>
-          </p:cNvPr>
-          <p:cNvSpPr>
-            <a:spLocks xmlns:a="http://schemas.openxmlformats.org/drawingml/2006/main" noGrp="1"/>
-          </p:cNvSpPr>
-          <p:nvPr/>
-        </p:nvSpPr>
-        <p:spPr>
-          <a:xfrm xmlns:a="http://schemas.openxmlformats.org/drawingml/2006/main">
-            <a:off x="1000125" y="1352550"/>
-            <a:ext cx="10191750" cy="4905375"/>
+                <a16:creationId xmlns:a16="http://schemas.microsoft.com/office/drawing/2014/main" id="{C96C60D3-C5F7-4C39-991D-FB86EB75687F}"/>
+              </a:ext>
+            </a:extLst>
+          </p:cNvPr>
+          <p:cNvSpPr>
+            <a:spLocks xmlns:a="http://schemas.openxmlformats.org/drawingml/2006/main" noGrp="1"/>
+          </p:cNvSpPr>
+          <p:nvPr/>
+        </p:nvSpPr>
+        <p:spPr>
+          <a:xfrm xmlns:a="http://schemas.openxmlformats.org/drawingml/2006/main">
+            <a:off x="323850" y="1381125"/>
+            <a:ext cx="8572500" cy="4819650"/>
           </a:xfrm>
           <a:prstGeom xmlns:a="http://schemas.openxmlformats.org/drawingml/2006/main" prst="rect">
             <a:avLst/>
@@ -19343,76 +19449,345 @@
           <p:cNvPr id="8" name="">
             <a:extLst xmlns:a="http://schemas.openxmlformats.org/drawingml/2006/main">
               <a:ext uri="{FF2B5EF4-FFF2-40B4-BE49-F238E27FC236}">
-                <a16:creationId xmlns:a16="http://schemas.microsoft.com/office/drawing/2014/main" id="{4346A5F2-8CC4-4151-9BDB-346D47A3096B}"/>
-              </a:ext>
-            </a:extLst>
-          </p:cNvPr>
-          <p:cNvSpPr>
-            <a:spLocks xmlns:a="http://schemas.openxmlformats.org/drawingml/2006/main" noGrp="1"/>
-          </p:cNvSpPr>
-          <p:nvPr/>
-        </p:nvSpPr>
-        <p:spPr>
-          <a:xfrm xmlns:a="http://schemas.openxmlformats.org/drawingml/2006/main">
-            <a:off x="1143000" y="6286500"/>
-            <a:ext cx="9906000" cy="171450"/>
-          </a:xfrm>
-          <a:prstGeom xmlns:a="http://schemas.openxmlformats.org/drawingml/2006/main" prst="rect">
-            <a:avLst/>
-          </a:prstGeom>
-          <a:noFill xmlns:a="http://schemas.openxmlformats.org/drawingml/2006/main"/>
-          <a:ln xmlns:a="http://schemas.openxmlformats.org/drawingml/2006/main" w="0">
-            <a:noFill/>
-            <a:prstDash val="solid"/>
-          </a:ln>
-        </p:spPr>
-        <p:txBody>
-          <a:bodyPr xmlns:a="http://schemas.openxmlformats.org/drawingml/2006/main" wrap="square" lIns="0" tIns="0" rIns="0" bIns="0" anchor="t">
-            <a:normAutofit fontScale="93750"/>
-          </a:bodyPr>
-          <a:lstStyle xmlns:a="http://schemas.openxmlformats.org/drawingml/2006/main"/>
-          <a:p xmlns:a="http://schemas.openxmlformats.org/drawingml/2006/main">
-            <a:pPr algn="ctr">
-              <a:buNone/>
-              <a:defRPr sz="1200" b="0">
-                <a:solidFill>
-                  <a:srgbClr val="667384"/>
-                </a:solidFill>
-                <a:latin typeface="Arial"/>
-                <a:ea typeface="Arial"/>
-                <a:cs typeface="Arial"/>
-              </a:defRPr>
-            </a:pPr>
-            <a:r>
-              <a:rPr sz="1200" b="0">
-                <a:solidFill>
-                  <a:srgbClr val="667384"/>
-                </a:solidFill>
-                <a:latin typeface="Arial"/>
-                <a:ea typeface="Arial"/>
-                <a:cs typeface="Arial"/>
-              </a:rPr>
-              <a:t>All 81 cells positive; strongest +0.198 at 10 prior / 25 forward; 0/81 within-state BH passes.</a:t>
+                <a16:creationId xmlns:a16="http://schemas.microsoft.com/office/drawing/2014/main" id="{C5B493DE-9AA4-4FF1-8BE2-28F352E8FA07}"/>
+              </a:ext>
+            </a:extLst>
+          </p:cNvPr>
+          <p:cNvSpPr>
+            <a:spLocks xmlns:a="http://schemas.openxmlformats.org/drawingml/2006/main" noGrp="1"/>
+          </p:cNvSpPr>
+          <p:nvPr/>
+        </p:nvSpPr>
+        <p:spPr>
+          <a:xfrm xmlns:a="http://schemas.openxmlformats.org/drawingml/2006/main">
+            <a:off x="9201150" y="1581150"/>
+            <a:ext cx="2190750" cy="361950"/>
+          </a:xfrm>
+          <a:prstGeom xmlns:a="http://schemas.openxmlformats.org/drawingml/2006/main" prst="rect">
+            <a:avLst/>
+          </a:prstGeom>
+          <a:noFill xmlns:a="http://schemas.openxmlformats.org/drawingml/2006/main"/>
+          <a:ln xmlns:a="http://schemas.openxmlformats.org/drawingml/2006/main" w="0">
+            <a:noFill/>
+            <a:prstDash val="solid"/>
+          </a:ln>
+        </p:spPr>
+        <p:txBody>
+          <a:bodyPr xmlns:a="http://schemas.openxmlformats.org/drawingml/2006/main" wrap="square" lIns="0" tIns="0" rIns="0" bIns="0" anchor="t">
+            <a:normAutofit fontScale="100000"/>
+          </a:bodyPr>
+          <a:lstStyle xmlns:a="http://schemas.openxmlformats.org/drawingml/2006/main"/>
+          <a:p xmlns:a="http://schemas.openxmlformats.org/drawingml/2006/main">
+            <a:pPr algn="l">
+              <a:buNone/>
+              <a:defRPr sz="2100" b="1">
+                <a:solidFill>
+                  <a:srgbClr val="000000"/>
+                </a:solidFill>
+                <a:latin typeface="Arial"/>
+                <a:ea typeface="Arial"/>
+                <a:cs typeface="Arial"/>
+              </a:defRPr>
+            </a:pPr>
+            <a:r>
+              <a:rPr sz="2100" b="1">
+                <a:solidFill>
+                  <a:srgbClr val="000000"/>
+                </a:solidFill>
+                <a:latin typeface="Arial"/>
+                <a:ea typeface="Arial"/>
+                <a:cs typeface="Arial"/>
+              </a:rPr>
+              <a:t>How</a:t>
+            </a:r>
+          </a:p>
+        </p:txBody>
+      </p:sp>
+      <p:sp>
+        <p:nvSpPr>
+          <p:cNvPr id="9" name="">
+            <a:extLst xmlns:a="http://schemas.openxmlformats.org/drawingml/2006/main">
+              <a:ext uri="{FF2B5EF4-FFF2-40B4-BE49-F238E27FC236}">
+                <a16:creationId xmlns:a16="http://schemas.microsoft.com/office/drawing/2014/main" id="{5B6B1C17-35A6-411A-A67C-A4A72F63EF67}"/>
+              </a:ext>
+            </a:extLst>
+          </p:cNvPr>
+          <p:cNvSpPr>
+            <a:spLocks xmlns:a="http://schemas.openxmlformats.org/drawingml/2006/main" noGrp="1"/>
+          </p:cNvSpPr>
+          <p:nvPr/>
+        </p:nvSpPr>
+        <p:spPr>
+          <a:xfrm xmlns:a="http://schemas.openxmlformats.org/drawingml/2006/main">
+            <a:off x="9201150" y="2038350"/>
+            <a:ext cx="2400300" cy="1143000"/>
+          </a:xfrm>
+          <a:prstGeom xmlns:a="http://schemas.openxmlformats.org/drawingml/2006/main" prst="rect">
+            <a:avLst/>
+          </a:prstGeom>
+          <a:noFill xmlns:a="http://schemas.openxmlformats.org/drawingml/2006/main"/>
+          <a:ln xmlns:a="http://schemas.openxmlformats.org/drawingml/2006/main" w="0">
+            <a:noFill/>
+            <a:prstDash val="solid"/>
+          </a:ln>
+        </p:spPr>
+        <p:txBody>
+          <a:bodyPr xmlns:a="http://schemas.openxmlformats.org/drawingml/2006/main" wrap="square" lIns="0" tIns="0" rIns="0" bIns="0" anchor="t">
+            <a:normAutofit fontScale="100000"/>
+          </a:bodyPr>
+          <a:lstStyle xmlns:a="http://schemas.openxmlformats.org/drawingml/2006/main"/>
+          <a:p xmlns:a="http://schemas.openxmlformats.org/drawingml/2006/main">
+            <a:pPr algn="l">
+              <a:buNone/>
+              <a:defRPr sz="1500" b="0">
+                <a:solidFill>
+                  <a:srgbClr val="273548"/>
+                </a:solidFill>
+                <a:latin typeface="Arial"/>
+                <a:ea typeface="Arial"/>
+                <a:cs typeface="Arial"/>
+              </a:defRPr>
+            </a:pPr>
+            <a:r>
+              <a:rPr sz="1500" b="0">
+                <a:solidFill>
+                  <a:srgbClr val="273548"/>
+                </a:solidFill>
+                <a:latin typeface="Arial"/>
+                <a:ea typeface="Arial"/>
+                <a:cs typeface="Arial"/>
+              </a:rPr>
+              <a:t>Accepted state uses Wilder ATR14 / close, ranked against the prior 252 completed ATR% observations.</a:t>
+            </a:r>
+          </a:p>
+        </p:txBody>
+      </p:sp>
+      <p:sp>
+        <p:nvSpPr>
+          <p:cNvPr id="10" name="">
+            <a:extLst xmlns:a="http://schemas.openxmlformats.org/drawingml/2006/main">
+              <a:ext uri="{FF2B5EF4-FFF2-40B4-BE49-F238E27FC236}">
+                <a16:creationId xmlns:a16="http://schemas.microsoft.com/office/drawing/2014/main" id="{1E6C96CB-CC04-417E-9ADF-6D8B711B5273}"/>
+              </a:ext>
+            </a:extLst>
+          </p:cNvPr>
+          <p:cNvSpPr>
+            <a:spLocks xmlns:a="http://schemas.openxmlformats.org/drawingml/2006/main" noGrp="1"/>
+          </p:cNvSpPr>
+          <p:nvPr/>
+        </p:nvSpPr>
+        <p:spPr>
+          <a:xfrm xmlns:a="http://schemas.openxmlformats.org/drawingml/2006/main">
+            <a:off x="9201150" y="3409950"/>
+            <a:ext cx="2190750" cy="361950"/>
+          </a:xfrm>
+          <a:prstGeom xmlns:a="http://schemas.openxmlformats.org/drawingml/2006/main" prst="rect">
+            <a:avLst/>
+          </a:prstGeom>
+          <a:noFill xmlns:a="http://schemas.openxmlformats.org/drawingml/2006/main"/>
+          <a:ln xmlns:a="http://schemas.openxmlformats.org/drawingml/2006/main" w="0">
+            <a:noFill/>
+            <a:prstDash val="solid"/>
+          </a:ln>
+        </p:spPr>
+        <p:txBody>
+          <a:bodyPr xmlns:a="http://schemas.openxmlformats.org/drawingml/2006/main" wrap="square" lIns="0" tIns="0" rIns="0" bIns="0" anchor="t">
+            <a:normAutofit fontScale="100000"/>
+          </a:bodyPr>
+          <a:lstStyle xmlns:a="http://schemas.openxmlformats.org/drawingml/2006/main"/>
+          <a:p xmlns:a="http://schemas.openxmlformats.org/drawingml/2006/main">
+            <a:pPr algn="l">
+              <a:buNone/>
+              <a:defRPr sz="2100" b="1">
+                <a:solidFill>
+                  <a:srgbClr val="000000"/>
+                </a:solidFill>
+                <a:latin typeface="Arial"/>
+                <a:ea typeface="Arial"/>
+                <a:cs typeface="Arial"/>
+              </a:defRPr>
+            </a:pPr>
+            <a:r>
+              <a:rPr sz="2100" b="1">
+                <a:solidFill>
+                  <a:srgbClr val="000000"/>
+                </a:solidFill>
+                <a:latin typeface="Arial"/>
+                <a:ea typeface="Arial"/>
+                <a:cs typeface="Arial"/>
+              </a:rPr>
+              <a:t>Read</a:t>
+            </a:r>
+          </a:p>
+        </p:txBody>
+      </p:sp>
+      <p:sp>
+        <p:nvSpPr>
+          <p:cNvPr id="11" name="">
+            <a:extLst xmlns:a="http://schemas.openxmlformats.org/drawingml/2006/main">
+              <a:ext uri="{FF2B5EF4-FFF2-40B4-BE49-F238E27FC236}">
+                <a16:creationId xmlns:a16="http://schemas.microsoft.com/office/drawing/2014/main" id="{6C2CCFF6-12C5-4DA0-960D-99266D20441C}"/>
+              </a:ext>
+            </a:extLst>
+          </p:cNvPr>
+          <p:cNvSpPr>
+            <a:spLocks xmlns:a="http://schemas.openxmlformats.org/drawingml/2006/main" noGrp="1"/>
+          </p:cNvSpPr>
+          <p:nvPr/>
+        </p:nvSpPr>
+        <p:spPr>
+          <a:xfrm xmlns:a="http://schemas.openxmlformats.org/drawingml/2006/main">
+            <a:off x="9201150" y="3867150"/>
+            <a:ext cx="2400300" cy="1657350"/>
+          </a:xfrm>
+          <a:prstGeom xmlns:a="http://schemas.openxmlformats.org/drawingml/2006/main" prst="rect">
+            <a:avLst/>
+          </a:prstGeom>
+          <a:noFill xmlns:a="http://schemas.openxmlformats.org/drawingml/2006/main"/>
+          <a:ln xmlns:a="http://schemas.openxmlformats.org/drawingml/2006/main" w="0">
+            <a:noFill/>
+            <a:prstDash val="solid"/>
+          </a:ln>
+        </p:spPr>
+        <p:txBody>
+          <a:bodyPr xmlns:a="http://schemas.openxmlformats.org/drawingml/2006/main" wrap="square" lIns="0" tIns="0" rIns="0" bIns="0" anchor="t">
+            <a:normAutofit fontScale="100000"/>
+          </a:bodyPr>
+          <a:lstStyle xmlns:a="http://schemas.openxmlformats.org/drawingml/2006/main"/>
+          <a:p xmlns:a="http://schemas.openxmlformats.org/drawingml/2006/main">
+            <a:pPr algn="l">
+              <a:buNone/>
+              <a:defRPr sz="1500" b="0">
+                <a:solidFill>
+                  <a:srgbClr val="273548"/>
+                </a:solidFill>
+                <a:latin typeface="Arial"/>
+                <a:ea typeface="Arial"/>
+                <a:cs typeface="Arial"/>
+              </a:defRPr>
+            </a:pPr>
+            <a:r>
+              <a:rPr sz="1500" b="0">
+                <a:solidFill>
+                  <a:srgbClr val="273548"/>
+                </a:solidFill>
+                <a:latin typeface="Arial"/>
+                <a:ea typeface="Arial"/>
+                <a:cs typeface="Arial"/>
+              </a:rPr>
+              <a:t>Blue marks LOW, gold MEDIUM, and red HIGH movement capacity. Price and the causal trailing ATR% rank are shown together.</a:t>
+            </a:r>
+          </a:p>
+        </p:txBody>
+      </p:sp>
+      <p:sp>
+        <p:nvSpPr>
+          <p:cNvPr id="12" name="">
+            <a:extLst xmlns:a="http://schemas.openxmlformats.org/drawingml/2006/main">
+              <a:ext uri="{FF2B5EF4-FFF2-40B4-BE49-F238E27FC236}">
+                <a16:creationId xmlns:a16="http://schemas.microsoft.com/office/drawing/2014/main" id="{0ACC076C-14CF-4CC6-9A1F-9DE2F654A640}"/>
+              </a:ext>
+            </a:extLst>
+          </p:cNvPr>
+          <p:cNvSpPr>
+            <a:spLocks xmlns:a="http://schemas.openxmlformats.org/drawingml/2006/main" noGrp="1"/>
+          </p:cNvSpPr>
+          <p:nvPr/>
+        </p:nvSpPr>
+        <p:spPr>
+          <a:xfrm xmlns:a="http://schemas.openxmlformats.org/drawingml/2006/main">
+            <a:off x="9201150" y="5715000"/>
+            <a:ext cx="2400300" cy="38100"/>
+          </a:xfrm>
+          <a:prstGeom xmlns:a="http://schemas.openxmlformats.org/drawingml/2006/main" prst="rect">
+            <a:avLst/>
+          </a:prstGeom>
+          <a:solidFill xmlns:a="http://schemas.openxmlformats.org/drawingml/2006/main">
+            <a:srgbClr val="2A9D6F"/>
+          </a:solidFill>
+          <a:ln xmlns:a="http://schemas.openxmlformats.org/drawingml/2006/main" w="0">
+            <a:solidFill>
+              <a:srgbClr val="2A9D6F"/>
+            </a:solidFill>
+            <a:prstDash val="solid"/>
+          </a:ln>
+        </p:spPr>
+      </p:sp>
+      <p:sp>
+        <p:nvSpPr>
+          <p:cNvPr id="13" name="">
+            <a:extLst xmlns:a="http://schemas.openxmlformats.org/drawingml/2006/main">
+              <a:ext uri="{FF2B5EF4-FFF2-40B4-BE49-F238E27FC236}">
+                <a16:creationId xmlns:a16="http://schemas.microsoft.com/office/drawing/2014/main" id="{75B62FEB-4FFC-484D-8635-E7157EEBB857}"/>
+              </a:ext>
+            </a:extLst>
+          </p:cNvPr>
+          <p:cNvSpPr>
+            <a:spLocks xmlns:a="http://schemas.openxmlformats.org/drawingml/2006/main" noGrp="1"/>
+          </p:cNvSpPr>
+          <p:nvPr/>
+        </p:nvSpPr>
+        <p:spPr>
+          <a:xfrm xmlns:a="http://schemas.openxmlformats.org/drawingml/2006/main">
+            <a:off x="9201150" y="5867400"/>
+            <a:ext cx="2400300" cy="419100"/>
+          </a:xfrm>
+          <a:prstGeom xmlns:a="http://schemas.openxmlformats.org/drawingml/2006/main" prst="rect">
+            <a:avLst/>
+          </a:prstGeom>
+          <a:noFill xmlns:a="http://schemas.openxmlformats.org/drawingml/2006/main"/>
+          <a:ln xmlns:a="http://schemas.openxmlformats.org/drawingml/2006/main" w="0">
+            <a:noFill/>
+            <a:prstDash val="solid"/>
+          </a:ln>
+        </p:spPr>
+        <p:txBody>
+          <a:bodyPr xmlns:a="http://schemas.openxmlformats.org/drawingml/2006/main" wrap="square" lIns="0" tIns="0" rIns="0" bIns="0" anchor="t">
+            <a:normAutofit fontScale="100000"/>
+          </a:bodyPr>
+          <a:lstStyle xmlns:a="http://schemas.openxmlformats.org/drawingml/2006/main"/>
+          <a:p xmlns:a="http://schemas.openxmlformats.org/drawingml/2006/main">
+            <a:pPr algn="l">
+              <a:buNone/>
+              <a:defRPr sz="1275" b="1">
+                <a:solidFill>
+                  <a:srgbClr val="2A9D6F"/>
+                </a:solidFill>
+                <a:latin typeface="Arial"/>
+                <a:ea typeface="Arial"/>
+                <a:cs typeface="Arial"/>
+              </a:defRPr>
+            </a:pPr>
+            <a:r>
+              <a:rPr sz="1275" b="1">
+                <a:solidFill>
+                  <a:srgbClr val="2A9D6F"/>
+                </a:solidFill>
+                <a:latin typeface="Arial"/>
+                <a:ea typeface="Arial"/>
+                <a:cs typeface="Arial"/>
+              </a:rPr>
+              <a:t>Descriptive state—not a future-return claim</a:t>
             </a:r>
           </a:p>
         </p:txBody>
       </p:sp>
       <p:pic>
         <p:nvPicPr>
-          <p:cNvPr id="18" name=""/>
+          <p:cNvPr id="28" name=""/>
           <p:cNvPicPr>
             <a:picLocks xmlns:a="http://schemas.openxmlformats.org/drawingml/2006/main" noChangeAspect="1"/>
           </p:cNvPicPr>
           <p:nvPr/>
         </p:nvPicPr>
         <p:blipFill>
-          <a:blip xmlns:r="http://schemas.openxmlformats.org/officeDocument/2006/relationships" xmlns:a="http://schemas.openxmlformats.org/drawingml/2006/main" r:embed="R0ae3be0cccb447e3"/>
+          <a:blip xmlns:r="http://schemas.openxmlformats.org/officeDocument/2006/relationships" xmlns:a="http://schemas.openxmlformats.org/drawingml/2006/main" r:embed="R4af3966987f646be"/>
           <a:stretch xmlns:a="http://schemas.openxmlformats.org/drawingml/2006/main"/>
         </p:blipFill>
         <p:spPr>
           <a:xfrm xmlns:a="http://schemas.openxmlformats.org/drawingml/2006/main" flipH="0" flipV="0">
-            <a:off x="2942545" y="1352550"/>
-            <a:ext cx="6306911" cy="4905375"/>
+            <a:off x="325967" y="1381125"/>
+            <a:ext cx="8568267" cy="4819650"/>
           </a:xfrm>
           <a:prstGeom xmlns:a="http://schemas.openxmlformats.org/drawingml/2006/main" prst="rect">
             <a:avLst/>
@@ -19422,7 +19797,7 @@
     </p:spTree>
     <p:extLst>
       <p:ext uri="{BB962C8B-B14F-4D97-AF65-F5344CB8AC3E}">
-        <p14:creationId xmlns:p14="http://schemas.microsoft.com/office/powerpoint/2010/main" val="400872380"/>
+        <p14:creationId xmlns:p14="http://schemas.microsoft.com/office/powerpoint/2010/main" val="317191340"/>
       </p:ext>
     </p:extLst>
   </p:cSld>
@@ -19537,7 +19912,7 @@
         </p:spPr>
         <p:txBody>
           <a:bodyPr xmlns:a="http://schemas.openxmlformats.org/drawingml/2006/main" wrap="square" lIns="0" tIns="0" rIns="0" bIns="0" anchor="t">
-            <a:normAutofit fontScale="96973"/>
+            <a:normAutofit fontScale="100000"/>
           </a:bodyPr>
           <a:lstStyle xmlns:a="http://schemas.openxmlformats.org/drawingml/2006/main"/>
           <a:p xmlns:a="http://schemas.openxmlformats.org/drawingml/2006/main">
@@ -19561,7 +19936,7 @@
                 <a:ea typeface="Arial"/>
                 <a:cs typeface="Arial"/>
               </a:rPr>
-              <a:t>MEDIUM ATR% contains the stable continuation island</a:t>
+              <a:t>LOW ATR% is broadly positive, but no cell passes</a:t>
             </a:r>
           </a:p>
         </p:txBody>
@@ -19804,7 +20179,7 @@
                 <a:ea typeface="Arial"/>
                 <a:cs typeface="Arial"/>
               </a:rPr>
-              <a:t>All 81 cells positive; 21/81 within-state BH passes; strict survivors cluster at 5–10 prior / 2–3 forward.</a:t>
+              <a:t>All 81 cells positive; strongest +0.198 at 10 prior / 25 forward; 0/81 within-state BH passes.</a:t>
             </a:r>
           </a:p>
         </p:txBody>
@@ -19818,7 +20193,7 @@
           <p:nvPr/>
         </p:nvPicPr>
         <p:blipFill>
-          <a:blip xmlns:r="http://schemas.openxmlformats.org/officeDocument/2006/relationships" xmlns:a="http://schemas.openxmlformats.org/drawingml/2006/main" r:embed="R0dfa96f2513646e1"/>
+          <a:blip xmlns:r="http://schemas.openxmlformats.org/officeDocument/2006/relationships" xmlns:a="http://schemas.openxmlformats.org/drawingml/2006/main" r:embed="Rfab5cec8d9694f55"/>
           <a:stretch xmlns:a="http://schemas.openxmlformats.org/drawingml/2006/main"/>
         </p:blipFill>
         <p:spPr>
@@ -19949,7 +20324,7 @@
         </p:spPr>
         <p:txBody>
           <a:bodyPr xmlns:a="http://schemas.openxmlformats.org/drawingml/2006/main" wrap="square" lIns="0" tIns="0" rIns="0" bIns="0" anchor="t">
-            <a:normAutofit fontScale="100000"/>
+            <a:normAutofit fontScale="96973"/>
           </a:bodyPr>
           <a:lstStyle xmlns:a="http://schemas.openxmlformats.org/drawingml/2006/main"/>
           <a:p xmlns:a="http://schemas.openxmlformats.org/drawingml/2006/main">
@@ -19973,7 +20348,7 @@
                 <a:ea typeface="Arial"/>
                 <a:cs typeface="Arial"/>
               </a:rPr>
-              <a:t>HIGH ATR% flips the surface toward reversal</a:t>
+              <a:t>MEDIUM ATR% contains the stable continuation island</a:t>
             </a:r>
           </a:p>
         </p:txBody>
@@ -20216,7 +20591,7 @@
                 <a:ea typeface="Arial"/>
                 <a:cs typeface="Arial"/>
               </a:rPr>
-              <a:t>77/81 cells negative; strongest -0.301 at 20 prior / 20 forward; 0/81 within-state BH passes.</a:t>
+              <a:t>All 81 cells positive; 21/81 within-state BH passes; strict survivors cluster at 5–10 prior / 2–3 forward.</a:t>
             </a:r>
           </a:p>
         </p:txBody>
@@ -20230,7 +20605,7 @@
           <p:nvPr/>
         </p:nvPicPr>
         <p:blipFill>
-          <a:blip xmlns:r="http://schemas.openxmlformats.org/officeDocument/2006/relationships" xmlns:a="http://schemas.openxmlformats.org/drawingml/2006/main" r:embed="R73bedb1da1d04027"/>
+          <a:blip xmlns:r="http://schemas.openxmlformats.org/officeDocument/2006/relationships" xmlns:a="http://schemas.openxmlformats.org/drawingml/2006/main" r:embed="Rd42cf5fa0c1545c1"/>
           <a:stretch xmlns:a="http://schemas.openxmlformats.org/drawingml/2006/main"/>
         </p:blipFill>
         <p:spPr>
@@ -20274,10 +20649,10 @@
       </p:grpSpPr>
       <p:sp>
         <p:nvSpPr>
-          <p:cNvPr id="20" name="section-7">
-            <a:extLst xmlns:a="http://schemas.openxmlformats.org/drawingml/2006/main">
-              <a:ext uri="{FF2B5EF4-FFF2-40B4-BE49-F238E27FC236}">
-                <a16:creationId xmlns:a16="http://schemas.microsoft.com/office/drawing/2014/main" id="{BAC8373F-594E-467B-A8F8-56439CEBE044}"/>
+          <p:cNvPr id="9" name="section-4">
+            <a:extLst xmlns:a="http://schemas.openxmlformats.org/drawingml/2006/main">
+              <a:ext uri="{FF2B5EF4-FFF2-40B4-BE49-F238E27FC236}">
+                <a16:creationId xmlns:a16="http://schemas.microsoft.com/office/drawing/2014/main" id="{8AE0A271-669A-49F0-A82E-C4438BEE27D9}"/>
               </a:ext>
             </a:extLst>
           </p:cNvPr>
@@ -20333,10 +20708,10 @@
       </p:sp>
       <p:sp>
         <p:nvSpPr>
-          <p:cNvPr id="2" name="title-7">
-            <a:extLst xmlns:a="http://schemas.openxmlformats.org/drawingml/2006/main">
-              <a:ext uri="{FF2B5EF4-FFF2-40B4-BE49-F238E27FC236}">
-                <a16:creationId xmlns:a16="http://schemas.microsoft.com/office/drawing/2014/main" id="{7592E6E5-EA60-427F-BAB4-42C154D8CC5F}"/>
+          <p:cNvPr id="2" name="title-4">
+            <a:extLst xmlns:a="http://schemas.openxmlformats.org/drawingml/2006/main">
+              <a:ext uri="{FF2B5EF4-FFF2-40B4-BE49-F238E27FC236}">
+                <a16:creationId xmlns:a16="http://schemas.microsoft.com/office/drawing/2014/main" id="{50C6F92F-721A-4252-9CF8-B5C9B01C7310}"/>
               </a:ext>
             </a:extLst>
           </p:cNvPr>
@@ -20385,7 +20760,7 @@
                 <a:ea typeface="Arial"/>
                 <a:cs typeface="Arial"/>
               </a:rPr>
-              <a:t>HIGH and MEDIUM contain direct state differences</a:t>
+              <a:t>HIGH ATR% flips the surface toward reversal</a:t>
             </a:r>
           </a:p>
         </p:txBody>
@@ -20395,7 +20770,7 @@
           <p:cNvPr id="3" name="">
             <a:extLst xmlns:a="http://schemas.openxmlformats.org/drawingml/2006/main">
               <a:ext uri="{FF2B5EF4-FFF2-40B4-BE49-F238E27FC236}">
-                <a16:creationId xmlns:a16="http://schemas.microsoft.com/office/drawing/2014/main" id="{C852E1AC-5CE8-4847-87B1-81C28A4EFEDE}"/>
+                <a16:creationId xmlns:a16="http://schemas.microsoft.com/office/drawing/2014/main" id="{242399F2-4D0A-4337-B17E-DB3599DC380F}"/>
               </a:ext>
             </a:extLst>
           </p:cNvPr>
@@ -20425,10 +20800,10 @@
       </p:sp>
       <p:sp>
         <p:nvSpPr>
-          <p:cNvPr id="4" name="footer-left-7">
-            <a:extLst xmlns:a="http://schemas.openxmlformats.org/drawingml/2006/main">
-              <a:ext uri="{FF2B5EF4-FFF2-40B4-BE49-F238E27FC236}">
-                <a16:creationId xmlns:a16="http://schemas.microsoft.com/office/drawing/2014/main" id="{4896B590-20BC-4B46-9282-D9F5A22A0CC5}"/>
+          <p:cNvPr id="4" name="footer-left-4">
+            <a:extLst xmlns:a="http://schemas.openxmlformats.org/drawingml/2006/main">
+              <a:ext uri="{FF2B5EF4-FFF2-40B4-BE49-F238E27FC236}">
+                <a16:creationId xmlns:a16="http://schemas.microsoft.com/office/drawing/2014/main" id="{BF8B82CA-1E48-4669-BAD8-1FF8C09FCBFB}"/>
               </a:ext>
             </a:extLst>
           </p:cNvPr>
@@ -20484,10 +20859,10 @@
       </p:sp>
       <p:sp>
         <p:nvSpPr>
-          <p:cNvPr id="5" name="footer-number-7">
-            <a:extLst xmlns:a="http://schemas.openxmlformats.org/drawingml/2006/main">
-              <a:ext uri="{FF2B5EF4-FFF2-40B4-BE49-F238E27FC236}">
-                <a16:creationId xmlns:a16="http://schemas.microsoft.com/office/drawing/2014/main" id="{1503EFAF-F487-4981-AFDC-23F1B41A7207}"/>
+          <p:cNvPr id="5" name="footer-number-4">
+            <a:extLst xmlns:a="http://schemas.openxmlformats.org/drawingml/2006/main">
+              <a:ext uri="{FF2B5EF4-FFF2-40B4-BE49-F238E27FC236}">
+                <a16:creationId xmlns:a16="http://schemas.microsoft.com/office/drawing/2014/main" id="{05959AEC-B0A5-45F0-A65B-C94C3E5A032F}"/>
               </a:ext>
             </a:extLst>
           </p:cNvPr>
@@ -20546,19 +20921,19 @@
           <p:cNvPr id="6" name="">
             <a:extLst xmlns:a="http://schemas.openxmlformats.org/drawingml/2006/main">
               <a:ext uri="{FF2B5EF4-FFF2-40B4-BE49-F238E27FC236}">
-                <a16:creationId xmlns:a16="http://schemas.microsoft.com/office/drawing/2014/main" id="{4AA770DD-55E6-42DB-942A-6938E642B1A0}"/>
-              </a:ext>
-            </a:extLst>
-          </p:cNvPr>
-          <p:cNvSpPr>
-            <a:spLocks xmlns:a="http://schemas.openxmlformats.org/drawingml/2006/main" noGrp="1"/>
-          </p:cNvSpPr>
-          <p:nvPr/>
-        </p:nvSpPr>
-        <p:spPr>
-          <a:xfrm xmlns:a="http://schemas.openxmlformats.org/drawingml/2006/main">
-            <a:off x="342900" y="1428750"/>
-            <a:ext cx="7677150" cy="4762500"/>
+                <a16:creationId xmlns:a16="http://schemas.microsoft.com/office/drawing/2014/main" id="{9C8DEA29-E57D-4C8D-8538-2028FF89DA7C}"/>
+              </a:ext>
+            </a:extLst>
+          </p:cNvPr>
+          <p:cNvSpPr>
+            <a:spLocks xmlns:a="http://schemas.openxmlformats.org/drawingml/2006/main" noGrp="1"/>
+          </p:cNvSpPr>
+          <p:nvPr/>
+        </p:nvSpPr>
+        <p:spPr>
+          <a:xfrm xmlns:a="http://schemas.openxmlformats.org/drawingml/2006/main">
+            <a:off x="1000125" y="1352550"/>
+            <a:ext cx="10191750" cy="4905375"/>
           </a:xfrm>
           <a:prstGeom xmlns:a="http://schemas.openxmlformats.org/drawingml/2006/main" prst="rect">
             <a:avLst/>
@@ -20579,569 +20954,76 @@
           <p:cNvPr id="8" name="">
             <a:extLst xmlns:a="http://schemas.openxmlformats.org/drawingml/2006/main">
               <a:ext uri="{FF2B5EF4-FFF2-40B4-BE49-F238E27FC236}">
-                <a16:creationId xmlns:a16="http://schemas.microsoft.com/office/drawing/2014/main" id="{925D1653-1738-47C8-BFA1-9C9390285CC4}"/>
-              </a:ext>
-            </a:extLst>
-          </p:cNvPr>
-          <p:cNvSpPr>
-            <a:spLocks xmlns:a="http://schemas.openxmlformats.org/drawingml/2006/main" noGrp="1"/>
-          </p:cNvSpPr>
-          <p:nvPr/>
-        </p:nvSpPr>
-        <p:spPr>
-          <a:xfrm xmlns:a="http://schemas.openxmlformats.org/drawingml/2006/main">
-            <a:off x="8362950" y="1504950"/>
-            <a:ext cx="3143250" cy="1428750"/>
-          </a:xfrm>
-          <a:prstGeom xmlns:a="http://schemas.openxmlformats.org/drawingml/2006/main" prst="rect">
-            <a:avLst/>
-          </a:prstGeom>
-          <a:solidFill xmlns:a="http://schemas.openxmlformats.org/drawingml/2006/main">
-            <a:srgbClr val="EDEDED"/>
-          </a:solidFill>
-          <a:ln xmlns:a="http://schemas.openxmlformats.org/drawingml/2006/main" w="0">
-            <a:solidFill>
-              <a:srgbClr val="EDEDED"/>
-            </a:solidFill>
-            <a:prstDash val="solid"/>
-          </a:ln>
-        </p:spPr>
-      </p:sp>
-      <p:sp>
-        <p:nvSpPr>
-          <p:cNvPr id="9" name="">
-            <a:extLst xmlns:a="http://schemas.openxmlformats.org/drawingml/2006/main">
-              <a:ext uri="{FF2B5EF4-FFF2-40B4-BE49-F238E27FC236}">
-                <a16:creationId xmlns:a16="http://schemas.microsoft.com/office/drawing/2014/main" id="{AD911094-04B5-4E98-9749-4F832E6A7030}"/>
-              </a:ext>
-            </a:extLst>
-          </p:cNvPr>
-          <p:cNvSpPr>
-            <a:spLocks xmlns:a="http://schemas.openxmlformats.org/drawingml/2006/main" noGrp="1"/>
-          </p:cNvSpPr>
-          <p:nvPr/>
-        </p:nvSpPr>
-        <p:spPr>
-          <a:xfrm xmlns:a="http://schemas.openxmlformats.org/drawingml/2006/main">
-            <a:off x="8362950" y="1504950"/>
-            <a:ext cx="76200" cy="1428750"/>
-          </a:xfrm>
-          <a:prstGeom xmlns:a="http://schemas.openxmlformats.org/drawingml/2006/main" prst="rect">
-            <a:avLst/>
-          </a:prstGeom>
-          <a:solidFill xmlns:a="http://schemas.openxmlformats.org/drawingml/2006/main">
-            <a:srgbClr val="E45756"/>
-          </a:solidFill>
-          <a:ln xmlns:a="http://schemas.openxmlformats.org/drawingml/2006/main" w="0">
-            <a:solidFill>
-              <a:srgbClr val="E45756"/>
-            </a:solidFill>
-            <a:prstDash val="solid"/>
-          </a:ln>
-        </p:spPr>
-      </p:sp>
-      <p:sp>
-        <p:nvSpPr>
-          <p:cNvPr id="10" name="">
-            <a:extLst xmlns:a="http://schemas.openxmlformats.org/drawingml/2006/main">
-              <a:ext uri="{FF2B5EF4-FFF2-40B4-BE49-F238E27FC236}">
-                <a16:creationId xmlns:a16="http://schemas.microsoft.com/office/drawing/2014/main" id="{8259A327-4374-4B4E-A3BA-F8E016498564}"/>
-              </a:ext>
-            </a:extLst>
-          </p:cNvPr>
-          <p:cNvSpPr>
-            <a:spLocks xmlns:a="http://schemas.openxmlformats.org/drawingml/2006/main" noGrp="1"/>
-          </p:cNvSpPr>
-          <p:nvPr/>
-        </p:nvSpPr>
-        <p:spPr>
-          <a:xfrm xmlns:a="http://schemas.openxmlformats.org/drawingml/2006/main">
-            <a:off x="8629650" y="1676400"/>
-            <a:ext cx="2686050" cy="590550"/>
-          </a:xfrm>
-          <a:prstGeom xmlns:a="http://schemas.openxmlformats.org/drawingml/2006/main" prst="rect">
-            <a:avLst/>
-          </a:prstGeom>
-          <a:noFill xmlns:a="http://schemas.openxmlformats.org/drawingml/2006/main"/>
-          <a:ln xmlns:a="http://schemas.openxmlformats.org/drawingml/2006/main" w="0">
-            <a:noFill/>
-            <a:prstDash val="solid"/>
-          </a:ln>
-        </p:spPr>
-        <p:txBody>
-          <a:bodyPr xmlns:a="http://schemas.openxmlformats.org/drawingml/2006/main" wrap="square" lIns="0" tIns="0" rIns="0" bIns="0" anchor="t">
-            <a:normAutofit fontScale="100000"/>
-          </a:bodyPr>
-          <a:lstStyle xmlns:a="http://schemas.openxmlformats.org/drawingml/2006/main"/>
-          <a:p xmlns:a="http://schemas.openxmlformats.org/drawingml/2006/main">
-            <a:pPr algn="l">
-              <a:buNone/>
-              <a:defRPr sz="3225" b="1">
-                <a:solidFill>
-                  <a:srgbClr val="E45756"/>
-                </a:solidFill>
-                <a:latin typeface="Arial"/>
-                <a:ea typeface="Arial"/>
-                <a:cs typeface="Arial"/>
-              </a:defRPr>
-            </a:pPr>
-            <a:r>
-              <a:rPr sz="3225" b="1">
-                <a:solidFill>
-                  <a:srgbClr val="E45756"/>
-                </a:solidFill>
-                <a:latin typeface="Arial"/>
-                <a:ea typeface="Arial"/>
-                <a:cs typeface="Arial"/>
-              </a:rPr>
-              <a:t>-0.548</a:t>
-            </a:r>
-          </a:p>
-        </p:txBody>
-      </p:sp>
-      <p:sp>
-        <p:nvSpPr>
-          <p:cNvPr id="11" name="">
-            <a:extLst xmlns:a="http://schemas.openxmlformats.org/drawingml/2006/main">
-              <a:ext uri="{FF2B5EF4-FFF2-40B4-BE49-F238E27FC236}">
-                <a16:creationId xmlns:a16="http://schemas.microsoft.com/office/drawing/2014/main" id="{BE341AE3-547D-4111-ADFF-14E5545F2DBF}"/>
-              </a:ext>
-            </a:extLst>
-          </p:cNvPr>
-          <p:cNvSpPr>
-            <a:spLocks xmlns:a="http://schemas.openxmlformats.org/drawingml/2006/main" noGrp="1"/>
-          </p:cNvSpPr>
-          <p:nvPr/>
-        </p:nvSpPr>
-        <p:spPr>
-          <a:xfrm xmlns:a="http://schemas.openxmlformats.org/drawingml/2006/main">
-            <a:off x="8629650" y="2343150"/>
-            <a:ext cx="2686050" cy="438150"/>
-          </a:xfrm>
-          <a:prstGeom xmlns:a="http://schemas.openxmlformats.org/drawingml/2006/main" prst="rect">
-            <a:avLst/>
-          </a:prstGeom>
-          <a:noFill xmlns:a="http://schemas.openxmlformats.org/drawingml/2006/main"/>
-          <a:ln xmlns:a="http://schemas.openxmlformats.org/drawingml/2006/main" w="0">
-            <a:noFill/>
-            <a:prstDash val="solid"/>
-          </a:ln>
-        </p:spPr>
-        <p:txBody>
-          <a:bodyPr xmlns:a="http://schemas.openxmlformats.org/drawingml/2006/main" wrap="square" lIns="0" tIns="0" rIns="0" bIns="0" anchor="t">
-            <a:normAutofit fontScale="100000"/>
-          </a:bodyPr>
-          <a:lstStyle xmlns:a="http://schemas.openxmlformats.org/drawingml/2006/main"/>
-          <a:p xmlns:a="http://schemas.openxmlformats.org/drawingml/2006/main">
-            <a:pPr algn="l">
-              <a:buNone/>
-              <a:defRPr sz="1350" b="0">
-                <a:solidFill>
-                  <a:srgbClr val="273548"/>
-                </a:solidFill>
-                <a:latin typeface="Arial"/>
-                <a:ea typeface="Arial"/>
-                <a:cs typeface="Arial"/>
-              </a:defRPr>
-            </a:pPr>
-            <a:r>
-              <a:rPr sz="1350" b="0">
-                <a:solidFill>
-                  <a:srgbClr val="273548"/>
-                </a:solidFill>
-                <a:latin typeface="Arial"/>
-                <a:ea typeface="Arial"/>
-                <a:cs typeface="Arial"/>
-              </a:rPr>
-              <a:t>largest correlation change: 25 prior / 15 forward</a:t>
-            </a:r>
-          </a:p>
-        </p:txBody>
-      </p:sp>
-      <p:sp>
-        <p:nvSpPr>
-          <p:cNvPr id="12" name="">
-            <a:extLst xmlns:a="http://schemas.openxmlformats.org/drawingml/2006/main">
-              <a:ext uri="{FF2B5EF4-FFF2-40B4-BE49-F238E27FC236}">
-                <a16:creationId xmlns:a16="http://schemas.microsoft.com/office/drawing/2014/main" id="{627B1C2D-BD18-4B6C-8DC8-10694F2FD365}"/>
-              </a:ext>
-            </a:extLst>
-          </p:cNvPr>
-          <p:cNvSpPr>
-            <a:spLocks xmlns:a="http://schemas.openxmlformats.org/drawingml/2006/main" noGrp="1"/>
-          </p:cNvSpPr>
-          <p:nvPr/>
-        </p:nvSpPr>
-        <p:spPr>
-          <a:xfrm xmlns:a="http://schemas.openxmlformats.org/drawingml/2006/main">
-            <a:off x="8362950" y="3143250"/>
-            <a:ext cx="3143250" cy="1428750"/>
-          </a:xfrm>
-          <a:prstGeom xmlns:a="http://schemas.openxmlformats.org/drawingml/2006/main" prst="rect">
-            <a:avLst/>
-          </a:prstGeom>
-          <a:solidFill xmlns:a="http://schemas.openxmlformats.org/drawingml/2006/main">
-            <a:srgbClr val="EDEDED"/>
-          </a:solidFill>
-          <a:ln xmlns:a="http://schemas.openxmlformats.org/drawingml/2006/main" w="0">
-            <a:solidFill>
-              <a:srgbClr val="EDEDED"/>
-            </a:solidFill>
-            <a:prstDash val="solid"/>
-          </a:ln>
-        </p:spPr>
-      </p:sp>
-      <p:sp>
-        <p:nvSpPr>
-          <p:cNvPr id="13" name="">
-            <a:extLst xmlns:a="http://schemas.openxmlformats.org/drawingml/2006/main">
-              <a:ext uri="{FF2B5EF4-FFF2-40B4-BE49-F238E27FC236}">
-                <a16:creationId xmlns:a16="http://schemas.microsoft.com/office/drawing/2014/main" id="{1A4050CC-5568-4F8A-B026-EC7B8ABEFB7A}"/>
-              </a:ext>
-            </a:extLst>
-          </p:cNvPr>
-          <p:cNvSpPr>
-            <a:spLocks xmlns:a="http://schemas.openxmlformats.org/drawingml/2006/main" noGrp="1"/>
-          </p:cNvSpPr>
-          <p:nvPr/>
-        </p:nvSpPr>
-        <p:spPr>
-          <a:xfrm xmlns:a="http://schemas.openxmlformats.org/drawingml/2006/main">
-            <a:off x="8362950" y="3143250"/>
-            <a:ext cx="76200" cy="1428750"/>
-          </a:xfrm>
-          <a:prstGeom xmlns:a="http://schemas.openxmlformats.org/drawingml/2006/main" prst="rect">
-            <a:avLst/>
-          </a:prstGeom>
-          <a:solidFill xmlns:a="http://schemas.openxmlformats.org/drawingml/2006/main">
-            <a:srgbClr val="3D8DFF"/>
-          </a:solidFill>
-          <a:ln xmlns:a="http://schemas.openxmlformats.org/drawingml/2006/main" w="0">
-            <a:solidFill>
-              <a:srgbClr val="3D8DFF"/>
-            </a:solidFill>
-            <a:prstDash val="solid"/>
-          </a:ln>
-        </p:spPr>
-      </p:sp>
-      <p:sp>
-        <p:nvSpPr>
-          <p:cNvPr id="14" name="">
-            <a:extLst xmlns:a="http://schemas.openxmlformats.org/drawingml/2006/main">
-              <a:ext uri="{FF2B5EF4-FFF2-40B4-BE49-F238E27FC236}">
-                <a16:creationId xmlns:a16="http://schemas.microsoft.com/office/drawing/2014/main" id="{502FF9D4-D051-476B-B68A-15DCA6B44FE9}"/>
-              </a:ext>
-            </a:extLst>
-          </p:cNvPr>
-          <p:cNvSpPr>
-            <a:spLocks xmlns:a="http://schemas.openxmlformats.org/drawingml/2006/main" noGrp="1"/>
-          </p:cNvSpPr>
-          <p:nvPr/>
-        </p:nvSpPr>
-        <p:spPr>
-          <a:xfrm xmlns:a="http://schemas.openxmlformats.org/drawingml/2006/main">
-            <a:off x="8629650" y="3314700"/>
-            <a:ext cx="2686050" cy="590550"/>
-          </a:xfrm>
-          <a:prstGeom xmlns:a="http://schemas.openxmlformats.org/drawingml/2006/main" prst="rect">
-            <a:avLst/>
-          </a:prstGeom>
-          <a:noFill xmlns:a="http://schemas.openxmlformats.org/drawingml/2006/main"/>
-          <a:ln xmlns:a="http://schemas.openxmlformats.org/drawingml/2006/main" w="0">
-            <a:noFill/>
-            <a:prstDash val="solid"/>
-          </a:ln>
-        </p:spPr>
-        <p:txBody>
-          <a:bodyPr xmlns:a="http://schemas.openxmlformats.org/drawingml/2006/main" wrap="square" lIns="0" tIns="0" rIns="0" bIns="0" anchor="t">
-            <a:normAutofit fontScale="100000"/>
-          </a:bodyPr>
-          <a:lstStyle xmlns:a="http://schemas.openxmlformats.org/drawingml/2006/main"/>
-          <a:p xmlns:a="http://schemas.openxmlformats.org/drawingml/2006/main">
-            <a:pPr algn="l">
-              <a:buNone/>
-              <a:defRPr sz="3225" b="1">
-                <a:solidFill>
-                  <a:srgbClr val="3D8DFF"/>
-                </a:solidFill>
-                <a:latin typeface="Arial"/>
-                <a:ea typeface="Arial"/>
-                <a:cs typeface="Arial"/>
-              </a:defRPr>
-            </a:pPr>
-            <a:r>
-              <a:rPr sz="3225" b="1">
-                <a:solidFill>
-                  <a:srgbClr val="3D8DFF"/>
-                </a:solidFill>
-                <a:latin typeface="Arial"/>
-                <a:ea typeface="Arial"/>
-                <a:cs typeface="Arial"/>
-              </a:rPr>
-              <a:t>q = 0.038</a:t>
-            </a:r>
-          </a:p>
-        </p:txBody>
-      </p:sp>
-      <p:sp>
-        <p:nvSpPr>
-          <p:cNvPr id="15" name="">
-            <a:extLst xmlns:a="http://schemas.openxmlformats.org/drawingml/2006/main">
-              <a:ext uri="{FF2B5EF4-FFF2-40B4-BE49-F238E27FC236}">
-                <a16:creationId xmlns:a16="http://schemas.microsoft.com/office/drawing/2014/main" id="{03DFBB46-08D6-4497-AA7C-C2049757E9DE}"/>
-              </a:ext>
-            </a:extLst>
-          </p:cNvPr>
-          <p:cNvSpPr>
-            <a:spLocks xmlns:a="http://schemas.openxmlformats.org/drawingml/2006/main" noGrp="1"/>
-          </p:cNvSpPr>
-          <p:nvPr/>
-        </p:nvSpPr>
-        <p:spPr>
-          <a:xfrm xmlns:a="http://schemas.openxmlformats.org/drawingml/2006/main">
-            <a:off x="8629650" y="3981450"/>
-            <a:ext cx="2686050" cy="438150"/>
-          </a:xfrm>
-          <a:prstGeom xmlns:a="http://schemas.openxmlformats.org/drawingml/2006/main" prst="rect">
-            <a:avLst/>
-          </a:prstGeom>
-          <a:noFill xmlns:a="http://schemas.openxmlformats.org/drawingml/2006/main"/>
-          <a:ln xmlns:a="http://schemas.openxmlformats.org/drawingml/2006/main" w="0">
-            <a:noFill/>
-            <a:prstDash val="solid"/>
-          </a:ln>
-        </p:spPr>
-        <p:txBody>
-          <a:bodyPr xmlns:a="http://schemas.openxmlformats.org/drawingml/2006/main" wrap="square" lIns="0" tIns="0" rIns="0" bIns="0" anchor="t">
-            <a:normAutofit fontScale="100000"/>
-          </a:bodyPr>
-          <a:lstStyle xmlns:a="http://schemas.openxmlformats.org/drawingml/2006/main"/>
-          <a:p xmlns:a="http://schemas.openxmlformats.org/drawingml/2006/main">
-            <a:pPr algn="l">
-              <a:buNone/>
-              <a:defRPr sz="1350" b="0">
-                <a:solidFill>
-                  <a:srgbClr val="273548"/>
-                </a:solidFill>
-                <a:latin typeface="Arial"/>
-                <a:ea typeface="Arial"/>
-                <a:cs typeface="Arial"/>
-              </a:defRPr>
-            </a:pPr>
-            <a:r>
-              <a:rPr sz="1350" b="0">
-                <a:solidFill>
-                  <a:srgbClr val="273548"/>
-                </a:solidFill>
-                <a:latin typeface="Arial"/>
-                <a:ea typeface="Arial"/>
-                <a:cs typeface="Arial"/>
-              </a:rPr>
-              <a:t>within HIGH-minus-MEDIUM family</a:t>
-            </a:r>
-          </a:p>
-        </p:txBody>
-      </p:sp>
-      <p:sp>
-        <p:nvSpPr>
-          <p:cNvPr id="16" name="">
-            <a:extLst xmlns:a="http://schemas.openxmlformats.org/drawingml/2006/main">
-              <a:ext uri="{FF2B5EF4-FFF2-40B4-BE49-F238E27FC236}">
-                <a16:creationId xmlns:a16="http://schemas.microsoft.com/office/drawing/2014/main" id="{509D61CC-6E5E-49EC-A5F6-E861E8561441}"/>
-              </a:ext>
-            </a:extLst>
-          </p:cNvPr>
-          <p:cNvSpPr>
-            <a:spLocks xmlns:a="http://schemas.openxmlformats.org/drawingml/2006/main" noGrp="1"/>
-          </p:cNvSpPr>
-          <p:nvPr/>
-        </p:nvSpPr>
-        <p:spPr>
-          <a:xfrm xmlns:a="http://schemas.openxmlformats.org/drawingml/2006/main">
-            <a:off x="8362950" y="4781550"/>
-            <a:ext cx="3143250" cy="1428750"/>
-          </a:xfrm>
-          <a:prstGeom xmlns:a="http://schemas.openxmlformats.org/drawingml/2006/main" prst="rect">
-            <a:avLst/>
-          </a:prstGeom>
-          <a:solidFill xmlns:a="http://schemas.openxmlformats.org/drawingml/2006/main">
-            <a:srgbClr val="EDEDED"/>
-          </a:solidFill>
-          <a:ln xmlns:a="http://schemas.openxmlformats.org/drawingml/2006/main" w="0">
-            <a:solidFill>
-              <a:srgbClr val="EDEDED"/>
-            </a:solidFill>
-            <a:prstDash val="solid"/>
-          </a:ln>
-        </p:spPr>
-      </p:sp>
-      <p:sp>
-        <p:nvSpPr>
-          <p:cNvPr id="17" name="">
-            <a:extLst xmlns:a="http://schemas.openxmlformats.org/drawingml/2006/main">
-              <a:ext uri="{FF2B5EF4-FFF2-40B4-BE49-F238E27FC236}">
-                <a16:creationId xmlns:a16="http://schemas.microsoft.com/office/drawing/2014/main" id="{A935608E-4DDE-41BA-8DF2-831CF419565B}"/>
-              </a:ext>
-            </a:extLst>
-          </p:cNvPr>
-          <p:cNvSpPr>
-            <a:spLocks xmlns:a="http://schemas.openxmlformats.org/drawingml/2006/main" noGrp="1"/>
-          </p:cNvSpPr>
-          <p:nvPr/>
-        </p:nvSpPr>
-        <p:spPr>
-          <a:xfrm xmlns:a="http://schemas.openxmlformats.org/drawingml/2006/main">
-            <a:off x="8362950" y="4781550"/>
-            <a:ext cx="76200" cy="1428750"/>
-          </a:xfrm>
-          <a:prstGeom xmlns:a="http://schemas.openxmlformats.org/drawingml/2006/main" prst="rect">
-            <a:avLst/>
-          </a:prstGeom>
-          <a:solidFill xmlns:a="http://schemas.openxmlformats.org/drawingml/2006/main">
-            <a:srgbClr val="273548"/>
-          </a:solidFill>
-          <a:ln xmlns:a="http://schemas.openxmlformats.org/drawingml/2006/main" w="0">
-            <a:solidFill>
-              <a:srgbClr val="273548"/>
-            </a:solidFill>
-            <a:prstDash val="solid"/>
-          </a:ln>
-        </p:spPr>
-      </p:sp>
-      <p:sp>
-        <p:nvSpPr>
-          <p:cNvPr id="18" name="">
-            <a:extLst xmlns:a="http://schemas.openxmlformats.org/drawingml/2006/main">
-              <a:ext uri="{FF2B5EF4-FFF2-40B4-BE49-F238E27FC236}">
-                <a16:creationId xmlns:a16="http://schemas.microsoft.com/office/drawing/2014/main" id="{088A976D-39D1-4C6C-803F-0D3F8BAE4A28}"/>
-              </a:ext>
-            </a:extLst>
-          </p:cNvPr>
-          <p:cNvSpPr>
-            <a:spLocks xmlns:a="http://schemas.openxmlformats.org/drawingml/2006/main" noGrp="1"/>
-          </p:cNvSpPr>
-          <p:nvPr/>
-        </p:nvSpPr>
-        <p:spPr>
-          <a:xfrm xmlns:a="http://schemas.openxmlformats.org/drawingml/2006/main">
-            <a:off x="8629650" y="4953000"/>
-            <a:ext cx="2686050" cy="590550"/>
-          </a:xfrm>
-          <a:prstGeom xmlns:a="http://schemas.openxmlformats.org/drawingml/2006/main" prst="rect">
-            <a:avLst/>
-          </a:prstGeom>
-          <a:noFill xmlns:a="http://schemas.openxmlformats.org/drawingml/2006/main"/>
-          <a:ln xmlns:a="http://schemas.openxmlformats.org/drawingml/2006/main" w="0">
-            <a:noFill/>
-            <a:prstDash val="solid"/>
-          </a:ln>
-        </p:spPr>
-        <p:txBody>
-          <a:bodyPr xmlns:a="http://schemas.openxmlformats.org/drawingml/2006/main" wrap="square" lIns="0" tIns="0" rIns="0" bIns="0" anchor="t">
-            <a:normAutofit fontScale="100000"/>
-          </a:bodyPr>
-          <a:lstStyle xmlns:a="http://schemas.openxmlformats.org/drawingml/2006/main"/>
-          <a:p xmlns:a="http://schemas.openxmlformats.org/drawingml/2006/main">
-            <a:pPr algn="l">
-              <a:buNone/>
-              <a:defRPr sz="3225" b="1">
-                <a:solidFill>
-                  <a:srgbClr val="273548"/>
-                </a:solidFill>
-                <a:latin typeface="Arial"/>
-                <a:ea typeface="Arial"/>
-                <a:cs typeface="Arial"/>
-              </a:defRPr>
-            </a:pPr>
-            <a:r>
-              <a:rPr sz="3225" b="1">
-                <a:solidFill>
-                  <a:srgbClr val="273548"/>
-                </a:solidFill>
-                <a:latin typeface="Arial"/>
-                <a:ea typeface="Arial"/>
-                <a:cs typeface="Arial"/>
-              </a:rPr>
-              <a:t>3 / 243</a:t>
-            </a:r>
-          </a:p>
-        </p:txBody>
-      </p:sp>
-      <p:sp>
-        <p:nvSpPr>
-          <p:cNvPr id="19" name="">
-            <a:extLst xmlns:a="http://schemas.openxmlformats.org/drawingml/2006/main">
-              <a:ext uri="{FF2B5EF4-FFF2-40B4-BE49-F238E27FC236}">
-                <a16:creationId xmlns:a16="http://schemas.microsoft.com/office/drawing/2014/main" id="{AA1E116E-13CC-4735-B31A-B5C1846B2D22}"/>
-              </a:ext>
-            </a:extLst>
-          </p:cNvPr>
-          <p:cNvSpPr>
-            <a:spLocks xmlns:a="http://schemas.openxmlformats.org/drawingml/2006/main" noGrp="1"/>
-          </p:cNvSpPr>
-          <p:nvPr/>
-        </p:nvSpPr>
-        <p:spPr>
-          <a:xfrm xmlns:a="http://schemas.openxmlformats.org/drawingml/2006/main">
-            <a:off x="8629650" y="5619750"/>
-            <a:ext cx="2686050" cy="438150"/>
-          </a:xfrm>
-          <a:prstGeom xmlns:a="http://schemas.openxmlformats.org/drawingml/2006/main" prst="rect">
-            <a:avLst/>
-          </a:prstGeom>
-          <a:noFill xmlns:a="http://schemas.openxmlformats.org/drawingml/2006/main"/>
-          <a:ln xmlns:a="http://schemas.openxmlformats.org/drawingml/2006/main" w="0">
-            <a:noFill/>
-            <a:prstDash val="solid"/>
-          </a:ln>
-        </p:spPr>
-        <p:txBody>
-          <a:bodyPr xmlns:a="http://schemas.openxmlformats.org/drawingml/2006/main" wrap="square" lIns="0" tIns="0" rIns="0" bIns="0" anchor="t">
-            <a:normAutofit fontScale="100000"/>
-          </a:bodyPr>
-          <a:lstStyle xmlns:a="http://schemas.openxmlformats.org/drawingml/2006/main"/>
-          <a:p xmlns:a="http://schemas.openxmlformats.org/drawingml/2006/main">
-            <a:pPr algn="l">
-              <a:buNone/>
-              <a:defRPr sz="1350" b="0">
-                <a:solidFill>
-                  <a:srgbClr val="273548"/>
-                </a:solidFill>
-                <a:latin typeface="Arial"/>
-                <a:ea typeface="Arial"/>
-                <a:cs typeface="Arial"/>
-              </a:defRPr>
-            </a:pPr>
-            <a:r>
-              <a:rPr sz="1350" b="0">
-                <a:solidFill>
-                  <a:srgbClr val="273548"/>
-                </a:solidFill>
-                <a:latin typeface="Arial"/>
-                <a:ea typeface="Arial"/>
-                <a:cs typeface="Arial"/>
-              </a:rPr>
-              <a:t>pairwise cells surviving strict omnibus BH</a:t>
+                <a16:creationId xmlns:a16="http://schemas.microsoft.com/office/drawing/2014/main" id="{4346A5F2-8CC4-4151-9BDB-346D47A3096B}"/>
+              </a:ext>
+            </a:extLst>
+          </p:cNvPr>
+          <p:cNvSpPr>
+            <a:spLocks xmlns:a="http://schemas.openxmlformats.org/drawingml/2006/main" noGrp="1"/>
+          </p:cNvSpPr>
+          <p:nvPr/>
+        </p:nvSpPr>
+        <p:spPr>
+          <a:xfrm xmlns:a="http://schemas.openxmlformats.org/drawingml/2006/main">
+            <a:off x="1143000" y="6286500"/>
+            <a:ext cx="9906000" cy="171450"/>
+          </a:xfrm>
+          <a:prstGeom xmlns:a="http://schemas.openxmlformats.org/drawingml/2006/main" prst="rect">
+            <a:avLst/>
+          </a:prstGeom>
+          <a:noFill xmlns:a="http://schemas.openxmlformats.org/drawingml/2006/main"/>
+          <a:ln xmlns:a="http://schemas.openxmlformats.org/drawingml/2006/main" w="0">
+            <a:noFill/>
+            <a:prstDash val="solid"/>
+          </a:ln>
+        </p:spPr>
+        <p:txBody>
+          <a:bodyPr xmlns:a="http://schemas.openxmlformats.org/drawingml/2006/main" wrap="square" lIns="0" tIns="0" rIns="0" bIns="0" anchor="t">
+            <a:normAutofit fontScale="93750"/>
+          </a:bodyPr>
+          <a:lstStyle xmlns:a="http://schemas.openxmlformats.org/drawingml/2006/main"/>
+          <a:p xmlns:a="http://schemas.openxmlformats.org/drawingml/2006/main">
+            <a:pPr algn="ctr">
+              <a:buNone/>
+              <a:defRPr sz="1200" b="0">
+                <a:solidFill>
+                  <a:srgbClr val="667384"/>
+                </a:solidFill>
+                <a:latin typeface="Arial"/>
+                <a:ea typeface="Arial"/>
+                <a:cs typeface="Arial"/>
+              </a:defRPr>
+            </a:pPr>
+            <a:r>
+              <a:rPr sz="1200" b="0">
+                <a:solidFill>
+                  <a:srgbClr val="667384"/>
+                </a:solidFill>
+                <a:latin typeface="Arial"/>
+                <a:ea typeface="Arial"/>
+                <a:cs typeface="Arial"/>
+              </a:rPr>
+              <a:t>77/81 cells negative; strongest -0.301 at 20 prior / 20 forward; 0/81 within-state BH passes.</a:t>
             </a:r>
           </a:p>
         </p:txBody>
       </p:sp>
       <p:pic>
         <p:nvPicPr>
-          <p:cNvPr id="40" name=""/>
+          <p:cNvPr id="18" name=""/>
           <p:cNvPicPr>
             <a:picLocks xmlns:a="http://schemas.openxmlformats.org/drawingml/2006/main" noChangeAspect="1"/>
           </p:cNvPicPr>
           <p:nvPr/>
         </p:nvPicPr>
         <p:blipFill>
-          <a:blip xmlns:r="http://schemas.openxmlformats.org/officeDocument/2006/relationships" xmlns:a="http://schemas.openxmlformats.org/drawingml/2006/main" r:embed="Rc767c798367e4772"/>
+          <a:blip xmlns:r="http://schemas.openxmlformats.org/officeDocument/2006/relationships" xmlns:a="http://schemas.openxmlformats.org/drawingml/2006/main" r:embed="Rde716d7962a84bfa"/>
           <a:stretch xmlns:a="http://schemas.openxmlformats.org/drawingml/2006/main"/>
         </p:blipFill>
         <p:spPr>
           <a:xfrm xmlns:a="http://schemas.openxmlformats.org/drawingml/2006/main" flipH="0" flipV="0">
-            <a:off x="609600" y="1428750"/>
-            <a:ext cx="7143750" cy="4762500"/>
+            <a:off x="2942545" y="1352550"/>
+            <a:ext cx="6306911" cy="4905375"/>
           </a:xfrm>
           <a:prstGeom xmlns:a="http://schemas.openxmlformats.org/drawingml/2006/main" prst="rect">
             <a:avLst/>
@@ -21151,7 +21033,7 @@
     </p:spTree>
     <p:extLst>
       <p:ext uri="{BB962C8B-B14F-4D97-AF65-F5344CB8AC3E}">
-        <p14:creationId xmlns:p14="http://schemas.microsoft.com/office/powerpoint/2010/main" val="1583170704"/>
+        <p14:creationId xmlns:p14="http://schemas.microsoft.com/office/powerpoint/2010/main" val="400872380"/>
       </p:ext>
     </p:extLst>
   </p:cSld>
@@ -22711,10 +22593,10 @@
       </p:grpSpPr>
       <p:sp>
         <p:nvSpPr>
-          <p:cNvPr id="24" name="section-11">
-            <a:extLst xmlns:a="http://schemas.openxmlformats.org/drawingml/2006/main">
-              <a:ext uri="{FF2B5EF4-FFF2-40B4-BE49-F238E27FC236}">
-                <a16:creationId xmlns:a16="http://schemas.microsoft.com/office/drawing/2014/main" id="{272ED433-B59C-436C-9DFB-4D317B90A13F}"/>
+          <p:cNvPr id="20" name="section-7">
+            <a:extLst xmlns:a="http://schemas.openxmlformats.org/drawingml/2006/main">
+              <a:ext uri="{FF2B5EF4-FFF2-40B4-BE49-F238E27FC236}">
+                <a16:creationId xmlns:a16="http://schemas.microsoft.com/office/drawing/2014/main" id="{BAC8373F-594E-467B-A8F8-56439CEBE044}"/>
               </a:ext>
             </a:extLst>
           </p:cNvPr>
@@ -22770,10 +22652,10 @@
       </p:sp>
       <p:sp>
         <p:nvSpPr>
-          <p:cNvPr id="2" name="title-11">
-            <a:extLst xmlns:a="http://schemas.openxmlformats.org/drawingml/2006/main">
-              <a:ext uri="{FF2B5EF4-FFF2-40B4-BE49-F238E27FC236}">
-                <a16:creationId xmlns:a16="http://schemas.microsoft.com/office/drawing/2014/main" id="{3EC40708-7E00-432C-8ECE-907FA5705292}"/>
+          <p:cNvPr id="2" name="title-7">
+            <a:extLst xmlns:a="http://schemas.openxmlformats.org/drawingml/2006/main">
+              <a:ext uri="{FF2B5EF4-FFF2-40B4-BE49-F238E27FC236}">
+                <a16:creationId xmlns:a16="http://schemas.microsoft.com/office/drawing/2014/main" id="{7592E6E5-EA60-427F-BAB4-42C154D8CC5F}"/>
               </a:ext>
             </a:extLst>
           </p:cNvPr>
@@ -22798,7 +22680,7 @@
         </p:spPr>
         <p:txBody>
           <a:bodyPr xmlns:a="http://schemas.openxmlformats.org/drawingml/2006/main" wrap="square" lIns="0" tIns="0" rIns="0" bIns="0" anchor="t">
-            <a:normAutofit fontScale="88324"/>
+            <a:normAutofit fontScale="100000"/>
           </a:bodyPr>
           <a:lstStyle xmlns:a="http://schemas.openxmlformats.org/drawingml/2006/main"/>
           <a:p xmlns:a="http://schemas.openxmlformats.org/drawingml/2006/main">
@@ -22822,7 +22704,7 @@
                 <a:ea typeface="Arial"/>
                 <a:cs typeface="Arial"/>
               </a:rPr>
-              <a:t>ATR% changes the map—and leaves a replication candidate</a:t>
+              <a:t>HIGH and MEDIUM contain direct state differences</a:t>
             </a:r>
           </a:p>
         </p:txBody>
@@ -22832,7 +22714,7 @@
           <p:cNvPr id="3" name="">
             <a:extLst xmlns:a="http://schemas.openxmlformats.org/drawingml/2006/main">
               <a:ext uri="{FF2B5EF4-FFF2-40B4-BE49-F238E27FC236}">
-                <a16:creationId xmlns:a16="http://schemas.microsoft.com/office/drawing/2014/main" id="{D5CA0FCE-75E8-41EF-A76A-23E9E2120C6A}"/>
+                <a16:creationId xmlns:a16="http://schemas.microsoft.com/office/drawing/2014/main" id="{C852E1AC-5CE8-4847-87B1-81C28A4EFEDE}"/>
               </a:ext>
             </a:extLst>
           </p:cNvPr>
@@ -22862,10 +22744,10 @@
       </p:sp>
       <p:sp>
         <p:nvSpPr>
-          <p:cNvPr id="4" name="footer-left-11">
-            <a:extLst xmlns:a="http://schemas.openxmlformats.org/drawingml/2006/main">
-              <a:ext uri="{FF2B5EF4-FFF2-40B4-BE49-F238E27FC236}">
-                <a16:creationId xmlns:a16="http://schemas.microsoft.com/office/drawing/2014/main" id="{700DA765-80E0-4197-8700-00D867B86FA2}"/>
+          <p:cNvPr id="4" name="footer-left-7">
+            <a:extLst xmlns:a="http://schemas.openxmlformats.org/drawingml/2006/main">
+              <a:ext uri="{FF2B5EF4-FFF2-40B4-BE49-F238E27FC236}">
+                <a16:creationId xmlns:a16="http://schemas.microsoft.com/office/drawing/2014/main" id="{4896B590-20BC-4B46-9282-D9F5A22A0CC5}"/>
               </a:ext>
             </a:extLst>
           </p:cNvPr>
@@ -22921,10 +22803,10 @@
       </p:sp>
       <p:sp>
         <p:nvSpPr>
-          <p:cNvPr id="5" name="footer-number-11">
-            <a:extLst xmlns:a="http://schemas.openxmlformats.org/drawingml/2006/main">
-              <a:ext uri="{FF2B5EF4-FFF2-40B4-BE49-F238E27FC236}">
-                <a16:creationId xmlns:a16="http://schemas.microsoft.com/office/drawing/2014/main" id="{83896276-4112-4532-AF7C-776C67C58B77}"/>
+          <p:cNvPr id="5" name="footer-number-7">
+            <a:extLst xmlns:a="http://schemas.openxmlformats.org/drawingml/2006/main">
+              <a:ext uri="{FF2B5EF4-FFF2-40B4-BE49-F238E27FC236}">
+                <a16:creationId xmlns:a16="http://schemas.microsoft.com/office/drawing/2014/main" id="{1503EFAF-F487-4981-AFDC-23F1B41A7207}"/>
               </a:ext>
             </a:extLst>
           </p:cNvPr>
@@ -22974,6 +22856,911 @@
                 <a:cs typeface="Arial"/>
               </a:rPr>
               <a:t>30</a:t>
+            </a:r>
+          </a:p>
+        </p:txBody>
+      </p:sp>
+      <p:sp>
+        <p:nvSpPr>
+          <p:cNvPr id="6" name="">
+            <a:extLst xmlns:a="http://schemas.openxmlformats.org/drawingml/2006/main">
+              <a:ext uri="{FF2B5EF4-FFF2-40B4-BE49-F238E27FC236}">
+                <a16:creationId xmlns:a16="http://schemas.microsoft.com/office/drawing/2014/main" id="{4AA770DD-55E6-42DB-942A-6938E642B1A0}"/>
+              </a:ext>
+            </a:extLst>
+          </p:cNvPr>
+          <p:cNvSpPr>
+            <a:spLocks xmlns:a="http://schemas.openxmlformats.org/drawingml/2006/main" noGrp="1"/>
+          </p:cNvSpPr>
+          <p:nvPr/>
+        </p:nvSpPr>
+        <p:spPr>
+          <a:xfrm xmlns:a="http://schemas.openxmlformats.org/drawingml/2006/main">
+            <a:off x="342900" y="1428750"/>
+            <a:ext cx="7677150" cy="4762500"/>
+          </a:xfrm>
+          <a:prstGeom xmlns:a="http://schemas.openxmlformats.org/drawingml/2006/main" prst="rect">
+            <a:avLst/>
+          </a:prstGeom>
+          <a:solidFill xmlns:a="http://schemas.openxmlformats.org/drawingml/2006/main">
+            <a:srgbClr val="FFFFFF"/>
+          </a:solidFill>
+          <a:ln xmlns:a="http://schemas.openxmlformats.org/drawingml/2006/main" w="9525">
+            <a:solidFill>
+              <a:srgbClr val="B8BCC4"/>
+            </a:solidFill>
+            <a:prstDash val="solid"/>
+          </a:ln>
+        </p:spPr>
+      </p:sp>
+      <p:sp>
+        <p:nvSpPr>
+          <p:cNvPr id="8" name="">
+            <a:extLst xmlns:a="http://schemas.openxmlformats.org/drawingml/2006/main">
+              <a:ext uri="{FF2B5EF4-FFF2-40B4-BE49-F238E27FC236}">
+                <a16:creationId xmlns:a16="http://schemas.microsoft.com/office/drawing/2014/main" id="{925D1653-1738-47C8-BFA1-9C9390285CC4}"/>
+              </a:ext>
+            </a:extLst>
+          </p:cNvPr>
+          <p:cNvSpPr>
+            <a:spLocks xmlns:a="http://schemas.openxmlformats.org/drawingml/2006/main" noGrp="1"/>
+          </p:cNvSpPr>
+          <p:nvPr/>
+        </p:nvSpPr>
+        <p:spPr>
+          <a:xfrm xmlns:a="http://schemas.openxmlformats.org/drawingml/2006/main">
+            <a:off x="8362950" y="1504950"/>
+            <a:ext cx="3143250" cy="1428750"/>
+          </a:xfrm>
+          <a:prstGeom xmlns:a="http://schemas.openxmlformats.org/drawingml/2006/main" prst="rect">
+            <a:avLst/>
+          </a:prstGeom>
+          <a:solidFill xmlns:a="http://schemas.openxmlformats.org/drawingml/2006/main">
+            <a:srgbClr val="EDEDED"/>
+          </a:solidFill>
+          <a:ln xmlns:a="http://schemas.openxmlformats.org/drawingml/2006/main" w="0">
+            <a:solidFill>
+              <a:srgbClr val="EDEDED"/>
+            </a:solidFill>
+            <a:prstDash val="solid"/>
+          </a:ln>
+        </p:spPr>
+      </p:sp>
+      <p:sp>
+        <p:nvSpPr>
+          <p:cNvPr id="9" name="">
+            <a:extLst xmlns:a="http://schemas.openxmlformats.org/drawingml/2006/main">
+              <a:ext uri="{FF2B5EF4-FFF2-40B4-BE49-F238E27FC236}">
+                <a16:creationId xmlns:a16="http://schemas.microsoft.com/office/drawing/2014/main" id="{AD911094-04B5-4E98-9749-4F832E6A7030}"/>
+              </a:ext>
+            </a:extLst>
+          </p:cNvPr>
+          <p:cNvSpPr>
+            <a:spLocks xmlns:a="http://schemas.openxmlformats.org/drawingml/2006/main" noGrp="1"/>
+          </p:cNvSpPr>
+          <p:nvPr/>
+        </p:nvSpPr>
+        <p:spPr>
+          <a:xfrm xmlns:a="http://schemas.openxmlformats.org/drawingml/2006/main">
+            <a:off x="8362950" y="1504950"/>
+            <a:ext cx="76200" cy="1428750"/>
+          </a:xfrm>
+          <a:prstGeom xmlns:a="http://schemas.openxmlformats.org/drawingml/2006/main" prst="rect">
+            <a:avLst/>
+          </a:prstGeom>
+          <a:solidFill xmlns:a="http://schemas.openxmlformats.org/drawingml/2006/main">
+            <a:srgbClr val="E45756"/>
+          </a:solidFill>
+          <a:ln xmlns:a="http://schemas.openxmlformats.org/drawingml/2006/main" w="0">
+            <a:solidFill>
+              <a:srgbClr val="E45756"/>
+            </a:solidFill>
+            <a:prstDash val="solid"/>
+          </a:ln>
+        </p:spPr>
+      </p:sp>
+      <p:sp>
+        <p:nvSpPr>
+          <p:cNvPr id="10" name="">
+            <a:extLst xmlns:a="http://schemas.openxmlformats.org/drawingml/2006/main">
+              <a:ext uri="{FF2B5EF4-FFF2-40B4-BE49-F238E27FC236}">
+                <a16:creationId xmlns:a16="http://schemas.microsoft.com/office/drawing/2014/main" id="{8259A327-4374-4B4E-A3BA-F8E016498564}"/>
+              </a:ext>
+            </a:extLst>
+          </p:cNvPr>
+          <p:cNvSpPr>
+            <a:spLocks xmlns:a="http://schemas.openxmlformats.org/drawingml/2006/main" noGrp="1"/>
+          </p:cNvSpPr>
+          <p:nvPr/>
+        </p:nvSpPr>
+        <p:spPr>
+          <a:xfrm xmlns:a="http://schemas.openxmlformats.org/drawingml/2006/main">
+            <a:off x="8629650" y="1676400"/>
+            <a:ext cx="2686050" cy="590550"/>
+          </a:xfrm>
+          <a:prstGeom xmlns:a="http://schemas.openxmlformats.org/drawingml/2006/main" prst="rect">
+            <a:avLst/>
+          </a:prstGeom>
+          <a:noFill xmlns:a="http://schemas.openxmlformats.org/drawingml/2006/main"/>
+          <a:ln xmlns:a="http://schemas.openxmlformats.org/drawingml/2006/main" w="0">
+            <a:noFill/>
+            <a:prstDash val="solid"/>
+          </a:ln>
+        </p:spPr>
+        <p:txBody>
+          <a:bodyPr xmlns:a="http://schemas.openxmlformats.org/drawingml/2006/main" wrap="square" lIns="0" tIns="0" rIns="0" bIns="0" anchor="t">
+            <a:normAutofit fontScale="100000"/>
+          </a:bodyPr>
+          <a:lstStyle xmlns:a="http://schemas.openxmlformats.org/drawingml/2006/main"/>
+          <a:p xmlns:a="http://schemas.openxmlformats.org/drawingml/2006/main">
+            <a:pPr algn="l">
+              <a:buNone/>
+              <a:defRPr sz="3225" b="1">
+                <a:solidFill>
+                  <a:srgbClr val="E45756"/>
+                </a:solidFill>
+                <a:latin typeface="Arial"/>
+                <a:ea typeface="Arial"/>
+                <a:cs typeface="Arial"/>
+              </a:defRPr>
+            </a:pPr>
+            <a:r>
+              <a:rPr sz="3225" b="1">
+                <a:solidFill>
+                  <a:srgbClr val="E45756"/>
+                </a:solidFill>
+                <a:latin typeface="Arial"/>
+                <a:ea typeface="Arial"/>
+                <a:cs typeface="Arial"/>
+              </a:rPr>
+              <a:t>-0.548</a:t>
+            </a:r>
+          </a:p>
+        </p:txBody>
+      </p:sp>
+      <p:sp>
+        <p:nvSpPr>
+          <p:cNvPr id="11" name="">
+            <a:extLst xmlns:a="http://schemas.openxmlformats.org/drawingml/2006/main">
+              <a:ext uri="{FF2B5EF4-FFF2-40B4-BE49-F238E27FC236}">
+                <a16:creationId xmlns:a16="http://schemas.microsoft.com/office/drawing/2014/main" id="{BE341AE3-547D-4111-ADFF-14E5545F2DBF}"/>
+              </a:ext>
+            </a:extLst>
+          </p:cNvPr>
+          <p:cNvSpPr>
+            <a:spLocks xmlns:a="http://schemas.openxmlformats.org/drawingml/2006/main" noGrp="1"/>
+          </p:cNvSpPr>
+          <p:nvPr/>
+        </p:nvSpPr>
+        <p:spPr>
+          <a:xfrm xmlns:a="http://schemas.openxmlformats.org/drawingml/2006/main">
+            <a:off x="8629650" y="2343150"/>
+            <a:ext cx="2686050" cy="438150"/>
+          </a:xfrm>
+          <a:prstGeom xmlns:a="http://schemas.openxmlformats.org/drawingml/2006/main" prst="rect">
+            <a:avLst/>
+          </a:prstGeom>
+          <a:noFill xmlns:a="http://schemas.openxmlformats.org/drawingml/2006/main"/>
+          <a:ln xmlns:a="http://schemas.openxmlformats.org/drawingml/2006/main" w="0">
+            <a:noFill/>
+            <a:prstDash val="solid"/>
+          </a:ln>
+        </p:spPr>
+        <p:txBody>
+          <a:bodyPr xmlns:a="http://schemas.openxmlformats.org/drawingml/2006/main" wrap="square" lIns="0" tIns="0" rIns="0" bIns="0" anchor="t">
+            <a:normAutofit fontScale="100000"/>
+          </a:bodyPr>
+          <a:lstStyle xmlns:a="http://schemas.openxmlformats.org/drawingml/2006/main"/>
+          <a:p xmlns:a="http://schemas.openxmlformats.org/drawingml/2006/main">
+            <a:pPr algn="l">
+              <a:buNone/>
+              <a:defRPr sz="1350" b="0">
+                <a:solidFill>
+                  <a:srgbClr val="273548"/>
+                </a:solidFill>
+                <a:latin typeface="Arial"/>
+                <a:ea typeface="Arial"/>
+                <a:cs typeface="Arial"/>
+              </a:defRPr>
+            </a:pPr>
+            <a:r>
+              <a:rPr sz="1350" b="0">
+                <a:solidFill>
+                  <a:srgbClr val="273548"/>
+                </a:solidFill>
+                <a:latin typeface="Arial"/>
+                <a:ea typeface="Arial"/>
+                <a:cs typeface="Arial"/>
+              </a:rPr>
+              <a:t>largest correlation change: 25 prior / 15 forward</a:t>
+            </a:r>
+          </a:p>
+        </p:txBody>
+      </p:sp>
+      <p:sp>
+        <p:nvSpPr>
+          <p:cNvPr id="12" name="">
+            <a:extLst xmlns:a="http://schemas.openxmlformats.org/drawingml/2006/main">
+              <a:ext uri="{FF2B5EF4-FFF2-40B4-BE49-F238E27FC236}">
+                <a16:creationId xmlns:a16="http://schemas.microsoft.com/office/drawing/2014/main" id="{627B1C2D-BD18-4B6C-8DC8-10694F2FD365}"/>
+              </a:ext>
+            </a:extLst>
+          </p:cNvPr>
+          <p:cNvSpPr>
+            <a:spLocks xmlns:a="http://schemas.openxmlformats.org/drawingml/2006/main" noGrp="1"/>
+          </p:cNvSpPr>
+          <p:nvPr/>
+        </p:nvSpPr>
+        <p:spPr>
+          <a:xfrm xmlns:a="http://schemas.openxmlformats.org/drawingml/2006/main">
+            <a:off x="8362950" y="3143250"/>
+            <a:ext cx="3143250" cy="1428750"/>
+          </a:xfrm>
+          <a:prstGeom xmlns:a="http://schemas.openxmlformats.org/drawingml/2006/main" prst="rect">
+            <a:avLst/>
+          </a:prstGeom>
+          <a:solidFill xmlns:a="http://schemas.openxmlformats.org/drawingml/2006/main">
+            <a:srgbClr val="EDEDED"/>
+          </a:solidFill>
+          <a:ln xmlns:a="http://schemas.openxmlformats.org/drawingml/2006/main" w="0">
+            <a:solidFill>
+              <a:srgbClr val="EDEDED"/>
+            </a:solidFill>
+            <a:prstDash val="solid"/>
+          </a:ln>
+        </p:spPr>
+      </p:sp>
+      <p:sp>
+        <p:nvSpPr>
+          <p:cNvPr id="13" name="">
+            <a:extLst xmlns:a="http://schemas.openxmlformats.org/drawingml/2006/main">
+              <a:ext uri="{FF2B5EF4-FFF2-40B4-BE49-F238E27FC236}">
+                <a16:creationId xmlns:a16="http://schemas.microsoft.com/office/drawing/2014/main" id="{1A4050CC-5568-4F8A-B026-EC7B8ABEFB7A}"/>
+              </a:ext>
+            </a:extLst>
+          </p:cNvPr>
+          <p:cNvSpPr>
+            <a:spLocks xmlns:a="http://schemas.openxmlformats.org/drawingml/2006/main" noGrp="1"/>
+          </p:cNvSpPr>
+          <p:nvPr/>
+        </p:nvSpPr>
+        <p:spPr>
+          <a:xfrm xmlns:a="http://schemas.openxmlformats.org/drawingml/2006/main">
+            <a:off x="8362950" y="3143250"/>
+            <a:ext cx="76200" cy="1428750"/>
+          </a:xfrm>
+          <a:prstGeom xmlns:a="http://schemas.openxmlformats.org/drawingml/2006/main" prst="rect">
+            <a:avLst/>
+          </a:prstGeom>
+          <a:solidFill xmlns:a="http://schemas.openxmlformats.org/drawingml/2006/main">
+            <a:srgbClr val="3D8DFF"/>
+          </a:solidFill>
+          <a:ln xmlns:a="http://schemas.openxmlformats.org/drawingml/2006/main" w="0">
+            <a:solidFill>
+              <a:srgbClr val="3D8DFF"/>
+            </a:solidFill>
+            <a:prstDash val="solid"/>
+          </a:ln>
+        </p:spPr>
+      </p:sp>
+      <p:sp>
+        <p:nvSpPr>
+          <p:cNvPr id="14" name="">
+            <a:extLst xmlns:a="http://schemas.openxmlformats.org/drawingml/2006/main">
+              <a:ext uri="{FF2B5EF4-FFF2-40B4-BE49-F238E27FC236}">
+                <a16:creationId xmlns:a16="http://schemas.microsoft.com/office/drawing/2014/main" id="{502FF9D4-D051-476B-B68A-15DCA6B44FE9}"/>
+              </a:ext>
+            </a:extLst>
+          </p:cNvPr>
+          <p:cNvSpPr>
+            <a:spLocks xmlns:a="http://schemas.openxmlformats.org/drawingml/2006/main" noGrp="1"/>
+          </p:cNvSpPr>
+          <p:nvPr/>
+        </p:nvSpPr>
+        <p:spPr>
+          <a:xfrm xmlns:a="http://schemas.openxmlformats.org/drawingml/2006/main">
+            <a:off x="8629650" y="3314700"/>
+            <a:ext cx="2686050" cy="590550"/>
+          </a:xfrm>
+          <a:prstGeom xmlns:a="http://schemas.openxmlformats.org/drawingml/2006/main" prst="rect">
+            <a:avLst/>
+          </a:prstGeom>
+          <a:noFill xmlns:a="http://schemas.openxmlformats.org/drawingml/2006/main"/>
+          <a:ln xmlns:a="http://schemas.openxmlformats.org/drawingml/2006/main" w="0">
+            <a:noFill/>
+            <a:prstDash val="solid"/>
+          </a:ln>
+        </p:spPr>
+        <p:txBody>
+          <a:bodyPr xmlns:a="http://schemas.openxmlformats.org/drawingml/2006/main" wrap="square" lIns="0" tIns="0" rIns="0" bIns="0" anchor="t">
+            <a:normAutofit fontScale="100000"/>
+          </a:bodyPr>
+          <a:lstStyle xmlns:a="http://schemas.openxmlformats.org/drawingml/2006/main"/>
+          <a:p xmlns:a="http://schemas.openxmlformats.org/drawingml/2006/main">
+            <a:pPr algn="l">
+              <a:buNone/>
+              <a:defRPr sz="3225" b="1">
+                <a:solidFill>
+                  <a:srgbClr val="3D8DFF"/>
+                </a:solidFill>
+                <a:latin typeface="Arial"/>
+                <a:ea typeface="Arial"/>
+                <a:cs typeface="Arial"/>
+              </a:defRPr>
+            </a:pPr>
+            <a:r>
+              <a:rPr sz="3225" b="1">
+                <a:solidFill>
+                  <a:srgbClr val="3D8DFF"/>
+                </a:solidFill>
+                <a:latin typeface="Arial"/>
+                <a:ea typeface="Arial"/>
+                <a:cs typeface="Arial"/>
+              </a:rPr>
+              <a:t>q = 0.038</a:t>
+            </a:r>
+          </a:p>
+        </p:txBody>
+      </p:sp>
+      <p:sp>
+        <p:nvSpPr>
+          <p:cNvPr id="15" name="">
+            <a:extLst xmlns:a="http://schemas.openxmlformats.org/drawingml/2006/main">
+              <a:ext uri="{FF2B5EF4-FFF2-40B4-BE49-F238E27FC236}">
+                <a16:creationId xmlns:a16="http://schemas.microsoft.com/office/drawing/2014/main" id="{03DFBB46-08D6-4497-AA7C-C2049757E9DE}"/>
+              </a:ext>
+            </a:extLst>
+          </p:cNvPr>
+          <p:cNvSpPr>
+            <a:spLocks xmlns:a="http://schemas.openxmlformats.org/drawingml/2006/main" noGrp="1"/>
+          </p:cNvSpPr>
+          <p:nvPr/>
+        </p:nvSpPr>
+        <p:spPr>
+          <a:xfrm xmlns:a="http://schemas.openxmlformats.org/drawingml/2006/main">
+            <a:off x="8629650" y="3981450"/>
+            <a:ext cx="2686050" cy="438150"/>
+          </a:xfrm>
+          <a:prstGeom xmlns:a="http://schemas.openxmlformats.org/drawingml/2006/main" prst="rect">
+            <a:avLst/>
+          </a:prstGeom>
+          <a:noFill xmlns:a="http://schemas.openxmlformats.org/drawingml/2006/main"/>
+          <a:ln xmlns:a="http://schemas.openxmlformats.org/drawingml/2006/main" w="0">
+            <a:noFill/>
+            <a:prstDash val="solid"/>
+          </a:ln>
+        </p:spPr>
+        <p:txBody>
+          <a:bodyPr xmlns:a="http://schemas.openxmlformats.org/drawingml/2006/main" wrap="square" lIns="0" tIns="0" rIns="0" bIns="0" anchor="t">
+            <a:normAutofit fontScale="100000"/>
+          </a:bodyPr>
+          <a:lstStyle xmlns:a="http://schemas.openxmlformats.org/drawingml/2006/main"/>
+          <a:p xmlns:a="http://schemas.openxmlformats.org/drawingml/2006/main">
+            <a:pPr algn="l">
+              <a:buNone/>
+              <a:defRPr sz="1350" b="0">
+                <a:solidFill>
+                  <a:srgbClr val="273548"/>
+                </a:solidFill>
+                <a:latin typeface="Arial"/>
+                <a:ea typeface="Arial"/>
+                <a:cs typeface="Arial"/>
+              </a:defRPr>
+            </a:pPr>
+            <a:r>
+              <a:rPr sz="1350" b="0">
+                <a:solidFill>
+                  <a:srgbClr val="273548"/>
+                </a:solidFill>
+                <a:latin typeface="Arial"/>
+                <a:ea typeface="Arial"/>
+                <a:cs typeface="Arial"/>
+              </a:rPr>
+              <a:t>within HIGH-minus-MEDIUM family</a:t>
+            </a:r>
+          </a:p>
+        </p:txBody>
+      </p:sp>
+      <p:sp>
+        <p:nvSpPr>
+          <p:cNvPr id="16" name="">
+            <a:extLst xmlns:a="http://schemas.openxmlformats.org/drawingml/2006/main">
+              <a:ext uri="{FF2B5EF4-FFF2-40B4-BE49-F238E27FC236}">
+                <a16:creationId xmlns:a16="http://schemas.microsoft.com/office/drawing/2014/main" id="{509D61CC-6E5E-49EC-A5F6-E861E8561441}"/>
+              </a:ext>
+            </a:extLst>
+          </p:cNvPr>
+          <p:cNvSpPr>
+            <a:spLocks xmlns:a="http://schemas.openxmlformats.org/drawingml/2006/main" noGrp="1"/>
+          </p:cNvSpPr>
+          <p:nvPr/>
+        </p:nvSpPr>
+        <p:spPr>
+          <a:xfrm xmlns:a="http://schemas.openxmlformats.org/drawingml/2006/main">
+            <a:off x="8362950" y="4781550"/>
+            <a:ext cx="3143250" cy="1428750"/>
+          </a:xfrm>
+          <a:prstGeom xmlns:a="http://schemas.openxmlformats.org/drawingml/2006/main" prst="rect">
+            <a:avLst/>
+          </a:prstGeom>
+          <a:solidFill xmlns:a="http://schemas.openxmlformats.org/drawingml/2006/main">
+            <a:srgbClr val="EDEDED"/>
+          </a:solidFill>
+          <a:ln xmlns:a="http://schemas.openxmlformats.org/drawingml/2006/main" w="0">
+            <a:solidFill>
+              <a:srgbClr val="EDEDED"/>
+            </a:solidFill>
+            <a:prstDash val="solid"/>
+          </a:ln>
+        </p:spPr>
+      </p:sp>
+      <p:sp>
+        <p:nvSpPr>
+          <p:cNvPr id="17" name="">
+            <a:extLst xmlns:a="http://schemas.openxmlformats.org/drawingml/2006/main">
+              <a:ext uri="{FF2B5EF4-FFF2-40B4-BE49-F238E27FC236}">
+                <a16:creationId xmlns:a16="http://schemas.microsoft.com/office/drawing/2014/main" id="{A935608E-4DDE-41BA-8DF2-831CF419565B}"/>
+              </a:ext>
+            </a:extLst>
+          </p:cNvPr>
+          <p:cNvSpPr>
+            <a:spLocks xmlns:a="http://schemas.openxmlformats.org/drawingml/2006/main" noGrp="1"/>
+          </p:cNvSpPr>
+          <p:nvPr/>
+        </p:nvSpPr>
+        <p:spPr>
+          <a:xfrm xmlns:a="http://schemas.openxmlformats.org/drawingml/2006/main">
+            <a:off x="8362950" y="4781550"/>
+            <a:ext cx="76200" cy="1428750"/>
+          </a:xfrm>
+          <a:prstGeom xmlns:a="http://schemas.openxmlformats.org/drawingml/2006/main" prst="rect">
+            <a:avLst/>
+          </a:prstGeom>
+          <a:solidFill xmlns:a="http://schemas.openxmlformats.org/drawingml/2006/main">
+            <a:srgbClr val="273548"/>
+          </a:solidFill>
+          <a:ln xmlns:a="http://schemas.openxmlformats.org/drawingml/2006/main" w="0">
+            <a:solidFill>
+              <a:srgbClr val="273548"/>
+            </a:solidFill>
+            <a:prstDash val="solid"/>
+          </a:ln>
+        </p:spPr>
+      </p:sp>
+      <p:sp>
+        <p:nvSpPr>
+          <p:cNvPr id="18" name="">
+            <a:extLst xmlns:a="http://schemas.openxmlformats.org/drawingml/2006/main">
+              <a:ext uri="{FF2B5EF4-FFF2-40B4-BE49-F238E27FC236}">
+                <a16:creationId xmlns:a16="http://schemas.microsoft.com/office/drawing/2014/main" id="{088A976D-39D1-4C6C-803F-0D3F8BAE4A28}"/>
+              </a:ext>
+            </a:extLst>
+          </p:cNvPr>
+          <p:cNvSpPr>
+            <a:spLocks xmlns:a="http://schemas.openxmlformats.org/drawingml/2006/main" noGrp="1"/>
+          </p:cNvSpPr>
+          <p:nvPr/>
+        </p:nvSpPr>
+        <p:spPr>
+          <a:xfrm xmlns:a="http://schemas.openxmlformats.org/drawingml/2006/main">
+            <a:off x="8629650" y="4953000"/>
+            <a:ext cx="2686050" cy="590550"/>
+          </a:xfrm>
+          <a:prstGeom xmlns:a="http://schemas.openxmlformats.org/drawingml/2006/main" prst="rect">
+            <a:avLst/>
+          </a:prstGeom>
+          <a:noFill xmlns:a="http://schemas.openxmlformats.org/drawingml/2006/main"/>
+          <a:ln xmlns:a="http://schemas.openxmlformats.org/drawingml/2006/main" w="0">
+            <a:noFill/>
+            <a:prstDash val="solid"/>
+          </a:ln>
+        </p:spPr>
+        <p:txBody>
+          <a:bodyPr xmlns:a="http://schemas.openxmlformats.org/drawingml/2006/main" wrap="square" lIns="0" tIns="0" rIns="0" bIns="0" anchor="t">
+            <a:normAutofit fontScale="100000"/>
+          </a:bodyPr>
+          <a:lstStyle xmlns:a="http://schemas.openxmlformats.org/drawingml/2006/main"/>
+          <a:p xmlns:a="http://schemas.openxmlformats.org/drawingml/2006/main">
+            <a:pPr algn="l">
+              <a:buNone/>
+              <a:defRPr sz="3225" b="1">
+                <a:solidFill>
+                  <a:srgbClr val="273548"/>
+                </a:solidFill>
+                <a:latin typeface="Arial"/>
+                <a:ea typeface="Arial"/>
+                <a:cs typeface="Arial"/>
+              </a:defRPr>
+            </a:pPr>
+            <a:r>
+              <a:rPr sz="3225" b="1">
+                <a:solidFill>
+                  <a:srgbClr val="273548"/>
+                </a:solidFill>
+                <a:latin typeface="Arial"/>
+                <a:ea typeface="Arial"/>
+                <a:cs typeface="Arial"/>
+              </a:rPr>
+              <a:t>3 / 243</a:t>
+            </a:r>
+          </a:p>
+        </p:txBody>
+      </p:sp>
+      <p:sp>
+        <p:nvSpPr>
+          <p:cNvPr id="19" name="">
+            <a:extLst xmlns:a="http://schemas.openxmlformats.org/drawingml/2006/main">
+              <a:ext uri="{FF2B5EF4-FFF2-40B4-BE49-F238E27FC236}">
+                <a16:creationId xmlns:a16="http://schemas.microsoft.com/office/drawing/2014/main" id="{AA1E116E-13CC-4735-B31A-B5C1846B2D22}"/>
+              </a:ext>
+            </a:extLst>
+          </p:cNvPr>
+          <p:cNvSpPr>
+            <a:spLocks xmlns:a="http://schemas.openxmlformats.org/drawingml/2006/main" noGrp="1"/>
+          </p:cNvSpPr>
+          <p:nvPr/>
+        </p:nvSpPr>
+        <p:spPr>
+          <a:xfrm xmlns:a="http://schemas.openxmlformats.org/drawingml/2006/main">
+            <a:off x="8629650" y="5619750"/>
+            <a:ext cx="2686050" cy="438150"/>
+          </a:xfrm>
+          <a:prstGeom xmlns:a="http://schemas.openxmlformats.org/drawingml/2006/main" prst="rect">
+            <a:avLst/>
+          </a:prstGeom>
+          <a:noFill xmlns:a="http://schemas.openxmlformats.org/drawingml/2006/main"/>
+          <a:ln xmlns:a="http://schemas.openxmlformats.org/drawingml/2006/main" w="0">
+            <a:noFill/>
+            <a:prstDash val="solid"/>
+          </a:ln>
+        </p:spPr>
+        <p:txBody>
+          <a:bodyPr xmlns:a="http://schemas.openxmlformats.org/drawingml/2006/main" wrap="square" lIns="0" tIns="0" rIns="0" bIns="0" anchor="t">
+            <a:normAutofit fontScale="100000"/>
+          </a:bodyPr>
+          <a:lstStyle xmlns:a="http://schemas.openxmlformats.org/drawingml/2006/main"/>
+          <a:p xmlns:a="http://schemas.openxmlformats.org/drawingml/2006/main">
+            <a:pPr algn="l">
+              <a:buNone/>
+              <a:defRPr sz="1350" b="0">
+                <a:solidFill>
+                  <a:srgbClr val="273548"/>
+                </a:solidFill>
+                <a:latin typeface="Arial"/>
+                <a:ea typeface="Arial"/>
+                <a:cs typeface="Arial"/>
+              </a:defRPr>
+            </a:pPr>
+            <a:r>
+              <a:rPr sz="1350" b="0">
+                <a:solidFill>
+                  <a:srgbClr val="273548"/>
+                </a:solidFill>
+                <a:latin typeface="Arial"/>
+                <a:ea typeface="Arial"/>
+                <a:cs typeface="Arial"/>
+              </a:rPr>
+              <a:t>pairwise cells surviving strict omnibus BH</a:t>
+            </a:r>
+          </a:p>
+        </p:txBody>
+      </p:sp>
+      <p:pic>
+        <p:nvPicPr>
+          <p:cNvPr id="40" name=""/>
+          <p:cNvPicPr>
+            <a:picLocks xmlns:a="http://schemas.openxmlformats.org/drawingml/2006/main" noChangeAspect="1"/>
+          </p:cNvPicPr>
+          <p:nvPr/>
+        </p:nvPicPr>
+        <p:blipFill>
+          <a:blip xmlns:r="http://schemas.openxmlformats.org/officeDocument/2006/relationships" xmlns:a="http://schemas.openxmlformats.org/drawingml/2006/main" r:embed="R0cba53e679374f80"/>
+          <a:stretch xmlns:a="http://schemas.openxmlformats.org/drawingml/2006/main"/>
+        </p:blipFill>
+        <p:spPr>
+          <a:xfrm xmlns:a="http://schemas.openxmlformats.org/drawingml/2006/main" flipH="0" flipV="0">
+            <a:off x="609600" y="1428750"/>
+            <a:ext cx="7143750" cy="4762500"/>
+          </a:xfrm>
+          <a:prstGeom xmlns:a="http://schemas.openxmlformats.org/drawingml/2006/main" prst="rect">
+            <a:avLst/>
+          </a:prstGeom>
+        </p:spPr>
+      </p:pic>
+    </p:spTree>
+    <p:extLst>
+      <p:ext uri="{BB962C8B-B14F-4D97-AF65-F5344CB8AC3E}">
+        <p14:creationId xmlns:p14="http://schemas.microsoft.com/office/powerpoint/2010/main" val="1583170704"/>
+      </p:ext>
+    </p:extLst>
+  </p:cSld>
+</p:sld>
+</file>
+
+<file path=ppt/slides/slide31.xml><?xml version="1.0" encoding="utf-8"?>
+<p:sld xmlns:p="http://schemas.openxmlformats.org/presentationml/2006/main">
+  <p:cSld>
+    <p:bg>
+      <p:bgPr>
+        <a:solidFill xmlns:a="http://schemas.openxmlformats.org/drawingml/2006/main">
+          <a:srgbClr val="FFFFFF"/>
+        </a:solidFill>
+      </p:bgPr>
+    </p:bg>
+    <p:spTree>
+      <p:nvGrpSpPr>
+        <p:cNvPr id="1" name=""/>
+        <p:cNvGrpSpPr/>
+        <p:nvPr/>
+      </p:nvGrpSpPr>
+      <p:grpSpPr>
+        <a:xfrm xmlns:a="http://schemas.openxmlformats.org/drawingml/2006/main"/>
+      </p:grpSpPr>
+      <p:sp>
+        <p:nvSpPr>
+          <p:cNvPr id="24" name="section-11">
+            <a:extLst xmlns:a="http://schemas.openxmlformats.org/drawingml/2006/main">
+              <a:ext uri="{FF2B5EF4-FFF2-40B4-BE49-F238E27FC236}">
+                <a16:creationId xmlns:a16="http://schemas.microsoft.com/office/drawing/2014/main" id="{272ED433-B59C-436C-9DFB-4D317B90A13F}"/>
+              </a:ext>
+            </a:extLst>
+          </p:cNvPr>
+          <p:cNvSpPr>
+            <a:spLocks xmlns:a="http://schemas.openxmlformats.org/drawingml/2006/main" noGrp="1"/>
+          </p:cNvSpPr>
+          <p:nvPr/>
+        </p:nvSpPr>
+        <p:spPr>
+          <a:xfrm xmlns:a="http://schemas.openxmlformats.org/drawingml/2006/main">
+            <a:off x="457200" y="228600"/>
+            <a:ext cx="4191000" cy="228600"/>
+          </a:xfrm>
+          <a:prstGeom xmlns:a="http://schemas.openxmlformats.org/drawingml/2006/main" prst="rect">
+            <a:avLst/>
+          </a:prstGeom>
+          <a:noFill xmlns:a="http://schemas.openxmlformats.org/drawingml/2006/main"/>
+          <a:ln xmlns:a="http://schemas.openxmlformats.org/drawingml/2006/main" w="0">
+            <a:noFill/>
+            <a:prstDash val="solid"/>
+          </a:ln>
+        </p:spPr>
+        <p:txBody>
+          <a:bodyPr xmlns:a="http://schemas.openxmlformats.org/drawingml/2006/main" wrap="square" lIns="0" tIns="0" rIns="0" bIns="0" anchor="t">
+            <a:normAutofit fontScale="100000"/>
+          </a:bodyPr>
+          <a:lstStyle xmlns:a="http://schemas.openxmlformats.org/drawingml/2006/main"/>
+          <a:p xmlns:a="http://schemas.openxmlformats.org/drawingml/2006/main">
+            <a:pPr algn="l">
+              <a:buNone/>
+              <a:defRPr sz="1200" b="1">
+                <a:solidFill>
+                  <a:srgbClr val="667384"/>
+                </a:solidFill>
+                <a:latin typeface="Arial"/>
+                <a:ea typeface="Arial"/>
+                <a:cs typeface="Arial"/>
+              </a:defRPr>
+            </a:pPr>
+            <a:r>
+              <a:rPr sz="1200" b="1">
+                <a:solidFill>
+                  <a:srgbClr val="667384"/>
+                </a:solidFill>
+                <a:latin typeface="Arial"/>
+                <a:ea typeface="Arial"/>
+                <a:cs typeface="Arial"/>
+              </a:rPr>
+              <a:t>TSLA DESCRIPTIVE MICROSCOPE</a:t>
+            </a:r>
+          </a:p>
+        </p:txBody>
+      </p:sp>
+      <p:sp>
+        <p:nvSpPr>
+          <p:cNvPr id="2" name="title-11">
+            <a:extLst xmlns:a="http://schemas.openxmlformats.org/drawingml/2006/main">
+              <a:ext uri="{FF2B5EF4-FFF2-40B4-BE49-F238E27FC236}">
+                <a16:creationId xmlns:a16="http://schemas.microsoft.com/office/drawing/2014/main" id="{3EC40708-7E00-432C-8ECE-907FA5705292}"/>
+              </a:ext>
+            </a:extLst>
+          </p:cNvPr>
+          <p:cNvSpPr>
+            <a:spLocks xmlns:a="http://schemas.openxmlformats.org/drawingml/2006/main" noGrp="1"/>
+          </p:cNvSpPr>
+          <p:nvPr/>
+        </p:nvSpPr>
+        <p:spPr>
+          <a:xfrm xmlns:a="http://schemas.openxmlformats.org/drawingml/2006/main">
+            <a:off x="457200" y="533400"/>
+            <a:ext cx="11277600" cy="628650"/>
+          </a:xfrm>
+          <a:prstGeom xmlns:a="http://schemas.openxmlformats.org/drawingml/2006/main" prst="rect">
+            <a:avLst/>
+          </a:prstGeom>
+          <a:noFill xmlns:a="http://schemas.openxmlformats.org/drawingml/2006/main"/>
+          <a:ln xmlns:a="http://schemas.openxmlformats.org/drawingml/2006/main" w="0">
+            <a:noFill/>
+            <a:prstDash val="solid"/>
+          </a:ln>
+        </p:spPr>
+        <p:txBody>
+          <a:bodyPr xmlns:a="http://schemas.openxmlformats.org/drawingml/2006/main" wrap="square" lIns="0" tIns="0" rIns="0" bIns="0" anchor="t">
+            <a:normAutofit fontScale="88324"/>
+          </a:bodyPr>
+          <a:lstStyle xmlns:a="http://schemas.openxmlformats.org/drawingml/2006/main"/>
+          <a:p xmlns:a="http://schemas.openxmlformats.org/drawingml/2006/main">
+            <a:pPr algn="l">
+              <a:buNone/>
+              <a:defRPr sz="3525" b="1">
+                <a:solidFill>
+                  <a:srgbClr val="000000"/>
+                </a:solidFill>
+                <a:latin typeface="Arial"/>
+                <a:ea typeface="Arial"/>
+                <a:cs typeface="Arial"/>
+              </a:defRPr>
+            </a:pPr>
+            <a:r>
+              <a:rPr sz="3525" b="1">
+                <a:solidFill>
+                  <a:srgbClr val="000000"/>
+                </a:solidFill>
+                <a:latin typeface="Arial"/>
+                <a:ea typeface="Arial"/>
+                <a:cs typeface="Arial"/>
+              </a:rPr>
+              <a:t>ATR% changes the map—and leaves a replication candidate</a:t>
+            </a:r>
+          </a:p>
+        </p:txBody>
+      </p:sp>
+      <p:sp>
+        <p:nvSpPr>
+          <p:cNvPr id="3" name="">
+            <a:extLst xmlns:a="http://schemas.openxmlformats.org/drawingml/2006/main">
+              <a:ext uri="{FF2B5EF4-FFF2-40B4-BE49-F238E27FC236}">
+                <a16:creationId xmlns:a16="http://schemas.microsoft.com/office/drawing/2014/main" id="{D5CA0FCE-75E8-41EF-A76A-23E9E2120C6A}"/>
+              </a:ext>
+            </a:extLst>
+          </p:cNvPr>
+          <p:cNvSpPr>
+            <a:spLocks xmlns:a="http://schemas.openxmlformats.org/drawingml/2006/main" noGrp="1"/>
+          </p:cNvSpPr>
+          <p:nvPr/>
+        </p:nvSpPr>
+        <p:spPr>
+          <a:xfrm xmlns:a="http://schemas.openxmlformats.org/drawingml/2006/main">
+            <a:off x="457200" y="1200150"/>
+            <a:ext cx="11277600" cy="19050"/>
+          </a:xfrm>
+          <a:prstGeom xmlns:a="http://schemas.openxmlformats.org/drawingml/2006/main" prst="rect">
+            <a:avLst/>
+          </a:prstGeom>
+          <a:solidFill xmlns:a="http://schemas.openxmlformats.org/drawingml/2006/main">
+            <a:srgbClr val="B8BCC4"/>
+          </a:solidFill>
+          <a:ln xmlns:a="http://schemas.openxmlformats.org/drawingml/2006/main" w="0">
+            <a:solidFill>
+              <a:srgbClr val="B8BCC4"/>
+            </a:solidFill>
+            <a:prstDash val="solid"/>
+          </a:ln>
+        </p:spPr>
+      </p:sp>
+      <p:sp>
+        <p:nvSpPr>
+          <p:cNvPr id="4" name="footer-left-11">
+            <a:extLst xmlns:a="http://schemas.openxmlformats.org/drawingml/2006/main">
+              <a:ext uri="{FF2B5EF4-FFF2-40B4-BE49-F238E27FC236}">
+                <a16:creationId xmlns:a16="http://schemas.microsoft.com/office/drawing/2014/main" id="{700DA765-80E0-4197-8700-00D867B86FA2}"/>
+              </a:ext>
+            </a:extLst>
+          </p:cNvPr>
+          <p:cNvSpPr>
+            <a:spLocks xmlns:a="http://schemas.openxmlformats.org/drawingml/2006/main" noGrp="1"/>
+          </p:cNvSpPr>
+          <p:nvPr/>
+        </p:nvSpPr>
+        <p:spPr>
+          <a:xfrm xmlns:a="http://schemas.openxmlformats.org/drawingml/2006/main">
+            <a:off x="457200" y="6515100"/>
+            <a:ext cx="3429000" cy="171450"/>
+          </a:xfrm>
+          <a:prstGeom xmlns:a="http://schemas.openxmlformats.org/drawingml/2006/main" prst="rect">
+            <a:avLst/>
+          </a:prstGeom>
+          <a:noFill xmlns:a="http://schemas.openxmlformats.org/drawingml/2006/main"/>
+          <a:ln xmlns:a="http://schemas.openxmlformats.org/drawingml/2006/main" w="0">
+            <a:noFill/>
+            <a:prstDash val="solid"/>
+          </a:ln>
+        </p:spPr>
+        <p:txBody>
+          <a:bodyPr xmlns:a="http://schemas.openxmlformats.org/drawingml/2006/main" wrap="square" lIns="0" tIns="0" rIns="0" bIns="0" anchor="t">
+            <a:normAutofit fontScale="100000"/>
+          </a:bodyPr>
+          <a:lstStyle xmlns:a="http://schemas.openxmlformats.org/drawingml/2006/main"/>
+          <a:p xmlns:a="http://schemas.openxmlformats.org/drawingml/2006/main">
+            <a:pPr algn="l">
+              <a:buNone/>
+              <a:defRPr sz="1050" b="0">
+                <a:solidFill>
+                  <a:srgbClr val="667384"/>
+                </a:solidFill>
+                <a:latin typeface="Arial"/>
+                <a:ea typeface="Arial"/>
+                <a:cs typeface="Arial"/>
+              </a:defRPr>
+            </a:pPr>
+            <a:r>
+              <a:rPr sz="1050" b="0">
+                <a:solidFill>
+                  <a:srgbClr val="667384"/>
+                </a:solidFill>
+                <a:latin typeface="Arial"/>
+                <a:ea typeface="Arial"/>
+                <a:cs typeface="Arial"/>
+              </a:rPr>
+              <a:t>Adjusted daily TSLA | 2018-2023</a:t>
+            </a:r>
+          </a:p>
+        </p:txBody>
+      </p:sp>
+      <p:sp>
+        <p:nvSpPr>
+          <p:cNvPr id="5" name="footer-number-11">
+            <a:extLst xmlns:a="http://schemas.openxmlformats.org/drawingml/2006/main">
+              <a:ext uri="{FF2B5EF4-FFF2-40B4-BE49-F238E27FC236}">
+                <a16:creationId xmlns:a16="http://schemas.microsoft.com/office/drawing/2014/main" id="{83896276-4112-4532-AF7C-776C67C58B77}"/>
+              </a:ext>
+            </a:extLst>
+          </p:cNvPr>
+          <p:cNvSpPr>
+            <a:spLocks xmlns:a="http://schemas.openxmlformats.org/drawingml/2006/main" noGrp="1"/>
+          </p:cNvSpPr>
+          <p:nvPr/>
+        </p:nvSpPr>
+        <p:spPr>
+          <a:xfrm xmlns:a="http://schemas.openxmlformats.org/drawingml/2006/main">
+            <a:off x="11239500" y="6496050"/>
+            <a:ext cx="495300" cy="190500"/>
+          </a:xfrm>
+          <a:prstGeom xmlns:a="http://schemas.openxmlformats.org/drawingml/2006/main" prst="rect">
+            <a:avLst/>
+          </a:prstGeom>
+          <a:noFill xmlns:a="http://schemas.openxmlformats.org/drawingml/2006/main"/>
+          <a:ln xmlns:a="http://schemas.openxmlformats.org/drawingml/2006/main" w="0">
+            <a:noFill/>
+            <a:prstDash val="solid"/>
+          </a:ln>
+        </p:spPr>
+        <p:txBody>
+          <a:bodyPr xmlns:a="http://schemas.openxmlformats.org/drawingml/2006/main" wrap="square" lIns="0" tIns="0" rIns="0" bIns="0" anchor="t">
+            <a:normAutofit fontScale="100000"/>
+          </a:bodyPr>
+          <a:lstStyle xmlns:a="http://schemas.openxmlformats.org/drawingml/2006/main"/>
+          <a:p xmlns:a="http://schemas.openxmlformats.org/drawingml/2006/main">
+            <a:pPr algn="r">
+              <a:buNone/>
+              <a:defRPr sz="1050" b="0">
+                <a:solidFill>
+                  <a:srgbClr val="667384"/>
+                </a:solidFill>
+                <a:latin typeface="Arial"/>
+                <a:ea typeface="Arial"/>
+                <a:cs typeface="Arial"/>
+              </a:defRPr>
+            </a:pPr>
+            <a:r>
+              <a:rPr sz="1050" b="0">
+                <a:solidFill>
+                  <a:srgbClr val="667384"/>
+                </a:solidFill>
+                <a:latin typeface="Arial"/>
+                <a:ea typeface="Arial"/>
+                <a:cs typeface="Arial"/>
+              </a:rPr>
+              <a:t>31</a:t>
             </a:r>
           </a:p>
         </p:txBody>
@@ -24198,7 +24985,7 @@
           <p:nvPr/>
         </p:nvPicPr>
         <p:blipFill>
-          <a:blip xmlns:r="http://schemas.openxmlformats.org/officeDocument/2006/relationships" xmlns:a="http://schemas.openxmlformats.org/drawingml/2006/main" r:embed="Rc2c7f769338e45a4"/>
+          <a:blip xmlns:r="http://schemas.openxmlformats.org/officeDocument/2006/relationships" xmlns:a="http://schemas.openxmlformats.org/drawingml/2006/main" r:embed="R3e6ac7e05ab44faa"/>
           <a:stretch xmlns:a="http://schemas.openxmlformats.org/drawingml/2006/main"/>
         </p:blipFill>
         <p:spPr>
@@ -24610,7 +25397,7 @@
           <p:nvPr/>
         </p:nvPicPr>
         <p:blipFill>
-          <a:blip xmlns:r="http://schemas.openxmlformats.org/officeDocument/2006/relationships" xmlns:a="http://schemas.openxmlformats.org/drawingml/2006/main" r:embed="R321943bf56324648"/>
+          <a:blip xmlns:r="http://schemas.openxmlformats.org/officeDocument/2006/relationships" xmlns:a="http://schemas.openxmlformats.org/drawingml/2006/main" r:embed="Rc01ec9e6b94b4f52"/>
           <a:stretch xmlns:a="http://schemas.openxmlformats.org/drawingml/2006/main"/>
         </p:blipFill>
         <p:spPr>
@@ -25672,7 +26459,7 @@
           <p:nvPr/>
         </p:nvPicPr>
         <p:blipFill>
-          <a:blip xmlns:r="http://schemas.openxmlformats.org/officeDocument/2006/relationships" xmlns:a="http://schemas.openxmlformats.org/drawingml/2006/main" r:embed="Rb459fa0b30344a67"/>
+          <a:blip xmlns:r="http://schemas.openxmlformats.org/officeDocument/2006/relationships" xmlns:a="http://schemas.openxmlformats.org/drawingml/2006/main" r:embed="R45df43d5ea58424a"/>
           <a:stretch xmlns:a="http://schemas.openxmlformats.org/drawingml/2006/main"/>
         </p:blipFill>
         <p:spPr>
@@ -26577,7 +27364,7 @@
           <p:nvPr/>
         </p:nvPicPr>
         <p:blipFill>
-          <a:blip xmlns:r="http://schemas.openxmlformats.org/officeDocument/2006/relationships" xmlns:a="http://schemas.openxmlformats.org/drawingml/2006/main" r:embed="R472b74b356914a8a"/>
+          <a:blip xmlns:r="http://schemas.openxmlformats.org/officeDocument/2006/relationships" xmlns:a="http://schemas.openxmlformats.org/drawingml/2006/main" r:embed="Rc7dd42bd33944d1f"/>
           <a:stretch xmlns:a="http://schemas.openxmlformats.org/drawingml/2006/main"/>
         </p:blipFill>
         <p:spPr>
@@ -27381,7 +28168,7 @@
           <p:nvPr/>
         </p:nvPicPr>
         <p:blipFill>
-          <a:blip xmlns:r="http://schemas.openxmlformats.org/officeDocument/2006/relationships" xmlns:a="http://schemas.openxmlformats.org/drawingml/2006/main" r:embed="Rcc88488bccb44203"/>
+          <a:blip xmlns:r="http://schemas.openxmlformats.org/officeDocument/2006/relationships" xmlns:a="http://schemas.openxmlformats.org/drawingml/2006/main" r:embed="R68bc16d9e41544fa"/>
           <a:stretch xmlns:a="http://schemas.openxmlformats.org/drawingml/2006/main"/>
         </p:blipFill>
         <p:spPr>

</xml_diff>

<commit_message>
Add three-way prior return heatmap comparison
</commit_message>
<xml_diff>
--- a/operator_hypothesis_lab/presentations/tsla_descriptive_microscope_evidence.pptx
+++ b/operator_hypothesis_lab/presentations/tsla_descriptive_microscope_evidence.pptx
@@ -2,65 +2,66 @@
 <file path=ppt/presentation.xml><?xml version="1.0" encoding="utf-8"?>
 <p:presentation xmlns:p="http://schemas.openxmlformats.org/presentationml/2006/main">
   <p:sldMasterIdLst>
-    <p:sldMasterId xmlns:r="http://schemas.openxmlformats.org/officeDocument/2006/relationships" id="2147483648" r:id="R2d0c60dfa8154058"/>
+    <p:sldMasterId xmlns:r="http://schemas.openxmlformats.org/officeDocument/2006/relationships" id="2147483648" r:id="Rf61dd1f23718494c"/>
   </p:sldMasterIdLst>
   <p:notesMasterIdLst>
-    <p:notesMasterId xmlns:r="http://schemas.openxmlformats.org/officeDocument/2006/relationships" r:id="Rc909d29ae35c4d05"/>
+    <p:notesMasterId xmlns:r="http://schemas.openxmlformats.org/officeDocument/2006/relationships" r:id="R81b9721162024041"/>
   </p:notesMasterIdLst>
   <p:sldIdLst>
-    <p:sldId xmlns:r="http://schemas.openxmlformats.org/officeDocument/2006/relationships" id="256" r:id="Rb5da33f69b824c39"/>
-    <p:sldId xmlns:r="http://schemas.openxmlformats.org/officeDocument/2006/relationships" id="257" r:id="R86485ec219bc4914"/>
-    <p:sldId xmlns:r="http://schemas.openxmlformats.org/officeDocument/2006/relationships" id="258" r:id="R507cec9fd33b456f"/>
-    <p:sldId xmlns:r="http://schemas.openxmlformats.org/officeDocument/2006/relationships" id="259" r:id="R1298cd02b5df4ce3"/>
-    <p:sldId xmlns:r="http://schemas.openxmlformats.org/officeDocument/2006/relationships" id="260" r:id="Rbe97eac3eecc4559"/>
-    <p:sldId xmlns:r="http://schemas.openxmlformats.org/officeDocument/2006/relationships" id="261" r:id="R8d8f3e588f32481f"/>
-    <p:sldId xmlns:r="http://schemas.openxmlformats.org/officeDocument/2006/relationships" id="262" r:id="Rc058de0f50f44cc9"/>
-    <p:sldId xmlns:r="http://schemas.openxmlformats.org/officeDocument/2006/relationships" id="263" r:id="Rf384f44496b44ebd"/>
-    <p:sldId xmlns:r="http://schemas.openxmlformats.org/officeDocument/2006/relationships" id="264" r:id="R9700962d23de46c8"/>
-    <p:sldId xmlns:r="http://schemas.openxmlformats.org/officeDocument/2006/relationships" id="265" r:id="R28f3beb482344672"/>
-    <p:sldId xmlns:r="http://schemas.openxmlformats.org/officeDocument/2006/relationships" id="266" r:id="R159eae1c65254443"/>
-    <p:sldId xmlns:r="http://schemas.openxmlformats.org/officeDocument/2006/relationships" id="267" r:id="Rb764c1a112754d06"/>
-    <p:sldId xmlns:r="http://schemas.openxmlformats.org/officeDocument/2006/relationships" id="268" r:id="R299a86d13f0748aa"/>
-    <p:sldId xmlns:r="http://schemas.openxmlformats.org/officeDocument/2006/relationships" id="269" r:id="R19677b2f514b4cd1"/>
-    <p:sldId xmlns:r="http://schemas.openxmlformats.org/officeDocument/2006/relationships" id="270" r:id="R1f6ba1e54b7b4da8"/>
-    <p:sldId xmlns:r="http://schemas.openxmlformats.org/officeDocument/2006/relationships" id="271" r:id="R8665125a4f5341cc"/>
-    <p:sldId xmlns:r="http://schemas.openxmlformats.org/officeDocument/2006/relationships" id="272" r:id="R5e69029554114e12"/>
-    <p:sldId xmlns:r="http://schemas.openxmlformats.org/officeDocument/2006/relationships" id="273" r:id="Racb65886ade94225"/>
-    <p:sldId xmlns:r="http://schemas.openxmlformats.org/officeDocument/2006/relationships" id="274" r:id="R9a01683007d444b9"/>
-    <p:sldId xmlns:r="http://schemas.openxmlformats.org/officeDocument/2006/relationships" id="275" r:id="R53c16fbdd6bd45d3"/>
-    <p:sldId xmlns:r="http://schemas.openxmlformats.org/officeDocument/2006/relationships" id="276" r:id="Rff86cf4a30724c42"/>
-    <p:sldId xmlns:r="http://schemas.openxmlformats.org/officeDocument/2006/relationships" id="277" r:id="Rbd31e32d4a344bfc"/>
-    <p:sldId xmlns:r="http://schemas.openxmlformats.org/officeDocument/2006/relationships" id="278" r:id="Rf158738c48164368"/>
-    <p:sldId xmlns:r="http://schemas.openxmlformats.org/officeDocument/2006/relationships" id="279" r:id="R3aa2b53991164f9f"/>
-    <p:sldId xmlns:r="http://schemas.openxmlformats.org/officeDocument/2006/relationships" id="280" r:id="R94cb0c3a9787486a"/>
-    <p:sldId xmlns:r="http://schemas.openxmlformats.org/officeDocument/2006/relationships" id="281" r:id="Re91ad19faf0f4475"/>
-    <p:sldId xmlns:r="http://schemas.openxmlformats.org/officeDocument/2006/relationships" id="282" r:id="Rdcdabb6a27444b08"/>
-    <p:sldId xmlns:r="http://schemas.openxmlformats.org/officeDocument/2006/relationships" id="283" r:id="R5591180664d9418f"/>
-    <p:sldId xmlns:r="http://schemas.openxmlformats.org/officeDocument/2006/relationships" id="284" r:id="R60580597089b43e2"/>
-    <p:sldId xmlns:r="http://schemas.openxmlformats.org/officeDocument/2006/relationships" id="285" r:id="Rcdae2b7c6abc4176"/>
-    <p:sldId xmlns:r="http://schemas.openxmlformats.org/officeDocument/2006/relationships" id="286" r:id="Rc8ecab206c4149a3"/>
-    <p:sldId xmlns:r="http://schemas.openxmlformats.org/officeDocument/2006/relationships" id="287" r:id="R48352f625278406f"/>
-    <p:sldId xmlns:r="http://schemas.openxmlformats.org/officeDocument/2006/relationships" id="288" r:id="Re98a7faeef234284"/>
-    <p:sldId xmlns:r="http://schemas.openxmlformats.org/officeDocument/2006/relationships" id="289" r:id="R62e758bbbe9f4a2a"/>
-    <p:sldId xmlns:r="http://schemas.openxmlformats.org/officeDocument/2006/relationships" id="290" r:id="Rf71bacf99c4d41a9"/>
-    <p:sldId xmlns:r="http://schemas.openxmlformats.org/officeDocument/2006/relationships" id="291" r:id="R6115b0548474494d"/>
-    <p:sldId xmlns:r="http://schemas.openxmlformats.org/officeDocument/2006/relationships" id="292" r:id="Rae2888d3ec4d4c7d"/>
-    <p:sldId xmlns:r="http://schemas.openxmlformats.org/officeDocument/2006/relationships" id="293" r:id="R5c128c99c3a64973"/>
-    <p:sldId xmlns:r="http://schemas.openxmlformats.org/officeDocument/2006/relationships" id="294" r:id="Rae827422b6194e12"/>
-    <p:sldId xmlns:r="http://schemas.openxmlformats.org/officeDocument/2006/relationships" id="295" r:id="R950565b7faba499e"/>
-    <p:sldId xmlns:r="http://schemas.openxmlformats.org/officeDocument/2006/relationships" id="296" r:id="R57dba2d151ff4b10"/>
-    <p:sldId xmlns:r="http://schemas.openxmlformats.org/officeDocument/2006/relationships" id="297" r:id="R44623d04a653437d"/>
-    <p:sldId xmlns:r="http://schemas.openxmlformats.org/officeDocument/2006/relationships" id="298" r:id="R675eacbfc68742d6"/>
-    <p:sldId xmlns:r="http://schemas.openxmlformats.org/officeDocument/2006/relationships" id="299" r:id="R49d100e88b9444a3"/>
-    <p:sldId xmlns:r="http://schemas.openxmlformats.org/officeDocument/2006/relationships" id="300" r:id="R9c17e4d3a4644dfd"/>
-    <p:sldId xmlns:r="http://schemas.openxmlformats.org/officeDocument/2006/relationships" id="301" r:id="Rfd9b5ed52224450c"/>
-    <p:sldId xmlns:r="http://schemas.openxmlformats.org/officeDocument/2006/relationships" id="302" r:id="R17f5d8bd4b2e4953"/>
-    <p:sldId xmlns:r="http://schemas.openxmlformats.org/officeDocument/2006/relationships" id="303" r:id="R1afb64cd08f448da"/>
-    <p:sldId xmlns:r="http://schemas.openxmlformats.org/officeDocument/2006/relationships" id="304" r:id="R4fe355cdbcf2424b"/>
-    <p:sldId xmlns:r="http://schemas.openxmlformats.org/officeDocument/2006/relationships" id="305" r:id="Rdd458d252e874f3c"/>
-    <p:sldId xmlns:r="http://schemas.openxmlformats.org/officeDocument/2006/relationships" id="306" r:id="R2e28cbb731d94a3f"/>
-    <p:sldId xmlns:r="http://schemas.openxmlformats.org/officeDocument/2006/relationships" id="307" r:id="R5f3d2787aef84bdb"/>
-    <p:sldId xmlns:r="http://schemas.openxmlformats.org/officeDocument/2006/relationships" id="308" r:id="R13d54c743bae45da"/>
+    <p:sldId xmlns:r="http://schemas.openxmlformats.org/officeDocument/2006/relationships" id="256" r:id="Rd529e9f358b244a8"/>
+    <p:sldId xmlns:r="http://schemas.openxmlformats.org/officeDocument/2006/relationships" id="257" r:id="Rc356486f566f4c2d"/>
+    <p:sldId xmlns:r="http://schemas.openxmlformats.org/officeDocument/2006/relationships" id="258" r:id="Re82aef3c68f04574"/>
+    <p:sldId xmlns:r="http://schemas.openxmlformats.org/officeDocument/2006/relationships" id="259" r:id="R466e892a068d4664"/>
+    <p:sldId xmlns:r="http://schemas.openxmlformats.org/officeDocument/2006/relationships" id="260" r:id="Re417a43f19134f68"/>
+    <p:sldId xmlns:r="http://schemas.openxmlformats.org/officeDocument/2006/relationships" id="261" r:id="R271f45b6d12c4495"/>
+    <p:sldId xmlns:r="http://schemas.openxmlformats.org/officeDocument/2006/relationships" id="262" r:id="Ra863e21e033d4d76"/>
+    <p:sldId xmlns:r="http://schemas.openxmlformats.org/officeDocument/2006/relationships" id="263" r:id="R8232b5c9785d4cbc"/>
+    <p:sldId xmlns:r="http://schemas.openxmlformats.org/officeDocument/2006/relationships" id="264" r:id="Rc1acf6d23e044b0e"/>
+    <p:sldId xmlns:r="http://schemas.openxmlformats.org/officeDocument/2006/relationships" id="265" r:id="Rb7ec82c82c8c44dc"/>
+    <p:sldId xmlns:r="http://schemas.openxmlformats.org/officeDocument/2006/relationships" id="266" r:id="Rf2c7793e025b4400"/>
+    <p:sldId xmlns:r="http://schemas.openxmlformats.org/officeDocument/2006/relationships" id="267" r:id="R20791de619b74893"/>
+    <p:sldId xmlns:r="http://schemas.openxmlformats.org/officeDocument/2006/relationships" id="268" r:id="R312c8a5fd9354a03"/>
+    <p:sldId xmlns:r="http://schemas.openxmlformats.org/officeDocument/2006/relationships" id="269" r:id="R6267bdbaeb1449f0"/>
+    <p:sldId xmlns:r="http://schemas.openxmlformats.org/officeDocument/2006/relationships" id="270" r:id="R38d4bb1e362b4bdd"/>
+    <p:sldId xmlns:r="http://schemas.openxmlformats.org/officeDocument/2006/relationships" id="271" r:id="R1b58016fb1d042df"/>
+    <p:sldId xmlns:r="http://schemas.openxmlformats.org/officeDocument/2006/relationships" id="272" r:id="R2898cb1bddef4c5c"/>
+    <p:sldId xmlns:r="http://schemas.openxmlformats.org/officeDocument/2006/relationships" id="273" r:id="R33a1585bb05144cd"/>
+    <p:sldId xmlns:r="http://schemas.openxmlformats.org/officeDocument/2006/relationships" id="274" r:id="R547410e006904312"/>
+    <p:sldId xmlns:r="http://schemas.openxmlformats.org/officeDocument/2006/relationships" id="275" r:id="Ref611fff2b354357"/>
+    <p:sldId xmlns:r="http://schemas.openxmlformats.org/officeDocument/2006/relationships" id="276" r:id="Rdbb3af3237464437"/>
+    <p:sldId xmlns:r="http://schemas.openxmlformats.org/officeDocument/2006/relationships" id="277" r:id="R255205585b564edd"/>
+    <p:sldId xmlns:r="http://schemas.openxmlformats.org/officeDocument/2006/relationships" id="278" r:id="R2de7367c44454c4e"/>
+    <p:sldId xmlns:r="http://schemas.openxmlformats.org/officeDocument/2006/relationships" id="279" r:id="Rb140ee5455714ab5"/>
+    <p:sldId xmlns:r="http://schemas.openxmlformats.org/officeDocument/2006/relationships" id="280" r:id="Re3170730671c4b8c"/>
+    <p:sldId xmlns:r="http://schemas.openxmlformats.org/officeDocument/2006/relationships" id="281" r:id="R3007416aff5347b4"/>
+    <p:sldId xmlns:r="http://schemas.openxmlformats.org/officeDocument/2006/relationships" id="282" r:id="R115c58aa49174245"/>
+    <p:sldId xmlns:r="http://schemas.openxmlformats.org/officeDocument/2006/relationships" id="283" r:id="R994bb15582184ec0"/>
+    <p:sldId xmlns:r="http://schemas.openxmlformats.org/officeDocument/2006/relationships" id="284" r:id="R1b996ff9f0024938"/>
+    <p:sldId xmlns:r="http://schemas.openxmlformats.org/officeDocument/2006/relationships" id="285" r:id="R5a22998ac5a0497d"/>
+    <p:sldId xmlns:r="http://schemas.openxmlformats.org/officeDocument/2006/relationships" id="286" r:id="R7c475a0f575e4aa8"/>
+    <p:sldId xmlns:r="http://schemas.openxmlformats.org/officeDocument/2006/relationships" id="287" r:id="R3b45af128ea74c6a"/>
+    <p:sldId xmlns:r="http://schemas.openxmlformats.org/officeDocument/2006/relationships" id="288" r:id="R19b26324dfbb4383"/>
+    <p:sldId xmlns:r="http://schemas.openxmlformats.org/officeDocument/2006/relationships" id="289" r:id="R6ed55f6b04014b49"/>
+    <p:sldId xmlns:r="http://schemas.openxmlformats.org/officeDocument/2006/relationships" id="290" r:id="R835a57eaaae64903"/>
+    <p:sldId xmlns:r="http://schemas.openxmlformats.org/officeDocument/2006/relationships" id="291" r:id="R65a926a64c0b4c0e"/>
+    <p:sldId xmlns:r="http://schemas.openxmlformats.org/officeDocument/2006/relationships" id="292" r:id="Ra9839fa44c77492a"/>
+    <p:sldId xmlns:r="http://schemas.openxmlformats.org/officeDocument/2006/relationships" id="293" r:id="R64dc8a30f4ea4728"/>
+    <p:sldId xmlns:r="http://schemas.openxmlformats.org/officeDocument/2006/relationships" id="294" r:id="R6a754a44c34f4bb1"/>
+    <p:sldId xmlns:r="http://schemas.openxmlformats.org/officeDocument/2006/relationships" id="295" r:id="Rd11cc658b8b34b22"/>
+    <p:sldId xmlns:r="http://schemas.openxmlformats.org/officeDocument/2006/relationships" id="296" r:id="Rfeb0eeab965c4579"/>
+    <p:sldId xmlns:r="http://schemas.openxmlformats.org/officeDocument/2006/relationships" id="297" r:id="R44e04f7905f4410e"/>
+    <p:sldId xmlns:r="http://schemas.openxmlformats.org/officeDocument/2006/relationships" id="298" r:id="R038cd30c6eda455d"/>
+    <p:sldId xmlns:r="http://schemas.openxmlformats.org/officeDocument/2006/relationships" id="299" r:id="Red0a0811517d4db8"/>
+    <p:sldId xmlns:r="http://schemas.openxmlformats.org/officeDocument/2006/relationships" id="300" r:id="Re5f12015abb14c9a"/>
+    <p:sldId xmlns:r="http://schemas.openxmlformats.org/officeDocument/2006/relationships" id="301" r:id="Raf568e89fb1d4048"/>
+    <p:sldId xmlns:r="http://schemas.openxmlformats.org/officeDocument/2006/relationships" id="302" r:id="Rabe8660e61b741df"/>
+    <p:sldId xmlns:r="http://schemas.openxmlformats.org/officeDocument/2006/relationships" id="303" r:id="R1e3bb9b4fb694bf7"/>
+    <p:sldId xmlns:r="http://schemas.openxmlformats.org/officeDocument/2006/relationships" id="304" r:id="Rbd4fbf1d201047a9"/>
+    <p:sldId xmlns:r="http://schemas.openxmlformats.org/officeDocument/2006/relationships" id="305" r:id="Rfbfcb626eabe4614"/>
+    <p:sldId xmlns:r="http://schemas.openxmlformats.org/officeDocument/2006/relationships" id="306" r:id="Rd82e957cec7e42e8"/>
+    <p:sldId xmlns:r="http://schemas.openxmlformats.org/officeDocument/2006/relationships" id="307" r:id="Rf5fd6644ebf94e6a"/>
+    <p:sldId xmlns:r="http://schemas.openxmlformats.org/officeDocument/2006/relationships" id="308" r:id="R06d63831d43b48e5"/>
+    <p:sldId xmlns:r="http://schemas.openxmlformats.org/officeDocument/2006/relationships" id="309" r:id="Rdc2f36f62e9b41d1"/>
   </p:sldIdLst>
   <p:sldSz cx="12192000" cy="6858000"/>
   <p:notesSz cx="6858000" cy="9144000"/>
@@ -5014,6 +5015,96 @@
           </a:p>
           <a:p xmlns:a="http://schemas.openxmlformats.org/drawingml/2006/main">
             <a:r>
+              <a:t>Internal Gen5 own-return baseline packet: runs/research_workbench/operator_hypothesis_lab/tsla_cumulative_return_horizon_grid_20260825/</a:t>
+            </a:r>
+          </a:p>
+          <a:p xmlns:a="http://schemas.openxmlformats.org/drawingml/2006/main">
+            <a:r>
+              <a:t>[/Sources]</a:t>
+            </a:r>
+          </a:p>
+        </p:txBody>
+      </p:sp>
+      <p:sp>
+        <p:nvSpPr>
+          <p:cNvPr id="4" name="Slide Number Placeholder 3"/>
+          <p:cNvSpPr>
+            <a:spLocks xmlns:a="http://schemas.openxmlformats.org/drawingml/2006/main" noGrp="1"/>
+          </p:cNvSpPr>
+          <p:nvPr>
+            <p:ph type="sldNum" idx="5"/>
+          </p:nvPr>
+        </p:nvSpPr>
+        <p:spPr/>
+        <p:txBody>
+          <a:bodyPr xmlns:a="http://schemas.openxmlformats.org/drawingml/2006/main"/>
+          <a:lstStyle xmlns:a="http://schemas.openxmlformats.org/drawingml/2006/main"/>
+          <a:p xmlns:a="http://schemas.openxmlformats.org/drawingml/2006/main"/>
+        </p:txBody>
+      </p:sp>
+    </p:spTree>
+  </p:cSld>
+  <p:clrMapOvr>
+    <a:masterClrMapping xmlns:a="http://schemas.openxmlformats.org/drawingml/2006/main"/>
+  </p:clrMapOvr>
+</p:notes>
+</file>
+
+<file path=ppt/notesSlides/notesSlide54.xml><?xml version="1.0" encoding="utf-8"?>
+<p:notes xmlns:p="http://schemas.openxmlformats.org/presentationml/2006/main">
+  <p:cSld>
+    <p:spTree>
+      <p:nvGrpSpPr>
+        <p:cNvPr id="1" name=""/>
+        <p:cNvGrpSpPr/>
+        <p:nvPr/>
+      </p:nvGrpSpPr>
+      <p:grpSpPr>
+        <a:xfrm xmlns:a="http://schemas.openxmlformats.org/drawingml/2006/main"/>
+      </p:grpSpPr>
+      <p:sp>
+        <p:nvSpPr>
+          <p:cNvPr id="2" name="Slide Image Placeholder 1"/>
+          <p:cNvSpPr>
+            <a:spLocks xmlns:a="http://schemas.openxmlformats.org/drawingml/2006/main" noGrp="1"/>
+          </p:cNvSpPr>
+          <p:nvPr>
+            <p:ph type="sldImg" idx="0"/>
+          </p:nvPr>
+        </p:nvSpPr>
+        <p:spPr/>
+      </p:sp>
+      <p:sp>
+        <p:nvSpPr>
+          <p:cNvPr id="3" name="Notes Placeholder 2"/>
+          <p:cNvSpPr>
+            <a:spLocks xmlns:a="http://schemas.openxmlformats.org/drawingml/2006/main" noGrp="1"/>
+          </p:cNvSpPr>
+          <p:nvPr>
+            <p:ph type="body" idx="1"/>
+          </p:nvPr>
+        </p:nvSpPr>
+        <p:spPr/>
+        <p:txBody>
+          <a:bodyPr xmlns:a="http://schemas.openxmlformats.org/drawingml/2006/main"/>
+          <a:lstStyle xmlns:a="http://schemas.openxmlformats.org/drawingml/2006/main"/>
+          <a:p xmlns:a="http://schemas.openxmlformats.org/drawingml/2006/main">
+            <a:r>
+              <a:t>[Sources]</a:t>
+            </a:r>
+          </a:p>
+          <a:p xmlns:a="http://schemas.openxmlformats.org/drawingml/2006/main">
+            <a:r>
+              <a:t>Internal Gen5 packet: runs/research_workbench/operator_hypothesis_lab/tsla_qqq_spy_prior_return_horizon_grid_20260825/</a:t>
+            </a:r>
+          </a:p>
+          <a:p xmlns:a="http://schemas.openxmlformats.org/drawingml/2006/main">
+            <a:r>
+              <a:t>Internal Gen5 note: operator_hypothesis_lab/docs/TSLA_QQQ_SPY_PRIOR_RETURN_HORIZON_GRID_2018_2023.md</a:t>
+            </a:r>
+          </a:p>
+          <a:p xmlns:a="http://schemas.openxmlformats.org/drawingml/2006/main">
+            <a:r>
               <a:t>Internal Gen5 comparison packet: runs/research_workbench/operator_hypothesis_lab/tsla_return_horizon_grid_20260824/</a:t>
             </a:r>
           </a:p>
@@ -5477,7 +5568,7 @@
   </p:cSld>
   <p:clrMap bg1="lt1" tx1="dk1" bg2="lt2" tx2="dk2" accent1="accent1" accent2="accent2" accent3="accent3" accent4="accent4" accent5="accent5" accent6="accent6" hlink="hlink" folHlink="folHlink"/>
   <p:sldLayoutIdLst>
-    <p:sldLayoutId xmlns:r="http://schemas.openxmlformats.org/officeDocument/2006/relationships" id="2147483649" r:id="Rb0dbce1e837d4a3a"/>
+    <p:sldLayoutId xmlns:r="http://schemas.openxmlformats.org/officeDocument/2006/relationships" id="2147483649" r:id="R153e58f707b04b92"/>
   </p:sldLayoutIdLst>
   <p:txStyles>
     <p:titleStyle>
@@ -6656,7 +6747,7 @@
           <p:nvPr/>
         </p:nvPicPr>
         <p:blipFill>
-          <a:blip xmlns:r="http://schemas.openxmlformats.org/officeDocument/2006/relationships" xmlns:a="http://schemas.openxmlformats.org/drawingml/2006/main" r:embed="Rcab7b7c0b1cb40ed"/>
+          <a:blip xmlns:r="http://schemas.openxmlformats.org/officeDocument/2006/relationships" xmlns:a="http://schemas.openxmlformats.org/drawingml/2006/main" r:embed="R781ccdcb81604dbe"/>
           <a:stretch xmlns:a="http://schemas.openxmlformats.org/drawingml/2006/main"/>
         </p:blipFill>
         <p:spPr>
@@ -10577,7 +10668,7 @@
           <p:nvPr/>
         </p:nvPicPr>
         <p:blipFill>
-          <a:blip xmlns:r="http://schemas.openxmlformats.org/officeDocument/2006/relationships" xmlns:a="http://schemas.openxmlformats.org/drawingml/2006/main" r:embed="R6dbf029c19894815"/>
+          <a:blip xmlns:r="http://schemas.openxmlformats.org/officeDocument/2006/relationships" xmlns:a="http://schemas.openxmlformats.org/drawingml/2006/main" r:embed="R0988610be9cc4e56"/>
           <a:stretch xmlns:a="http://schemas.openxmlformats.org/drawingml/2006/main"/>
         </p:blipFill>
         <p:spPr>
@@ -11482,7 +11573,7 @@
           <p:nvPr/>
         </p:nvPicPr>
         <p:blipFill>
-          <a:blip xmlns:r="http://schemas.openxmlformats.org/officeDocument/2006/relationships" xmlns:a="http://schemas.openxmlformats.org/drawingml/2006/main" r:embed="Reaf50aa0b4334874"/>
+          <a:blip xmlns:r="http://schemas.openxmlformats.org/officeDocument/2006/relationships" xmlns:a="http://schemas.openxmlformats.org/drawingml/2006/main" r:embed="Rf3266d2e5dae4023"/>
           <a:stretch xmlns:a="http://schemas.openxmlformats.org/drawingml/2006/main"/>
         </p:blipFill>
         <p:spPr>
@@ -12286,7 +12377,7 @@
           <p:nvPr/>
         </p:nvPicPr>
         <p:blipFill>
-          <a:blip xmlns:r="http://schemas.openxmlformats.org/officeDocument/2006/relationships" xmlns:a="http://schemas.openxmlformats.org/drawingml/2006/main" r:embed="R075c54dcde854ec5"/>
+          <a:blip xmlns:r="http://schemas.openxmlformats.org/officeDocument/2006/relationships" xmlns:a="http://schemas.openxmlformats.org/drawingml/2006/main" r:embed="R90fbece7564a438e"/>
           <a:stretch xmlns:a="http://schemas.openxmlformats.org/drawingml/2006/main"/>
         </p:blipFill>
         <p:spPr>
@@ -16639,7 +16730,7 @@
           <p:nvPr/>
         </p:nvPicPr>
         <p:blipFill>
-          <a:blip xmlns:r="http://schemas.openxmlformats.org/officeDocument/2006/relationships" xmlns:a="http://schemas.openxmlformats.org/drawingml/2006/main" r:embed="R0ec84b4d1e4049ff"/>
+          <a:blip xmlns:r="http://schemas.openxmlformats.org/officeDocument/2006/relationships" xmlns:a="http://schemas.openxmlformats.org/drawingml/2006/main" r:embed="Rd8d2739ec61646db"/>
           <a:stretch xmlns:a="http://schemas.openxmlformats.org/drawingml/2006/main"/>
         </p:blipFill>
         <p:spPr>
@@ -17051,7 +17142,7 @@
           <p:nvPr/>
         </p:nvPicPr>
         <p:blipFill>
-          <a:blip xmlns:r="http://schemas.openxmlformats.org/officeDocument/2006/relationships" xmlns:a="http://schemas.openxmlformats.org/drawingml/2006/main" r:embed="R0a1aaa9241c84c8d"/>
+          <a:blip xmlns:r="http://schemas.openxmlformats.org/officeDocument/2006/relationships" xmlns:a="http://schemas.openxmlformats.org/drawingml/2006/main" r:embed="R32ee69f84bce44d3"/>
           <a:stretch xmlns:a="http://schemas.openxmlformats.org/drawingml/2006/main"/>
         </p:blipFill>
         <p:spPr>
@@ -17956,7 +18047,7 @@
           <p:nvPr/>
         </p:nvPicPr>
         <p:blipFill>
-          <a:blip xmlns:r="http://schemas.openxmlformats.org/officeDocument/2006/relationships" xmlns:a="http://schemas.openxmlformats.org/drawingml/2006/main" r:embed="R470effb4594349cd"/>
+          <a:blip xmlns:r="http://schemas.openxmlformats.org/officeDocument/2006/relationships" xmlns:a="http://schemas.openxmlformats.org/drawingml/2006/main" r:embed="R44c89596c34b49f7"/>
           <a:stretch xmlns:a="http://schemas.openxmlformats.org/drawingml/2006/main"/>
         </p:blipFill>
         <p:spPr>
@@ -21728,7 +21819,7 @@
           <p:nvPr/>
         </p:nvPicPr>
         <p:blipFill>
-          <a:blip xmlns:r="http://schemas.openxmlformats.org/officeDocument/2006/relationships" xmlns:a="http://schemas.openxmlformats.org/drawingml/2006/main" r:embed="R7fa0a0942b9f4d2b"/>
+          <a:blip xmlns:r="http://schemas.openxmlformats.org/officeDocument/2006/relationships" xmlns:a="http://schemas.openxmlformats.org/drawingml/2006/main" r:embed="R981bb5217faa4601"/>
           <a:stretch xmlns:a="http://schemas.openxmlformats.org/drawingml/2006/main"/>
         </p:blipFill>
         <p:spPr>
@@ -22140,7 +22231,7 @@
           <p:nvPr/>
         </p:nvPicPr>
         <p:blipFill>
-          <a:blip xmlns:r="http://schemas.openxmlformats.org/officeDocument/2006/relationships" xmlns:a="http://schemas.openxmlformats.org/drawingml/2006/main" r:embed="R3598d30657ac4505"/>
+          <a:blip xmlns:r="http://schemas.openxmlformats.org/officeDocument/2006/relationships" xmlns:a="http://schemas.openxmlformats.org/drawingml/2006/main" r:embed="R3236a7dfed144fd0"/>
           <a:stretch xmlns:a="http://schemas.openxmlformats.org/drawingml/2006/main"/>
         </p:blipFill>
         <p:spPr>
@@ -22552,7 +22643,7 @@
           <p:nvPr/>
         </p:nvPicPr>
         <p:blipFill>
-          <a:blip xmlns:r="http://schemas.openxmlformats.org/officeDocument/2006/relationships" xmlns:a="http://schemas.openxmlformats.org/drawingml/2006/main" r:embed="Rc03ae16d0eb04a4a"/>
+          <a:blip xmlns:r="http://schemas.openxmlformats.org/officeDocument/2006/relationships" xmlns:a="http://schemas.openxmlformats.org/drawingml/2006/main" r:embed="R97755672eec54980"/>
           <a:stretch xmlns:a="http://schemas.openxmlformats.org/drawingml/2006/main"/>
         </p:blipFill>
         <p:spPr>
@@ -22964,7 +23055,7 @@
           <p:nvPr/>
         </p:nvPicPr>
         <p:blipFill>
-          <a:blip xmlns:r="http://schemas.openxmlformats.org/officeDocument/2006/relationships" xmlns:a="http://schemas.openxmlformats.org/drawingml/2006/main" r:embed="Rc94cd0e81912432b"/>
+          <a:blip xmlns:r="http://schemas.openxmlformats.org/officeDocument/2006/relationships" xmlns:a="http://schemas.openxmlformats.org/drawingml/2006/main" r:embed="R330aa16d701b4700"/>
           <a:stretch xmlns:a="http://schemas.openxmlformats.org/drawingml/2006/main"/>
         </p:blipFill>
         <p:spPr>
@@ -25401,7 +25492,7 @@
           <p:nvPr/>
         </p:nvPicPr>
         <p:blipFill>
-          <a:blip xmlns:r="http://schemas.openxmlformats.org/officeDocument/2006/relationships" xmlns:a="http://schemas.openxmlformats.org/drawingml/2006/main" r:embed="R0bc69edbf6d04db4"/>
+          <a:blip xmlns:r="http://schemas.openxmlformats.org/officeDocument/2006/relationships" xmlns:a="http://schemas.openxmlformats.org/drawingml/2006/main" r:embed="R9bbbfcee6def46ff"/>
           <a:stretch xmlns:a="http://schemas.openxmlformats.org/drawingml/2006/main"/>
         </p:blipFill>
         <p:spPr>
@@ -29149,7 +29240,7 @@
           <p:nvPr/>
         </p:nvPicPr>
         <p:blipFill>
-          <a:blip xmlns:r="http://schemas.openxmlformats.org/officeDocument/2006/relationships" xmlns:a="http://schemas.openxmlformats.org/drawingml/2006/main" r:embed="R18baa9981447494d"/>
+          <a:blip xmlns:r="http://schemas.openxmlformats.org/officeDocument/2006/relationships" xmlns:a="http://schemas.openxmlformats.org/drawingml/2006/main" r:embed="R9fb5b7cc3197490f"/>
           <a:stretch xmlns:a="http://schemas.openxmlformats.org/drawingml/2006/main"/>
         </p:blipFill>
         <p:spPr>
@@ -29171,7 +29262,7 @@
           <p:nvPr/>
         </p:nvPicPr>
         <p:blipFill>
-          <a:blip xmlns:r="http://schemas.openxmlformats.org/officeDocument/2006/relationships" xmlns:a="http://schemas.openxmlformats.org/drawingml/2006/main" r:embed="R264e646452964028"/>
+          <a:blip xmlns:r="http://schemas.openxmlformats.org/officeDocument/2006/relationships" xmlns:a="http://schemas.openxmlformats.org/drawingml/2006/main" r:embed="R7cd54ae45d7a4081"/>
           <a:stretch xmlns:a="http://schemas.openxmlformats.org/drawingml/2006/main"/>
         </p:blipFill>
         <p:spPr>
@@ -29583,7 +29674,7 @@
           <p:nvPr/>
         </p:nvPicPr>
         <p:blipFill>
-          <a:blip xmlns:r="http://schemas.openxmlformats.org/officeDocument/2006/relationships" xmlns:a="http://schemas.openxmlformats.org/drawingml/2006/main" r:embed="R6d0bab586b6c4923"/>
+          <a:blip xmlns:r="http://schemas.openxmlformats.org/officeDocument/2006/relationships" xmlns:a="http://schemas.openxmlformats.org/drawingml/2006/main" r:embed="R5c115e1fc3624940"/>
           <a:stretch xmlns:a="http://schemas.openxmlformats.org/drawingml/2006/main"/>
         </p:blipFill>
         <p:spPr>
@@ -29605,7 +29696,7 @@
           <p:nvPr/>
         </p:nvPicPr>
         <p:blipFill>
-          <a:blip xmlns:r="http://schemas.openxmlformats.org/officeDocument/2006/relationships" xmlns:a="http://schemas.openxmlformats.org/drawingml/2006/main" r:embed="Rcd0b2122601f4376"/>
+          <a:blip xmlns:r="http://schemas.openxmlformats.org/officeDocument/2006/relationships" xmlns:a="http://schemas.openxmlformats.org/drawingml/2006/main" r:embed="R84d61ca46c5e408a"/>
           <a:stretch xmlns:a="http://schemas.openxmlformats.org/drawingml/2006/main"/>
         </p:blipFill>
         <p:spPr>
@@ -30017,7 +30108,7 @@
           <p:nvPr/>
         </p:nvPicPr>
         <p:blipFill>
-          <a:blip xmlns:r="http://schemas.openxmlformats.org/officeDocument/2006/relationships" xmlns:a="http://schemas.openxmlformats.org/drawingml/2006/main" r:embed="Re2235d9a399946fc"/>
+          <a:blip xmlns:r="http://schemas.openxmlformats.org/officeDocument/2006/relationships" xmlns:a="http://schemas.openxmlformats.org/drawingml/2006/main" r:embed="Rc92868afc270479f"/>
           <a:stretch xmlns:a="http://schemas.openxmlformats.org/drawingml/2006/main"/>
         </p:blipFill>
         <p:spPr>
@@ -30039,7 +30130,7 @@
           <p:nvPr/>
         </p:nvPicPr>
         <p:blipFill>
-          <a:blip xmlns:r="http://schemas.openxmlformats.org/officeDocument/2006/relationships" xmlns:a="http://schemas.openxmlformats.org/drawingml/2006/main" r:embed="R2fb79264e7474fa9"/>
+          <a:blip xmlns:r="http://schemas.openxmlformats.org/officeDocument/2006/relationships" xmlns:a="http://schemas.openxmlformats.org/drawingml/2006/main" r:embed="Rae259f9a50864188"/>
           <a:stretch xmlns:a="http://schemas.openxmlformats.org/drawingml/2006/main"/>
         </p:blipFill>
         <p:spPr>
@@ -30451,7 +30542,7 @@
           <p:nvPr/>
         </p:nvPicPr>
         <p:blipFill>
-          <a:blip xmlns:r="http://schemas.openxmlformats.org/officeDocument/2006/relationships" xmlns:a="http://schemas.openxmlformats.org/drawingml/2006/main" r:embed="Rf62d6f3bd4964097"/>
+          <a:blip xmlns:r="http://schemas.openxmlformats.org/officeDocument/2006/relationships" xmlns:a="http://schemas.openxmlformats.org/drawingml/2006/main" r:embed="R3861d3fbf5eb43b8"/>
           <a:stretch xmlns:a="http://schemas.openxmlformats.org/drawingml/2006/main"/>
         </p:blipFill>
         <p:spPr>
@@ -30473,7 +30564,7 @@
           <p:nvPr/>
         </p:nvPicPr>
         <p:blipFill>
-          <a:blip xmlns:r="http://schemas.openxmlformats.org/officeDocument/2006/relationships" xmlns:a="http://schemas.openxmlformats.org/drawingml/2006/main" r:embed="Rcff7f4fdf5974f35"/>
+          <a:blip xmlns:r="http://schemas.openxmlformats.org/officeDocument/2006/relationships" xmlns:a="http://schemas.openxmlformats.org/drawingml/2006/main" r:embed="R32d61d750d4e4780"/>
           <a:stretch xmlns:a="http://schemas.openxmlformats.org/drawingml/2006/main"/>
         </p:blipFill>
         <p:spPr>
@@ -31378,7 +31469,7 @@
           <p:nvPr/>
         </p:nvPicPr>
         <p:blipFill>
-          <a:blip xmlns:r="http://schemas.openxmlformats.org/officeDocument/2006/relationships" xmlns:a="http://schemas.openxmlformats.org/drawingml/2006/main" r:embed="R16b45566989146a5"/>
+          <a:blip xmlns:r="http://schemas.openxmlformats.org/officeDocument/2006/relationships" xmlns:a="http://schemas.openxmlformats.org/drawingml/2006/main" r:embed="R0351242011ba4b2b"/>
           <a:stretch xmlns:a="http://schemas.openxmlformats.org/drawingml/2006/main"/>
         </p:blipFill>
         <p:spPr>
@@ -31400,7 +31491,7 @@
           <p:nvPr/>
         </p:nvPicPr>
         <p:blipFill>
-          <a:blip xmlns:r="http://schemas.openxmlformats.org/officeDocument/2006/relationships" xmlns:a="http://schemas.openxmlformats.org/drawingml/2006/main" r:embed="Re5dfa0ca2a854822"/>
+          <a:blip xmlns:r="http://schemas.openxmlformats.org/officeDocument/2006/relationships" xmlns:a="http://schemas.openxmlformats.org/drawingml/2006/main" r:embed="R6ab9b66c31e74076"/>
           <a:stretch xmlns:a="http://schemas.openxmlformats.org/drawingml/2006/main"/>
         </p:blipFill>
         <p:spPr>
@@ -32931,7 +33022,7 @@
           <p:nvPr/>
         </p:nvPicPr>
         <p:blipFill>
-          <a:blip xmlns:r="http://schemas.openxmlformats.org/officeDocument/2006/relationships" xmlns:a="http://schemas.openxmlformats.org/drawingml/2006/main" r:embed="R7ad2fa2f815d4d6d"/>
+          <a:blip xmlns:r="http://schemas.openxmlformats.org/officeDocument/2006/relationships" xmlns:a="http://schemas.openxmlformats.org/drawingml/2006/main" r:embed="Ra7520dbeb69e4a08"/>
           <a:stretch xmlns:a="http://schemas.openxmlformats.org/drawingml/2006/main"/>
         </p:blipFill>
         <p:spPr>
@@ -35560,7 +35651,7 @@
           <p:nvPr/>
         </p:nvPicPr>
         <p:blipFill>
-          <a:blip xmlns:r="http://schemas.openxmlformats.org/officeDocument/2006/relationships" xmlns:a="http://schemas.openxmlformats.org/drawingml/2006/main" r:embed="Rf627b50688354903"/>
+          <a:blip xmlns:r="http://schemas.openxmlformats.org/officeDocument/2006/relationships" xmlns:a="http://schemas.openxmlformats.org/drawingml/2006/main" r:embed="R0f09c7caf7cc4ec8"/>
           <a:stretch xmlns:a="http://schemas.openxmlformats.org/drawingml/2006/main"/>
         </p:blipFill>
         <p:spPr>
@@ -35582,7 +35673,7 @@
           <p:nvPr/>
         </p:nvPicPr>
         <p:blipFill>
-          <a:blip xmlns:r="http://schemas.openxmlformats.org/officeDocument/2006/relationships" xmlns:a="http://schemas.openxmlformats.org/drawingml/2006/main" r:embed="R58945659d51f44a1"/>
+          <a:blip xmlns:r="http://schemas.openxmlformats.org/officeDocument/2006/relationships" xmlns:a="http://schemas.openxmlformats.org/drawingml/2006/main" r:embed="Rae1f5a56da734ad3"/>
           <a:stretch xmlns:a="http://schemas.openxmlformats.org/drawingml/2006/main"/>
         </p:blipFill>
         <p:spPr>
@@ -35994,7 +36085,7 @@
           <p:nvPr/>
         </p:nvPicPr>
         <p:blipFill>
-          <a:blip xmlns:r="http://schemas.openxmlformats.org/officeDocument/2006/relationships" xmlns:a="http://schemas.openxmlformats.org/drawingml/2006/main" r:embed="R4f41a6a53e0c4f93"/>
+          <a:blip xmlns:r="http://schemas.openxmlformats.org/officeDocument/2006/relationships" xmlns:a="http://schemas.openxmlformats.org/drawingml/2006/main" r:embed="R018fa2bfa5b84dd8"/>
           <a:stretch xmlns:a="http://schemas.openxmlformats.org/drawingml/2006/main"/>
         </p:blipFill>
         <p:spPr>
@@ -36016,7 +36107,7 @@
           <p:nvPr/>
         </p:nvPicPr>
         <p:blipFill>
-          <a:blip xmlns:r="http://schemas.openxmlformats.org/officeDocument/2006/relationships" xmlns:a="http://schemas.openxmlformats.org/drawingml/2006/main" r:embed="R687a21721adb418a"/>
+          <a:blip xmlns:r="http://schemas.openxmlformats.org/officeDocument/2006/relationships" xmlns:a="http://schemas.openxmlformats.org/drawingml/2006/main" r:embed="R6caeea9c68b244d9"/>
           <a:stretch xmlns:a="http://schemas.openxmlformats.org/drawingml/2006/main"/>
         </p:blipFill>
         <p:spPr>
@@ -36428,7 +36519,7 @@
           <p:nvPr/>
         </p:nvPicPr>
         <p:blipFill>
-          <a:blip xmlns:r="http://schemas.openxmlformats.org/officeDocument/2006/relationships" xmlns:a="http://schemas.openxmlformats.org/drawingml/2006/main" r:embed="R2baf666064904f43"/>
+          <a:blip xmlns:r="http://schemas.openxmlformats.org/officeDocument/2006/relationships" xmlns:a="http://schemas.openxmlformats.org/drawingml/2006/main" r:embed="Rd5afa9b8f0724349"/>
           <a:stretch xmlns:a="http://schemas.openxmlformats.org/drawingml/2006/main"/>
         </p:blipFill>
         <p:spPr>
@@ -36450,7 +36541,7 @@
           <p:nvPr/>
         </p:nvPicPr>
         <p:blipFill>
-          <a:blip xmlns:r="http://schemas.openxmlformats.org/officeDocument/2006/relationships" xmlns:a="http://schemas.openxmlformats.org/drawingml/2006/main" r:embed="R984a13127eb343cf"/>
+          <a:blip xmlns:r="http://schemas.openxmlformats.org/officeDocument/2006/relationships" xmlns:a="http://schemas.openxmlformats.org/drawingml/2006/main" r:embed="R7531d327adaa4e5b"/>
           <a:stretch xmlns:a="http://schemas.openxmlformats.org/drawingml/2006/main"/>
         </p:blipFill>
         <p:spPr>
@@ -36862,7 +36953,7 @@
           <p:nvPr/>
         </p:nvPicPr>
         <p:blipFill>
-          <a:blip xmlns:r="http://schemas.openxmlformats.org/officeDocument/2006/relationships" xmlns:a="http://schemas.openxmlformats.org/drawingml/2006/main" r:embed="Rea75e8986eae4477"/>
+          <a:blip xmlns:r="http://schemas.openxmlformats.org/officeDocument/2006/relationships" xmlns:a="http://schemas.openxmlformats.org/drawingml/2006/main" r:embed="Rc63a75766b3e4ecd"/>
           <a:stretch xmlns:a="http://schemas.openxmlformats.org/drawingml/2006/main"/>
         </p:blipFill>
         <p:spPr>
@@ -36884,7 +36975,7 @@
           <p:nvPr/>
         </p:nvPicPr>
         <p:blipFill>
-          <a:blip xmlns:r="http://schemas.openxmlformats.org/officeDocument/2006/relationships" xmlns:a="http://schemas.openxmlformats.org/drawingml/2006/main" r:embed="Rae891186be36471b"/>
+          <a:blip xmlns:r="http://schemas.openxmlformats.org/officeDocument/2006/relationships" xmlns:a="http://schemas.openxmlformats.org/drawingml/2006/main" r:embed="R1df615e9bb8b4a5d"/>
           <a:stretch xmlns:a="http://schemas.openxmlformats.org/drawingml/2006/main"/>
         </p:blipFill>
         <p:spPr>
@@ -37789,7 +37880,7 @@
           <p:nvPr/>
         </p:nvPicPr>
         <p:blipFill>
-          <a:blip xmlns:r="http://schemas.openxmlformats.org/officeDocument/2006/relationships" xmlns:a="http://schemas.openxmlformats.org/drawingml/2006/main" r:embed="R440add1ae3854a4d"/>
+          <a:blip xmlns:r="http://schemas.openxmlformats.org/officeDocument/2006/relationships" xmlns:a="http://schemas.openxmlformats.org/drawingml/2006/main" r:embed="Rf43d2e1642cd4294"/>
           <a:stretch xmlns:a="http://schemas.openxmlformats.org/drawingml/2006/main"/>
         </p:blipFill>
         <p:spPr>
@@ -37811,7 +37902,7 @@
           <p:nvPr/>
         </p:nvPicPr>
         <p:blipFill>
-          <a:blip xmlns:r="http://schemas.openxmlformats.org/officeDocument/2006/relationships" xmlns:a="http://schemas.openxmlformats.org/drawingml/2006/main" r:embed="R0ced9f43c1dd4407"/>
+          <a:blip xmlns:r="http://schemas.openxmlformats.org/officeDocument/2006/relationships" xmlns:a="http://schemas.openxmlformats.org/drawingml/2006/main" r:embed="R1309559a2de54401"/>
           <a:stretch xmlns:a="http://schemas.openxmlformats.org/drawingml/2006/main"/>
         </p:blipFill>
         <p:spPr>
@@ -41231,7 +41322,7 @@
           <p:nvPr/>
         </p:nvPicPr>
         <p:blipFill>
-          <a:blip xmlns:r="http://schemas.openxmlformats.org/officeDocument/2006/relationships" xmlns:a="http://schemas.openxmlformats.org/drawingml/2006/main" r:embed="Re3f881a0d9f54425"/>
+          <a:blip xmlns:r="http://schemas.openxmlformats.org/officeDocument/2006/relationships" xmlns:a="http://schemas.openxmlformats.org/drawingml/2006/main" r:embed="Rfda214b5c579424b"/>
           <a:stretch xmlns:a="http://schemas.openxmlformats.org/drawingml/2006/main"/>
         </p:blipFill>
         <p:spPr>
@@ -41971,7 +42062,7 @@
           <p:nvPr/>
         </p:nvPicPr>
         <p:blipFill>
-          <a:blip xmlns:r="http://schemas.openxmlformats.org/officeDocument/2006/relationships" xmlns:a="http://schemas.openxmlformats.org/drawingml/2006/main" r:embed="R9617acbdd661423a"/>
+          <a:blip xmlns:r="http://schemas.openxmlformats.org/officeDocument/2006/relationships" xmlns:a="http://schemas.openxmlformats.org/drawingml/2006/main" r:embed="Rcd12a77403c548d9"/>
           <a:stretch xmlns:a="http://schemas.openxmlformats.org/drawingml/2006/main"/>
         </p:blipFill>
         <p:spPr>
@@ -41993,7 +42084,7 @@
           <p:nvPr/>
         </p:nvPicPr>
         <p:blipFill>
-          <a:blip xmlns:r="http://schemas.openxmlformats.org/officeDocument/2006/relationships" xmlns:a="http://schemas.openxmlformats.org/drawingml/2006/main" r:embed="R746b396aef224c3d"/>
+          <a:blip xmlns:r="http://schemas.openxmlformats.org/officeDocument/2006/relationships" xmlns:a="http://schemas.openxmlformats.org/drawingml/2006/main" r:embed="R013a2b654454478e"/>
           <a:stretch xmlns:a="http://schemas.openxmlformats.org/drawingml/2006/main"/>
         </p:blipFill>
         <p:spPr>
@@ -42405,7 +42496,7 @@
           <p:nvPr/>
         </p:nvPicPr>
         <p:blipFill>
-          <a:blip xmlns:r="http://schemas.openxmlformats.org/officeDocument/2006/relationships" xmlns:a="http://schemas.openxmlformats.org/drawingml/2006/main" r:embed="Rea9e525c0de64db1"/>
+          <a:blip xmlns:r="http://schemas.openxmlformats.org/officeDocument/2006/relationships" xmlns:a="http://schemas.openxmlformats.org/drawingml/2006/main" r:embed="Rd17ef16e3c324dbc"/>
           <a:stretch xmlns:a="http://schemas.openxmlformats.org/drawingml/2006/main"/>
         </p:blipFill>
         <p:spPr>
@@ -42427,7 +42518,7 @@
           <p:nvPr/>
         </p:nvPicPr>
         <p:blipFill>
-          <a:blip xmlns:r="http://schemas.openxmlformats.org/officeDocument/2006/relationships" xmlns:a="http://schemas.openxmlformats.org/drawingml/2006/main" r:embed="Rdd307b45b41c40b5"/>
+          <a:blip xmlns:r="http://schemas.openxmlformats.org/officeDocument/2006/relationships" xmlns:a="http://schemas.openxmlformats.org/drawingml/2006/main" r:embed="R14e3c570ac2a4e96"/>
           <a:stretch xmlns:a="http://schemas.openxmlformats.org/drawingml/2006/main"/>
         </p:blipFill>
         <p:spPr>
@@ -43332,7 +43423,7 @@
           <p:nvPr/>
         </p:nvPicPr>
         <p:blipFill>
-          <a:blip xmlns:r="http://schemas.openxmlformats.org/officeDocument/2006/relationships" xmlns:a="http://schemas.openxmlformats.org/drawingml/2006/main" r:embed="Re269ce31688244a6"/>
+          <a:blip xmlns:r="http://schemas.openxmlformats.org/officeDocument/2006/relationships" xmlns:a="http://schemas.openxmlformats.org/drawingml/2006/main" r:embed="R9ae801dbd1b947e4"/>
           <a:stretch xmlns:a="http://schemas.openxmlformats.org/drawingml/2006/main"/>
         </p:blipFill>
         <p:spPr>
@@ -43354,7 +43445,7 @@
           <p:nvPr/>
         </p:nvPicPr>
         <p:blipFill>
-          <a:blip xmlns:r="http://schemas.openxmlformats.org/officeDocument/2006/relationships" xmlns:a="http://schemas.openxmlformats.org/drawingml/2006/main" r:embed="R2c6c5ad576b24d78"/>
+          <a:blip xmlns:r="http://schemas.openxmlformats.org/officeDocument/2006/relationships" xmlns:a="http://schemas.openxmlformats.org/drawingml/2006/main" r:embed="R4e4372975ad841db"/>
           <a:stretch xmlns:a="http://schemas.openxmlformats.org/drawingml/2006/main"/>
         </p:blipFill>
         <p:spPr>
@@ -43398,10 +43489,10 @@
       </p:grpSpPr>
       <p:sp>
         <p:nvSpPr>
-          <p:cNvPr id="24" name="section-11">
-            <a:extLst xmlns:a="http://schemas.openxmlformats.org/drawingml/2006/main">
-              <a:ext uri="{FF2B5EF4-FFF2-40B4-BE49-F238E27FC236}">
-                <a16:creationId xmlns:a16="http://schemas.microsoft.com/office/drawing/2014/main" id="{272ED433-B59C-436C-9DFB-4D317B90A13F}"/>
+          <p:cNvPr id="9" name="section-4">
+            <a:extLst xmlns:a="http://schemas.openxmlformats.org/drawingml/2006/main">
+              <a:ext uri="{FF2B5EF4-FFF2-40B4-BE49-F238E27FC236}">
+                <a16:creationId xmlns:a16="http://schemas.microsoft.com/office/drawing/2014/main" id="{8AE0A271-669A-49F0-A82E-C4438BEE27D9}"/>
               </a:ext>
             </a:extLst>
           </p:cNvPr>
@@ -43457,10 +43548,10 @@
       </p:sp>
       <p:sp>
         <p:nvSpPr>
-          <p:cNvPr id="2" name="title-11">
-            <a:extLst xmlns:a="http://schemas.openxmlformats.org/drawingml/2006/main">
-              <a:ext uri="{FF2B5EF4-FFF2-40B4-BE49-F238E27FC236}">
-                <a16:creationId xmlns:a16="http://schemas.microsoft.com/office/drawing/2014/main" id="{3EC40708-7E00-432C-8ECE-907FA5705292}"/>
+          <p:cNvPr id="2" name="title-4">
+            <a:extLst xmlns:a="http://schemas.openxmlformats.org/drawingml/2006/main">
+              <a:ext uri="{FF2B5EF4-FFF2-40B4-BE49-F238E27FC236}">
+                <a16:creationId xmlns:a16="http://schemas.microsoft.com/office/drawing/2014/main" id="{50C6F92F-721A-4252-9CF8-B5C9B01C7310}"/>
               </a:ext>
             </a:extLst>
           </p:cNvPr>
@@ -43485,7 +43576,7 @@
         </p:spPr>
         <p:txBody>
           <a:bodyPr xmlns:a="http://schemas.openxmlformats.org/drawingml/2006/main" wrap="square" lIns="0" tIns="0" rIns="0" bIns="0" anchor="t">
-            <a:normAutofit fontScale="92007"/>
+            <a:normAutofit fontScale="91473"/>
           </a:bodyPr>
           <a:lstStyle xmlns:a="http://schemas.openxmlformats.org/drawingml/2006/main"/>
           <a:p xmlns:a="http://schemas.openxmlformats.org/drawingml/2006/main">
@@ -43509,7 +43600,7 @@
                 <a:ea typeface="Arial"/>
                 <a:cs typeface="Arial"/>
               </a:rPr>
-              <a:t>External prior returns reveal shared geometry—not a lead</a:t>
+              <a:t>QQQ and SPY largely reproduce TSLA's own horizon map</a:t>
             </a:r>
           </a:p>
         </p:txBody>
@@ -43519,7 +43610,7 @@
           <p:cNvPr id="3" name="">
             <a:extLst xmlns:a="http://schemas.openxmlformats.org/drawingml/2006/main">
               <a:ext uri="{FF2B5EF4-FFF2-40B4-BE49-F238E27FC236}">
-                <a16:creationId xmlns:a16="http://schemas.microsoft.com/office/drawing/2014/main" id="{D5CA0FCE-75E8-41EF-A76A-23E9E2120C6A}"/>
+                <a16:creationId xmlns:a16="http://schemas.microsoft.com/office/drawing/2014/main" id="{242399F2-4D0A-4337-B17E-DB3599DC380F}"/>
               </a:ext>
             </a:extLst>
           </p:cNvPr>
@@ -43549,10 +43640,10 @@
       </p:sp>
       <p:sp>
         <p:nvSpPr>
-          <p:cNvPr id="4" name="footer-left-11">
-            <a:extLst xmlns:a="http://schemas.openxmlformats.org/drawingml/2006/main">
-              <a:ext uri="{FF2B5EF4-FFF2-40B4-BE49-F238E27FC236}">
-                <a16:creationId xmlns:a16="http://schemas.microsoft.com/office/drawing/2014/main" id="{700DA765-80E0-4197-8700-00D867B86FA2}"/>
+          <p:cNvPr id="4" name="footer-left-4">
+            <a:extLst xmlns:a="http://schemas.openxmlformats.org/drawingml/2006/main">
+              <a:ext uri="{FF2B5EF4-FFF2-40B4-BE49-F238E27FC236}">
+                <a16:creationId xmlns:a16="http://schemas.microsoft.com/office/drawing/2014/main" id="{BF8B82CA-1E48-4669-BAD8-1FF8C09FCBFB}"/>
               </a:ext>
             </a:extLst>
           </p:cNvPr>
@@ -43608,10 +43699,10 @@
       </p:sp>
       <p:sp>
         <p:nvSpPr>
-          <p:cNvPr id="5" name="footer-number-11">
-            <a:extLst xmlns:a="http://schemas.openxmlformats.org/drawingml/2006/main">
-              <a:ext uri="{FF2B5EF4-FFF2-40B4-BE49-F238E27FC236}">
-                <a16:creationId xmlns:a16="http://schemas.microsoft.com/office/drawing/2014/main" id="{83896276-4112-4532-AF7C-776C67C58B77}"/>
+          <p:cNvPr id="5" name="footer-number-4">
+            <a:extLst xmlns:a="http://schemas.openxmlformats.org/drawingml/2006/main">
+              <a:ext uri="{FF2B5EF4-FFF2-40B4-BE49-F238E27FC236}">
+                <a16:creationId xmlns:a16="http://schemas.microsoft.com/office/drawing/2014/main" id="{05959AEC-B0A5-45F0-A65B-C94C3E5A032F}"/>
               </a:ext>
             </a:extLst>
           </p:cNvPr>
@@ -43661,6 +43752,473 @@
                 <a:cs typeface="Arial"/>
               </a:rPr>
               <a:t>53</a:t>
+            </a:r>
+          </a:p>
+        </p:txBody>
+      </p:sp>
+      <p:sp>
+        <p:nvSpPr>
+          <p:cNvPr id="6" name="">
+            <a:extLst xmlns:a="http://schemas.openxmlformats.org/drawingml/2006/main">
+              <a:ext uri="{FF2B5EF4-FFF2-40B4-BE49-F238E27FC236}">
+                <a16:creationId xmlns:a16="http://schemas.microsoft.com/office/drawing/2014/main" id="{9C8DEA29-E57D-4C8D-8538-2028FF89DA7C}"/>
+              </a:ext>
+            </a:extLst>
+          </p:cNvPr>
+          <p:cNvSpPr>
+            <a:spLocks xmlns:a="http://schemas.openxmlformats.org/drawingml/2006/main" noGrp="1"/>
+          </p:cNvSpPr>
+          <p:nvPr/>
+        </p:nvSpPr>
+        <p:spPr>
+          <a:xfrm xmlns:a="http://schemas.openxmlformats.org/drawingml/2006/main">
+            <a:off x="1000125" y="1352550"/>
+            <a:ext cx="10191750" cy="4905375"/>
+          </a:xfrm>
+          <a:prstGeom xmlns:a="http://schemas.openxmlformats.org/drawingml/2006/main" prst="rect">
+            <a:avLst/>
+          </a:prstGeom>
+          <a:solidFill xmlns:a="http://schemas.openxmlformats.org/drawingml/2006/main">
+            <a:srgbClr val="FFFFFF"/>
+          </a:solidFill>
+          <a:ln xmlns:a="http://schemas.openxmlformats.org/drawingml/2006/main" w="9525">
+            <a:solidFill>
+              <a:srgbClr val="B8BCC4"/>
+            </a:solidFill>
+            <a:prstDash val="solid"/>
+          </a:ln>
+        </p:spPr>
+      </p:sp>
+      <p:sp>
+        <p:nvSpPr>
+          <p:cNvPr id="8" name="">
+            <a:extLst xmlns:a="http://schemas.openxmlformats.org/drawingml/2006/main">
+              <a:ext uri="{FF2B5EF4-FFF2-40B4-BE49-F238E27FC236}">
+                <a16:creationId xmlns:a16="http://schemas.microsoft.com/office/drawing/2014/main" id="{4346A5F2-8CC4-4151-9BDB-346D47A3096B}"/>
+              </a:ext>
+            </a:extLst>
+          </p:cNvPr>
+          <p:cNvSpPr>
+            <a:spLocks xmlns:a="http://schemas.openxmlformats.org/drawingml/2006/main" noGrp="1"/>
+          </p:cNvSpPr>
+          <p:nvPr/>
+        </p:nvSpPr>
+        <p:spPr>
+          <a:xfrm xmlns:a="http://schemas.openxmlformats.org/drawingml/2006/main">
+            <a:off x="1143000" y="6286500"/>
+            <a:ext cx="9906000" cy="171450"/>
+          </a:xfrm>
+          <a:prstGeom xmlns:a="http://schemas.openxmlformats.org/drawingml/2006/main" prst="rect">
+            <a:avLst/>
+          </a:prstGeom>
+          <a:noFill xmlns:a="http://schemas.openxmlformats.org/drawingml/2006/main"/>
+          <a:ln xmlns:a="http://schemas.openxmlformats.org/drawingml/2006/main" w="0">
+            <a:noFill/>
+            <a:prstDash val="solid"/>
+          </a:ln>
+        </p:spPr>
+        <p:txBody>
+          <a:bodyPr xmlns:a="http://schemas.openxmlformats.org/drawingml/2006/main" wrap="square" lIns="0" tIns="0" rIns="0" bIns="0" anchor="t">
+            <a:normAutofit fontScale="93750"/>
+          </a:bodyPr>
+          <a:lstStyle xmlns:a="http://schemas.openxmlformats.org/drawingml/2006/main"/>
+          <a:p xmlns:a="http://schemas.openxmlformats.org/drawingml/2006/main">
+            <a:pPr algn="ctr">
+              <a:buNone/>
+              <a:defRPr sz="1200" b="0">
+                <a:solidFill>
+                  <a:srgbClr val="667384"/>
+                </a:solidFill>
+                <a:latin typeface="Arial"/>
+                <a:ea typeface="Arial"/>
+                <a:cs typeface="Arial"/>
+              </a:defRPr>
+            </a:pPr>
+            <a:r>
+              <a:rPr sz="1200" b="0">
+                <a:solidFill>
+                  <a:srgbClr val="667384"/>
+                </a:solidFill>
+                <a:latin typeface="Arial"/>
+                <a:ea typeface="Arial"/>
+                <a:cs typeface="Arial"/>
+              </a:rPr>
+              <a:t>Map correlation vs TSLA-own: QQQ +0.906, SPY +0.965; no external BH survivor.</a:t>
+            </a:r>
+          </a:p>
+        </p:txBody>
+      </p:sp>
+      <p:pic>
+        <p:nvPicPr>
+          <p:cNvPr id="20" name=""/>
+          <p:cNvPicPr>
+            <a:picLocks xmlns:a="http://schemas.openxmlformats.org/drawingml/2006/main" noChangeAspect="1"/>
+          </p:cNvPicPr>
+          <p:nvPr/>
+        </p:nvPicPr>
+        <p:blipFill>
+          <a:blip xmlns:r="http://schemas.openxmlformats.org/officeDocument/2006/relationships" xmlns:a="http://schemas.openxmlformats.org/drawingml/2006/main" r:embed="R0ddc4380e94a4e8a"/>
+          <a:stretch xmlns:a="http://schemas.openxmlformats.org/drawingml/2006/main"/>
+        </p:blipFill>
+        <p:spPr>
+          <a:xfrm xmlns:a="http://schemas.openxmlformats.org/drawingml/2006/main" flipH="0" flipV="0">
+            <a:off x="2942545" y="1352550"/>
+            <a:ext cx="6306911" cy="4905375"/>
+          </a:xfrm>
+          <a:prstGeom xmlns:a="http://schemas.openxmlformats.org/drawingml/2006/main" prst="rect">
+            <a:avLst/>
+          </a:prstGeom>
+        </p:spPr>
+      </p:pic>
+      <p:sp>
+        <p:nvSpPr>
+          <p:cNvPr id="11" name="">
+            <a:extLst xmlns:a="http://schemas.openxmlformats.org/drawingml/2006/main">
+              <a:ext uri="{FF2B5EF4-FFF2-40B4-BE49-F238E27FC236}">
+                <a16:creationId xmlns:a16="http://schemas.microsoft.com/office/drawing/2014/main" id="{CCA475D3-61B6-47E4-B4AF-667A5724B835}"/>
+              </a:ext>
+            </a:extLst>
+          </p:cNvPr>
+          <p:cNvSpPr>
+            <a:spLocks xmlns:a="http://schemas.openxmlformats.org/drawingml/2006/main" noGrp="1"/>
+          </p:cNvSpPr>
+          <p:nvPr/>
+        </p:nvSpPr>
+        <p:spPr>
+          <a:xfrm xmlns:a="http://schemas.openxmlformats.org/drawingml/2006/main">
+            <a:off x="1000125" y="1352550"/>
+            <a:ext cx="10191750" cy="4905375"/>
+          </a:xfrm>
+          <a:prstGeom xmlns:a="http://schemas.openxmlformats.org/drawingml/2006/main" prst="rect">
+            <a:avLst/>
+          </a:prstGeom>
+          <a:solidFill xmlns:a="http://schemas.openxmlformats.org/drawingml/2006/main">
+            <a:srgbClr val="FFFFFF"/>
+          </a:solidFill>
+          <a:ln xmlns:a="http://schemas.openxmlformats.org/drawingml/2006/main" w="9525">
+            <a:solidFill>
+              <a:srgbClr val="CDD3DA"/>
+            </a:solidFill>
+            <a:prstDash val="solid"/>
+          </a:ln>
+        </p:spPr>
+      </p:sp>
+      <p:pic>
+        <p:nvPicPr>
+          <p:cNvPr id="22" name=""/>
+          <p:cNvPicPr>
+            <a:picLocks xmlns:a="http://schemas.openxmlformats.org/drawingml/2006/main" noChangeAspect="1"/>
+          </p:cNvPicPr>
+          <p:nvPr/>
+        </p:nvPicPr>
+        <p:blipFill>
+          <a:blip xmlns:r="http://schemas.openxmlformats.org/officeDocument/2006/relationships" xmlns:a="http://schemas.openxmlformats.org/drawingml/2006/main" r:embed="R359c80643a0a4c48"/>
+          <a:stretch xmlns:a="http://schemas.openxmlformats.org/drawingml/2006/main"/>
+        </p:blipFill>
+        <p:spPr>
+          <a:xfrm xmlns:a="http://schemas.openxmlformats.org/drawingml/2006/main">
+            <a:off x="1000125" y="1581150"/>
+            <a:ext cx="10191750" cy="3838575"/>
+          </a:xfrm>
+          <a:prstGeom xmlns:a="http://schemas.openxmlformats.org/drawingml/2006/main" prst="rect">
+            <a:avLst/>
+          </a:prstGeom>
+        </p:spPr>
+      </p:pic>
+    </p:spTree>
+    <p:extLst>
+      <p:ext uri="{BB962C8B-B14F-4D97-AF65-F5344CB8AC3E}">
+        <p14:creationId xmlns:p14="http://schemas.microsoft.com/office/powerpoint/2010/main" val="400872380"/>
+      </p:ext>
+    </p:extLst>
+  </p:cSld>
+</p:sld>
+</file>
+
+<file path=ppt/slides/slide54.xml><?xml version="1.0" encoding="utf-8"?>
+<p:sld xmlns:p="http://schemas.openxmlformats.org/presentationml/2006/main">
+  <p:cSld>
+    <p:bg>
+      <p:bgPr>
+        <a:solidFill xmlns:a="http://schemas.openxmlformats.org/drawingml/2006/main">
+          <a:srgbClr val="FFFFFF"/>
+        </a:solidFill>
+      </p:bgPr>
+    </p:bg>
+    <p:spTree>
+      <p:nvGrpSpPr>
+        <p:cNvPr id="1" name=""/>
+        <p:cNvGrpSpPr/>
+        <p:nvPr/>
+      </p:nvGrpSpPr>
+      <p:grpSpPr>
+        <a:xfrm xmlns:a="http://schemas.openxmlformats.org/drawingml/2006/main"/>
+      </p:grpSpPr>
+      <p:sp>
+        <p:nvSpPr>
+          <p:cNvPr id="24" name="section-11">
+            <a:extLst xmlns:a="http://schemas.openxmlformats.org/drawingml/2006/main">
+              <a:ext uri="{FF2B5EF4-FFF2-40B4-BE49-F238E27FC236}">
+                <a16:creationId xmlns:a16="http://schemas.microsoft.com/office/drawing/2014/main" id="{272ED433-B59C-436C-9DFB-4D317B90A13F}"/>
+              </a:ext>
+            </a:extLst>
+          </p:cNvPr>
+          <p:cNvSpPr>
+            <a:spLocks xmlns:a="http://schemas.openxmlformats.org/drawingml/2006/main" noGrp="1"/>
+          </p:cNvSpPr>
+          <p:nvPr/>
+        </p:nvSpPr>
+        <p:spPr>
+          <a:xfrm xmlns:a="http://schemas.openxmlformats.org/drawingml/2006/main">
+            <a:off x="457200" y="228600"/>
+            <a:ext cx="4191000" cy="228600"/>
+          </a:xfrm>
+          <a:prstGeom xmlns:a="http://schemas.openxmlformats.org/drawingml/2006/main" prst="rect">
+            <a:avLst/>
+          </a:prstGeom>
+          <a:noFill xmlns:a="http://schemas.openxmlformats.org/drawingml/2006/main"/>
+          <a:ln xmlns:a="http://schemas.openxmlformats.org/drawingml/2006/main" w="0">
+            <a:noFill/>
+            <a:prstDash val="solid"/>
+          </a:ln>
+        </p:spPr>
+        <p:txBody>
+          <a:bodyPr xmlns:a="http://schemas.openxmlformats.org/drawingml/2006/main" wrap="square" lIns="0" tIns="0" rIns="0" bIns="0" anchor="t">
+            <a:normAutofit fontScale="100000"/>
+          </a:bodyPr>
+          <a:lstStyle xmlns:a="http://schemas.openxmlformats.org/drawingml/2006/main"/>
+          <a:p xmlns:a="http://schemas.openxmlformats.org/drawingml/2006/main">
+            <a:pPr algn="l">
+              <a:buNone/>
+              <a:defRPr sz="1200" b="1">
+                <a:solidFill>
+                  <a:srgbClr val="667384"/>
+                </a:solidFill>
+                <a:latin typeface="Arial"/>
+                <a:ea typeface="Arial"/>
+                <a:cs typeface="Arial"/>
+              </a:defRPr>
+            </a:pPr>
+            <a:r>
+              <a:rPr sz="1200" b="1">
+                <a:solidFill>
+                  <a:srgbClr val="667384"/>
+                </a:solidFill>
+                <a:latin typeface="Arial"/>
+                <a:ea typeface="Arial"/>
+                <a:cs typeface="Arial"/>
+              </a:rPr>
+              <a:t>TSLA DESCRIPTIVE MICROSCOPE</a:t>
+            </a:r>
+          </a:p>
+        </p:txBody>
+      </p:sp>
+      <p:sp>
+        <p:nvSpPr>
+          <p:cNvPr id="2" name="title-11">
+            <a:extLst xmlns:a="http://schemas.openxmlformats.org/drawingml/2006/main">
+              <a:ext uri="{FF2B5EF4-FFF2-40B4-BE49-F238E27FC236}">
+                <a16:creationId xmlns:a16="http://schemas.microsoft.com/office/drawing/2014/main" id="{3EC40708-7E00-432C-8ECE-907FA5705292}"/>
+              </a:ext>
+            </a:extLst>
+          </p:cNvPr>
+          <p:cNvSpPr>
+            <a:spLocks xmlns:a="http://schemas.openxmlformats.org/drawingml/2006/main" noGrp="1"/>
+          </p:cNvSpPr>
+          <p:nvPr/>
+        </p:nvSpPr>
+        <p:spPr>
+          <a:xfrm xmlns:a="http://schemas.openxmlformats.org/drawingml/2006/main">
+            <a:off x="457200" y="533400"/>
+            <a:ext cx="11277600" cy="628650"/>
+          </a:xfrm>
+          <a:prstGeom xmlns:a="http://schemas.openxmlformats.org/drawingml/2006/main" prst="rect">
+            <a:avLst/>
+          </a:prstGeom>
+          <a:noFill xmlns:a="http://schemas.openxmlformats.org/drawingml/2006/main"/>
+          <a:ln xmlns:a="http://schemas.openxmlformats.org/drawingml/2006/main" w="0">
+            <a:noFill/>
+            <a:prstDash val="solid"/>
+          </a:ln>
+        </p:spPr>
+        <p:txBody>
+          <a:bodyPr xmlns:a="http://schemas.openxmlformats.org/drawingml/2006/main" wrap="square" lIns="0" tIns="0" rIns="0" bIns="0" anchor="t">
+            <a:normAutofit fontScale="92007"/>
+          </a:bodyPr>
+          <a:lstStyle xmlns:a="http://schemas.openxmlformats.org/drawingml/2006/main"/>
+          <a:p xmlns:a="http://schemas.openxmlformats.org/drawingml/2006/main">
+            <a:pPr algn="l">
+              <a:buNone/>
+              <a:defRPr sz="3525" b="1">
+                <a:solidFill>
+                  <a:srgbClr val="000000"/>
+                </a:solidFill>
+                <a:latin typeface="Arial"/>
+                <a:ea typeface="Arial"/>
+                <a:cs typeface="Arial"/>
+              </a:defRPr>
+            </a:pPr>
+            <a:r>
+              <a:rPr sz="3525" b="1">
+                <a:solidFill>
+                  <a:srgbClr val="000000"/>
+                </a:solidFill>
+                <a:latin typeface="Arial"/>
+                <a:ea typeface="Arial"/>
+                <a:cs typeface="Arial"/>
+              </a:rPr>
+              <a:t>External prior returns reveal shared geometry—not a lead</a:t>
+            </a:r>
+          </a:p>
+        </p:txBody>
+      </p:sp>
+      <p:sp>
+        <p:nvSpPr>
+          <p:cNvPr id="3" name="">
+            <a:extLst xmlns:a="http://schemas.openxmlformats.org/drawingml/2006/main">
+              <a:ext uri="{FF2B5EF4-FFF2-40B4-BE49-F238E27FC236}">
+                <a16:creationId xmlns:a16="http://schemas.microsoft.com/office/drawing/2014/main" id="{D5CA0FCE-75E8-41EF-A76A-23E9E2120C6A}"/>
+              </a:ext>
+            </a:extLst>
+          </p:cNvPr>
+          <p:cNvSpPr>
+            <a:spLocks xmlns:a="http://schemas.openxmlformats.org/drawingml/2006/main" noGrp="1"/>
+          </p:cNvSpPr>
+          <p:nvPr/>
+        </p:nvSpPr>
+        <p:spPr>
+          <a:xfrm xmlns:a="http://schemas.openxmlformats.org/drawingml/2006/main">
+            <a:off x="457200" y="1200150"/>
+            <a:ext cx="11277600" cy="19050"/>
+          </a:xfrm>
+          <a:prstGeom xmlns:a="http://schemas.openxmlformats.org/drawingml/2006/main" prst="rect">
+            <a:avLst/>
+          </a:prstGeom>
+          <a:solidFill xmlns:a="http://schemas.openxmlformats.org/drawingml/2006/main">
+            <a:srgbClr val="B8BCC4"/>
+          </a:solidFill>
+          <a:ln xmlns:a="http://schemas.openxmlformats.org/drawingml/2006/main" w="0">
+            <a:solidFill>
+              <a:srgbClr val="B8BCC4"/>
+            </a:solidFill>
+            <a:prstDash val="solid"/>
+          </a:ln>
+        </p:spPr>
+      </p:sp>
+      <p:sp>
+        <p:nvSpPr>
+          <p:cNvPr id="4" name="footer-left-11">
+            <a:extLst xmlns:a="http://schemas.openxmlformats.org/drawingml/2006/main">
+              <a:ext uri="{FF2B5EF4-FFF2-40B4-BE49-F238E27FC236}">
+                <a16:creationId xmlns:a16="http://schemas.microsoft.com/office/drawing/2014/main" id="{700DA765-80E0-4197-8700-00D867B86FA2}"/>
+              </a:ext>
+            </a:extLst>
+          </p:cNvPr>
+          <p:cNvSpPr>
+            <a:spLocks xmlns:a="http://schemas.openxmlformats.org/drawingml/2006/main" noGrp="1"/>
+          </p:cNvSpPr>
+          <p:nvPr/>
+        </p:nvSpPr>
+        <p:spPr>
+          <a:xfrm xmlns:a="http://schemas.openxmlformats.org/drawingml/2006/main">
+            <a:off x="457200" y="6515100"/>
+            <a:ext cx="3429000" cy="171450"/>
+          </a:xfrm>
+          <a:prstGeom xmlns:a="http://schemas.openxmlformats.org/drawingml/2006/main" prst="rect">
+            <a:avLst/>
+          </a:prstGeom>
+          <a:noFill xmlns:a="http://schemas.openxmlformats.org/drawingml/2006/main"/>
+          <a:ln xmlns:a="http://schemas.openxmlformats.org/drawingml/2006/main" w="0">
+            <a:noFill/>
+            <a:prstDash val="solid"/>
+          </a:ln>
+        </p:spPr>
+        <p:txBody>
+          <a:bodyPr xmlns:a="http://schemas.openxmlformats.org/drawingml/2006/main" wrap="square" lIns="0" tIns="0" rIns="0" bIns="0" anchor="t">
+            <a:normAutofit fontScale="100000"/>
+          </a:bodyPr>
+          <a:lstStyle xmlns:a="http://schemas.openxmlformats.org/drawingml/2006/main"/>
+          <a:p xmlns:a="http://schemas.openxmlformats.org/drawingml/2006/main">
+            <a:pPr algn="l">
+              <a:buNone/>
+              <a:defRPr sz="1050" b="0">
+                <a:solidFill>
+                  <a:srgbClr val="667384"/>
+                </a:solidFill>
+                <a:latin typeface="Arial"/>
+                <a:ea typeface="Arial"/>
+                <a:cs typeface="Arial"/>
+              </a:defRPr>
+            </a:pPr>
+            <a:r>
+              <a:rPr sz="1050" b="0">
+                <a:solidFill>
+                  <a:srgbClr val="667384"/>
+                </a:solidFill>
+                <a:latin typeface="Arial"/>
+                <a:ea typeface="Arial"/>
+                <a:cs typeface="Arial"/>
+              </a:rPr>
+              <a:t>Adjusted daily TSLA | 2018-2023</a:t>
+            </a:r>
+          </a:p>
+        </p:txBody>
+      </p:sp>
+      <p:sp>
+        <p:nvSpPr>
+          <p:cNvPr id="5" name="footer-number-11">
+            <a:extLst xmlns:a="http://schemas.openxmlformats.org/drawingml/2006/main">
+              <a:ext uri="{FF2B5EF4-FFF2-40B4-BE49-F238E27FC236}">
+                <a16:creationId xmlns:a16="http://schemas.microsoft.com/office/drawing/2014/main" id="{83896276-4112-4532-AF7C-776C67C58B77}"/>
+              </a:ext>
+            </a:extLst>
+          </p:cNvPr>
+          <p:cNvSpPr>
+            <a:spLocks xmlns:a="http://schemas.openxmlformats.org/drawingml/2006/main" noGrp="1"/>
+          </p:cNvSpPr>
+          <p:nvPr/>
+        </p:nvSpPr>
+        <p:spPr>
+          <a:xfrm xmlns:a="http://schemas.openxmlformats.org/drawingml/2006/main">
+            <a:off x="11239500" y="6496050"/>
+            <a:ext cx="495300" cy="190500"/>
+          </a:xfrm>
+          <a:prstGeom xmlns:a="http://schemas.openxmlformats.org/drawingml/2006/main" prst="rect">
+            <a:avLst/>
+          </a:prstGeom>
+          <a:noFill xmlns:a="http://schemas.openxmlformats.org/drawingml/2006/main"/>
+          <a:ln xmlns:a="http://schemas.openxmlformats.org/drawingml/2006/main" w="0">
+            <a:noFill/>
+            <a:prstDash val="solid"/>
+          </a:ln>
+        </p:spPr>
+        <p:txBody>
+          <a:bodyPr xmlns:a="http://schemas.openxmlformats.org/drawingml/2006/main" wrap="square" lIns="0" tIns="0" rIns="0" bIns="0" anchor="t">
+            <a:normAutofit fontScale="100000"/>
+          </a:bodyPr>
+          <a:lstStyle xmlns:a="http://schemas.openxmlformats.org/drawingml/2006/main"/>
+          <a:p xmlns:a="http://schemas.openxmlformats.org/drawingml/2006/main">
+            <a:pPr algn="r">
+              <a:buNone/>
+              <a:defRPr sz="1050" b="0">
+                <a:solidFill>
+                  <a:srgbClr val="667384"/>
+                </a:solidFill>
+                <a:latin typeface="Arial"/>
+                <a:ea typeface="Arial"/>
+                <a:cs typeface="Arial"/>
+              </a:defRPr>
+            </a:pPr>
+            <a:r>
+              <a:rPr sz="1050" b="0">
+                <a:solidFill>
+                  <a:srgbClr val="667384"/>
+                </a:solidFill>
+                <a:latin typeface="Arial"/>
+                <a:ea typeface="Arial"/>
+                <a:cs typeface="Arial"/>
+              </a:rPr>
+              <a:t>54</a:t>
             </a:r>
           </a:p>
         </p:txBody>
@@ -45266,7 +45824,7 @@
           <p:nvPr/>
         </p:nvPicPr>
         <p:blipFill>
-          <a:blip xmlns:r="http://schemas.openxmlformats.org/officeDocument/2006/relationships" xmlns:a="http://schemas.openxmlformats.org/drawingml/2006/main" r:embed="R92c65cdd62d64b68"/>
+          <a:blip xmlns:r="http://schemas.openxmlformats.org/officeDocument/2006/relationships" xmlns:a="http://schemas.openxmlformats.org/drawingml/2006/main" r:embed="R2d8da2da6cde4799"/>
           <a:stretch xmlns:a="http://schemas.openxmlformats.org/drawingml/2006/main"/>
         </p:blipFill>
         <p:spPr>
@@ -46171,7 +46729,7 @@
           <p:nvPr/>
         </p:nvPicPr>
         <p:blipFill>
-          <a:blip xmlns:r="http://schemas.openxmlformats.org/officeDocument/2006/relationships" xmlns:a="http://schemas.openxmlformats.org/drawingml/2006/main" r:embed="Rf0f08754e4bc4009"/>
+          <a:blip xmlns:r="http://schemas.openxmlformats.org/officeDocument/2006/relationships" xmlns:a="http://schemas.openxmlformats.org/drawingml/2006/main" r:embed="R0ce103d7a77a427b"/>
           <a:stretch xmlns:a="http://schemas.openxmlformats.org/drawingml/2006/main"/>
         </p:blipFill>
         <p:spPr>
@@ -46975,7 +47533,7 @@
           <p:nvPr/>
         </p:nvPicPr>
         <p:blipFill>
-          <a:blip xmlns:r="http://schemas.openxmlformats.org/officeDocument/2006/relationships" xmlns:a="http://schemas.openxmlformats.org/drawingml/2006/main" r:embed="R9cf19edbd4864893"/>
+          <a:blip xmlns:r="http://schemas.openxmlformats.org/officeDocument/2006/relationships" xmlns:a="http://schemas.openxmlformats.org/drawingml/2006/main" r:embed="R1be092d3fe8043ff"/>
           <a:stretch xmlns:a="http://schemas.openxmlformats.org/drawingml/2006/main"/>
         </p:blipFill>
         <p:spPr>

</xml_diff>